<commit_message>
working on first EA result analysis
</commit_message>
<xml_diff>
--- a/scicom/skeleton_presentation.pptx
+++ b/scicom/skeleton_presentation.pptx
@@ -116,6 +116,11 @@
       </a:defRPr>
     </a:lvl9pPr>
   </p:defaultTextStyle>
+  <p:extLst>
+    <p:ext uri="{EFAFB233-063F-42B5-8137-9DF3F51BA10A}">
+      <p15:sldGuideLst xmlns:p15="http://schemas.microsoft.com/office/powerpoint/2012/main"/>
+    </p:ext>
+  </p:extLst>
 </p:presentation>
 </file>
 
@@ -266,7 +271,7 @@
           <a:p>
             <a:fld id="{42A0533D-F09C-441E-936C-5A7061C2C138}" type="datetimeFigureOut">
               <a:rPr lang="de-DE" smtClean="0"/>
-              <a:t>06.05.2026</a:t>
+              <a:t>11.05.2026</a:t>
             </a:fld>
             <a:endParaRPr lang="de-DE"/>
           </a:p>
@@ -464,7 +469,7 @@
           <a:p>
             <a:fld id="{42A0533D-F09C-441E-936C-5A7061C2C138}" type="datetimeFigureOut">
               <a:rPr lang="de-DE" smtClean="0"/>
-              <a:t>06.05.2026</a:t>
+              <a:t>11.05.2026</a:t>
             </a:fld>
             <a:endParaRPr lang="de-DE"/>
           </a:p>
@@ -672,7 +677,7 @@
           <a:p>
             <a:fld id="{42A0533D-F09C-441E-936C-5A7061C2C138}" type="datetimeFigureOut">
               <a:rPr lang="de-DE" smtClean="0"/>
-              <a:t>06.05.2026</a:t>
+              <a:t>11.05.2026</a:t>
             </a:fld>
             <a:endParaRPr lang="de-DE"/>
           </a:p>
@@ -870,7 +875,7 @@
           <a:p>
             <a:fld id="{42A0533D-F09C-441E-936C-5A7061C2C138}" type="datetimeFigureOut">
               <a:rPr lang="de-DE" smtClean="0"/>
-              <a:t>06.05.2026</a:t>
+              <a:t>11.05.2026</a:t>
             </a:fld>
             <a:endParaRPr lang="de-DE"/>
           </a:p>
@@ -1145,7 +1150,7 @@
           <a:p>
             <a:fld id="{42A0533D-F09C-441E-936C-5A7061C2C138}" type="datetimeFigureOut">
               <a:rPr lang="de-DE" smtClean="0"/>
-              <a:t>06.05.2026</a:t>
+              <a:t>11.05.2026</a:t>
             </a:fld>
             <a:endParaRPr lang="de-DE"/>
           </a:p>
@@ -1410,7 +1415,7 @@
           <a:p>
             <a:fld id="{42A0533D-F09C-441E-936C-5A7061C2C138}" type="datetimeFigureOut">
               <a:rPr lang="de-DE" smtClean="0"/>
-              <a:t>06.05.2026</a:t>
+              <a:t>11.05.2026</a:t>
             </a:fld>
             <a:endParaRPr lang="de-DE"/>
           </a:p>
@@ -1822,7 +1827,7 @@
           <a:p>
             <a:fld id="{42A0533D-F09C-441E-936C-5A7061C2C138}" type="datetimeFigureOut">
               <a:rPr lang="de-DE" smtClean="0"/>
-              <a:t>06.05.2026</a:t>
+              <a:t>11.05.2026</a:t>
             </a:fld>
             <a:endParaRPr lang="de-DE"/>
           </a:p>
@@ -1963,7 +1968,7 @@
           <a:p>
             <a:fld id="{42A0533D-F09C-441E-936C-5A7061C2C138}" type="datetimeFigureOut">
               <a:rPr lang="de-DE" smtClean="0"/>
-              <a:t>06.05.2026</a:t>
+              <a:t>11.05.2026</a:t>
             </a:fld>
             <a:endParaRPr lang="de-DE"/>
           </a:p>
@@ -2076,7 +2081,7 @@
           <a:p>
             <a:fld id="{42A0533D-F09C-441E-936C-5A7061C2C138}" type="datetimeFigureOut">
               <a:rPr lang="de-DE" smtClean="0"/>
-              <a:t>06.05.2026</a:t>
+              <a:t>11.05.2026</a:t>
             </a:fld>
             <a:endParaRPr lang="de-DE"/>
           </a:p>
@@ -2387,7 +2392,7 @@
           <a:p>
             <a:fld id="{42A0533D-F09C-441E-936C-5A7061C2C138}" type="datetimeFigureOut">
               <a:rPr lang="de-DE" smtClean="0"/>
-              <a:t>06.05.2026</a:t>
+              <a:t>11.05.2026</a:t>
             </a:fld>
             <a:endParaRPr lang="de-DE"/>
           </a:p>
@@ -2675,7 +2680,7 @@
           <a:p>
             <a:fld id="{42A0533D-F09C-441E-936C-5A7061C2C138}" type="datetimeFigureOut">
               <a:rPr lang="de-DE" smtClean="0"/>
-              <a:t>06.05.2026</a:t>
+              <a:t>11.05.2026</a:t>
             </a:fld>
             <a:endParaRPr lang="de-DE"/>
           </a:p>
@@ -2916,7 +2921,7 @@
           <a:p>
             <a:fld id="{42A0533D-F09C-441E-936C-5A7061C2C138}" type="datetimeFigureOut">
               <a:rPr lang="de-DE" smtClean="0"/>
-              <a:t>06.05.2026</a:t>
+              <a:t>11.05.2026</a:t>
             </a:fld>
             <a:endParaRPr lang="de-DE"/>
           </a:p>
@@ -4893,7 +4898,7 @@
         </p:nvSpPr>
         <p:spPr>
           <a:xfrm>
-            <a:off x="2857500" y="2628900"/>
+            <a:off x="955426" y="1325201"/>
             <a:ext cx="5140574" cy="369332"/>
           </a:xfrm>
           <a:prstGeom prst="rect">
@@ -4978,6 +4983,109 @@
           </a:p>
         </p:txBody>
       </p:sp>
+      <p:sp>
+        <p:nvSpPr>
+          <p:cNvPr id="3" name="Textfeld 2">
+            <a:extLst>
+              <a:ext uri="{FF2B5EF4-FFF2-40B4-BE49-F238E27FC236}">
+                <a16:creationId xmlns:a16="http://schemas.microsoft.com/office/drawing/2014/main" id="{4967ADF7-314F-D965-009A-9301567912C0}"/>
+              </a:ext>
+            </a:extLst>
+          </p:cNvPr>
+          <p:cNvSpPr txBox="1"/>
+          <p:nvPr/>
+        </p:nvSpPr>
+        <p:spPr>
+          <a:xfrm>
+            <a:off x="9739265" y="6460577"/>
+            <a:ext cx="2292790" cy="261610"/>
+          </a:xfrm>
+          <a:prstGeom prst="rect">
+            <a:avLst/>
+          </a:prstGeom>
+          <a:noFill/>
+        </p:spPr>
+        <p:txBody>
+          <a:bodyPr wrap="square">
+            <a:spAutoFit/>
+          </a:bodyPr>
+          <a:lstStyle/>
+          <a:p>
+            <a:r>
+              <a:rPr lang="de-DE" sz="1050" dirty="0" err="1"/>
+              <a:t>Photo</a:t>
+            </a:r>
+            <a:r>
+              <a:rPr lang="de-DE" sz="1050" dirty="0"/>
+              <a:t> </a:t>
+            </a:r>
+            <a:r>
+              <a:rPr lang="de-DE" sz="1050" dirty="0" err="1"/>
+              <a:t>by</a:t>
+            </a:r>
+            <a:r>
+              <a:rPr lang="de-DE" sz="1050" dirty="0"/>
+              <a:t> </a:t>
+            </a:r>
+            <a:r>
+              <a:rPr lang="de-DE" sz="1050" dirty="0">
+                <a:hlinkClick r:id="rId2"/>
+              </a:rPr>
+              <a:t>Ronan Furuta</a:t>
+            </a:r>
+            <a:r>
+              <a:rPr lang="de-DE" sz="1050" dirty="0"/>
+              <a:t> on </a:t>
+            </a:r>
+            <a:r>
+              <a:rPr lang="de-DE" sz="1050" dirty="0" err="1">
+                <a:hlinkClick r:id="rId3"/>
+              </a:rPr>
+              <a:t>Unsplash</a:t>
+            </a:r>
+            <a:r>
+              <a:rPr lang="de-DE" sz="1050" dirty="0"/>
+              <a:t> </a:t>
+            </a:r>
+          </a:p>
+        </p:txBody>
+      </p:sp>
+      <p:pic>
+        <p:nvPicPr>
+          <p:cNvPr id="6" name="Grafik 5">
+            <a:extLst>
+              <a:ext uri="{FF2B5EF4-FFF2-40B4-BE49-F238E27FC236}">
+                <a16:creationId xmlns:a16="http://schemas.microsoft.com/office/drawing/2014/main" id="{7473C84E-445B-BACD-6861-7F15FC414262}"/>
+              </a:ext>
+            </a:extLst>
+          </p:cNvPr>
+          <p:cNvPicPr>
+            <a:picLocks noChangeAspect="1"/>
+          </p:cNvPicPr>
+          <p:nvPr/>
+        </p:nvPicPr>
+        <p:blipFill>
+          <a:blip r:embed="rId4">
+            <a:extLst>
+              <a:ext uri="{28A0092B-C50C-407E-A947-70E740481C1C}">
+                <a14:useLocalDpi xmlns:a14="http://schemas.microsoft.com/office/drawing/2010/main" val="0"/>
+              </a:ext>
+            </a:extLst>
+          </a:blip>
+          <a:stretch>
+            <a:fillRect/>
+          </a:stretch>
+        </p:blipFill>
+        <p:spPr>
+          <a:xfrm>
+            <a:off x="7043596" y="962334"/>
+            <a:ext cx="3530851" cy="4707801"/>
+          </a:xfrm>
+          <a:prstGeom prst="rect">
+            <a:avLst/>
+          </a:prstGeom>
+        </p:spPr>
+      </p:pic>
     </p:spTree>
     <p:extLst>
       <p:ext uri="{BB962C8B-B14F-4D97-AF65-F5344CB8AC3E}">
@@ -5022,8 +5130,8 @@
         </p:nvSpPr>
         <p:spPr>
           <a:xfrm>
-            <a:off x="3124200" y="2393950"/>
-            <a:ext cx="5024452" cy="923330"/>
+            <a:off x="1071548" y="900129"/>
+            <a:ext cx="2952347" cy="369332"/>
           </a:xfrm>
           <a:prstGeom prst="rect">
             <a:avLst/>
@@ -5064,63 +5172,88 @@
               <a:rPr lang="de-DE" dirty="0"/>
               <a:t>:</a:t>
             </a:r>
-            <a:br>
-              <a:rPr lang="de-DE" dirty="0"/>
-            </a:br>
-            <a:br>
-              <a:rPr lang="de-DE" dirty="0"/>
-            </a:br>
-            <a:r>
-              <a:rPr lang="de-DE" dirty="0"/>
+          </a:p>
+        </p:txBody>
+      </p:sp>
+      <p:sp>
+        <p:nvSpPr>
+          <p:cNvPr id="4" name="Textfeld 3">
+            <a:extLst>
+              <a:ext uri="{FF2B5EF4-FFF2-40B4-BE49-F238E27FC236}">
+                <a16:creationId xmlns:a16="http://schemas.microsoft.com/office/drawing/2014/main" id="{3C3071AE-6EDF-A2C9-A890-5A1575E675A5}"/>
+              </a:ext>
+            </a:extLst>
+          </p:cNvPr>
+          <p:cNvSpPr txBox="1"/>
+          <p:nvPr/>
+        </p:nvSpPr>
+        <p:spPr>
+          <a:xfrm>
+            <a:off x="1301435" y="2802977"/>
+            <a:ext cx="9390708" cy="523220"/>
+          </a:xfrm>
+          <a:prstGeom prst="rect">
+            <a:avLst/>
+          </a:prstGeom>
+          <a:noFill/>
+        </p:spPr>
+        <p:txBody>
+          <a:bodyPr wrap="square">
+            <a:spAutoFit/>
+          </a:bodyPr>
+          <a:lstStyle/>
+          <a:p>
+            <a:r>
+              <a:rPr lang="de-DE" sz="2800" b="1" dirty="0"/>
               <a:t>The </a:t>
             </a:r>
             <a:r>
-              <a:rPr lang="de-DE" dirty="0" err="1"/>
+              <a:rPr lang="de-DE" sz="2800" b="1" dirty="0" err="1"/>
               <a:t>weather</a:t>
             </a:r>
             <a:r>
-              <a:rPr lang="de-DE" dirty="0"/>
+              <a:rPr lang="de-DE" sz="2800" b="1" dirty="0"/>
               <a:t> outside </a:t>
             </a:r>
             <a:r>
-              <a:rPr lang="de-DE" dirty="0" err="1"/>
+              <a:rPr lang="de-DE" sz="2800" b="1" dirty="0" err="1"/>
               <a:t>is</a:t>
             </a:r>
             <a:r>
-              <a:rPr lang="de-DE" dirty="0"/>
+              <a:rPr lang="de-DE" sz="2800" b="1" dirty="0"/>
               <a:t> nice </a:t>
             </a:r>
             <a:r>
-              <a:rPr lang="de-DE" dirty="0" err="1"/>
+              <a:rPr lang="de-DE" sz="2800" b="1" dirty="0" err="1"/>
               <a:t>today</a:t>
             </a:r>
             <a:r>
-              <a:rPr lang="de-DE" dirty="0"/>
+              <a:rPr lang="de-DE" sz="2800" b="1" dirty="0"/>
               <a:t>, </a:t>
             </a:r>
             <a:r>
-              <a:rPr lang="de-DE" dirty="0" err="1"/>
+              <a:rPr lang="de-DE" sz="2800" b="1" dirty="0" err="1"/>
               <a:t>the</a:t>
             </a:r>
             <a:r>
-              <a:rPr lang="de-DE" dirty="0"/>
-              <a:t> </a:t>
-            </a:r>
-            <a:r>
-              <a:rPr lang="de-DE" dirty="0" err="1"/>
+              <a:rPr lang="de-DE" sz="2800" b="1" dirty="0"/>
+              <a:t> </a:t>
+            </a:r>
+            <a:r>
+              <a:rPr lang="de-DE" sz="2800" b="1" dirty="0" err="1"/>
               <a:t>sky</a:t>
             </a:r>
             <a:r>
-              <a:rPr lang="de-DE" dirty="0"/>
-              <a:t> </a:t>
-            </a:r>
-            <a:r>
-              <a:rPr lang="de-DE" dirty="0" err="1"/>
+              <a:rPr lang="de-DE" sz="2800" b="1" dirty="0"/>
+              <a:t> </a:t>
+            </a:r>
+            <a:r>
+              <a:rPr lang="de-DE" sz="2800" b="1" dirty="0" err="1"/>
               <a:t>is</a:t>
             </a:r>
             <a:r>
-              <a:rPr lang="de-DE" dirty="0"/>
-              <a:t> ____.</a:t>
+              <a:rPr lang="de-DE" sz="2800" b="1" dirty="0"/>
+              <a:t> ________.</a:t>
             </a:r>
           </a:p>
         </p:txBody>
@@ -5169,8 +5302,8 @@
         </p:nvSpPr>
         <p:spPr>
           <a:xfrm>
-            <a:off x="3282950" y="2901950"/>
-            <a:ext cx="5806782" cy="369332"/>
+            <a:off x="548803" y="756279"/>
+            <a:ext cx="4553682" cy="369332"/>
           </a:xfrm>
           <a:prstGeom prst="rect">
             <a:avLst/>
@@ -5185,15 +5318,7 @@
           <a:p>
             <a:r>
               <a:rPr lang="de-DE" dirty="0"/>
-              <a:t>3 – Think </a:t>
-            </a:r>
-            <a:r>
-              <a:rPr lang="de-DE" dirty="0" err="1"/>
-              <a:t>of</a:t>
-            </a:r>
-            <a:r>
-              <a:rPr lang="de-DE" dirty="0"/>
-              <a:t> </a:t>
+              <a:t>3 – Find </a:t>
             </a:r>
             <a:r>
               <a:rPr lang="de-DE" dirty="0" err="1"/>
@@ -5205,68 +5330,83 @@
             </a:r>
             <a:r>
               <a:rPr lang="de-DE" dirty="0" err="1"/>
-              <a:t>directions</a:t>
-            </a:r>
-            <a:r>
-              <a:rPr lang="de-DE" dirty="0"/>
-              <a:t> </a:t>
-            </a:r>
-            <a:r>
-              <a:rPr lang="de-DE" dirty="0" err="1"/>
-              <a:t>you</a:t>
-            </a:r>
-            <a:r>
-              <a:rPr lang="de-DE" dirty="0"/>
-              <a:t> </a:t>
-            </a:r>
-            <a:r>
-              <a:rPr lang="de-DE" dirty="0" err="1"/>
-              <a:t>took</a:t>
-            </a:r>
-            <a:r>
-              <a:rPr lang="de-DE" dirty="0"/>
-              <a:t> </a:t>
-            </a:r>
-            <a:r>
-              <a:rPr lang="de-DE" dirty="0" err="1"/>
-              <a:t>from</a:t>
-            </a:r>
-            <a:r>
-              <a:rPr lang="de-DE" dirty="0"/>
-              <a:t> </a:t>
-            </a:r>
-            <a:r>
-              <a:rPr lang="de-DE" dirty="0" err="1"/>
-              <a:t>home</a:t>
-            </a:r>
-            <a:r>
-              <a:rPr lang="de-DE" dirty="0"/>
-              <a:t> </a:t>
-            </a:r>
-            <a:r>
-              <a:rPr lang="de-DE" dirty="0" err="1"/>
-              <a:t>to</a:t>
-            </a:r>
-            <a:r>
-              <a:rPr lang="de-DE" dirty="0"/>
-              <a:t> </a:t>
-            </a:r>
-            <a:r>
-              <a:rPr lang="de-DE" dirty="0" err="1"/>
-              <a:t>get</a:t>
-            </a:r>
-            <a:r>
-              <a:rPr lang="de-DE" dirty="0"/>
-              <a:t> </a:t>
-            </a:r>
-            <a:r>
-              <a:rPr lang="de-DE" dirty="0" err="1"/>
-              <a:t>here</a:t>
-            </a:r>
-            <a:endParaRPr lang="de-DE" dirty="0"/>
-          </a:p>
-        </p:txBody>
-      </p:sp>
+              <a:t>shortest</a:t>
+            </a:r>
+            <a:r>
+              <a:rPr lang="de-DE" dirty="0"/>
+              <a:t> </a:t>
+            </a:r>
+            <a:r>
+              <a:rPr lang="de-DE" dirty="0" err="1"/>
+              <a:t>path</a:t>
+            </a:r>
+            <a:r>
+              <a:rPr lang="de-DE" dirty="0"/>
+              <a:t> </a:t>
+            </a:r>
+            <a:r>
+              <a:rPr lang="de-DE" dirty="0" err="1"/>
+              <a:t>through</a:t>
+            </a:r>
+            <a:r>
+              <a:rPr lang="de-DE" dirty="0"/>
+              <a:t> </a:t>
+            </a:r>
+            <a:r>
+              <a:rPr lang="de-DE" dirty="0" err="1"/>
+              <a:t>this</a:t>
+            </a:r>
+            <a:r>
+              <a:rPr lang="de-DE" dirty="0"/>
+              <a:t> </a:t>
+            </a:r>
+            <a:r>
+              <a:rPr lang="de-DE" dirty="0" err="1"/>
+              <a:t>maze</a:t>
+            </a:r>
+            <a:r>
+              <a:rPr lang="de-DE" dirty="0"/>
+              <a:t>.</a:t>
+            </a:r>
+          </a:p>
+        </p:txBody>
+      </p:sp>
+      <p:pic>
+        <p:nvPicPr>
+          <p:cNvPr id="15" name="Grafik 14">
+            <a:extLst>
+              <a:ext uri="{FF2B5EF4-FFF2-40B4-BE49-F238E27FC236}">
+                <a16:creationId xmlns:a16="http://schemas.microsoft.com/office/drawing/2014/main" id="{9503983C-3D62-6428-B7F2-2A9BE9ADFD7D}"/>
+              </a:ext>
+            </a:extLst>
+          </p:cNvPr>
+          <p:cNvPicPr>
+            <a:picLocks noChangeAspect="1"/>
+          </p:cNvPicPr>
+          <p:nvPr/>
+        </p:nvPicPr>
+        <p:blipFill>
+          <a:blip r:embed="rId2">
+            <a:extLst>
+              <a:ext uri="{28A0092B-C50C-407E-A947-70E740481C1C}">
+                <a14:useLocalDpi xmlns:a14="http://schemas.microsoft.com/office/drawing/2010/main" val="0"/>
+              </a:ext>
+            </a:extLst>
+          </a:blip>
+          <a:stretch>
+            <a:fillRect/>
+          </a:stretch>
+        </p:blipFill>
+        <p:spPr>
+          <a:xfrm>
+            <a:off x="3763753" y="1437227"/>
+            <a:ext cx="4664494" cy="4664494"/>
+          </a:xfrm>
+          <a:prstGeom prst="rect">
+            <a:avLst/>
+          </a:prstGeom>
+        </p:spPr>
+      </p:pic>
     </p:spTree>
     <p:extLst>
       <p:ext uri="{BB962C8B-B14F-4D97-AF65-F5344CB8AC3E}">
@@ -5311,8 +5451,8 @@
         </p:nvSpPr>
         <p:spPr>
           <a:xfrm>
-            <a:off x="3581465" y="558800"/>
-            <a:ext cx="5029069" cy="1200329"/>
+            <a:off x="3644271" y="248257"/>
+            <a:ext cx="5317033" cy="1200329"/>
           </a:xfrm>
           <a:prstGeom prst="rect">
             <a:avLst/>
@@ -5325,86 +5465,90 @@
           </a:bodyPr>
           <a:lstStyle/>
           <a:p>
-            <a:r>
-              <a:rPr lang="de-DE" dirty="0"/>
+            <a:pPr algn="ctr"/>
+            <a:r>
+              <a:rPr lang="de-DE" b="1" dirty="0"/>
               <a:t>Why </a:t>
             </a:r>
             <a:r>
-              <a:rPr lang="de-DE" dirty="0" err="1"/>
+              <a:rPr lang="de-DE" b="1" dirty="0" err="1"/>
               <a:t>are</a:t>
             </a:r>
             <a:r>
-              <a:rPr lang="de-DE" dirty="0"/>
-              <a:t> </a:t>
-            </a:r>
-            <a:r>
-              <a:rPr lang="de-DE" dirty="0" err="1"/>
+              <a:rPr lang="de-DE" b="1" dirty="0"/>
+              <a:t> </a:t>
+            </a:r>
+            <a:r>
+              <a:rPr lang="de-DE" b="1" dirty="0" err="1"/>
               <a:t>brains</a:t>
             </a:r>
             <a:r>
-              <a:rPr lang="de-DE" dirty="0"/>
+              <a:rPr lang="de-DE" b="1" dirty="0"/>
               <a:t> so </a:t>
             </a:r>
             <a:r>
-              <a:rPr lang="de-DE" dirty="0" err="1"/>
+              <a:rPr lang="de-DE" b="1" dirty="0" err="1"/>
               <a:t>good</a:t>
             </a:r>
             <a:r>
-              <a:rPr lang="de-DE" dirty="0"/>
+              <a:rPr lang="de-DE" b="1" dirty="0"/>
               <a:t> at flexible </a:t>
             </a:r>
             <a:r>
-              <a:rPr lang="de-DE" dirty="0" err="1"/>
+              <a:rPr lang="de-DE" b="1" dirty="0" err="1"/>
               <a:t>generalization</a:t>
             </a:r>
             <a:r>
-              <a:rPr lang="de-DE" dirty="0"/>
+              <a:rPr lang="de-DE" b="1" dirty="0"/>
               <a:t>?</a:t>
             </a:r>
           </a:p>
           <a:p>
-            <a:endParaRPr lang="de-DE" dirty="0"/>
-          </a:p>
-          <a:p>
-            <a:r>
-              <a:rPr lang="de-DE" dirty="0"/>
+            <a:pPr algn="ctr"/>
+            <a:endParaRPr lang="de-DE" b="1" dirty="0"/>
+          </a:p>
+          <a:p>
+            <a:pPr algn="ctr"/>
+            <a:r>
+              <a:rPr lang="de-DE" b="1" dirty="0"/>
               <a:t>Why </a:t>
             </a:r>
             <a:r>
-              <a:rPr lang="de-DE" dirty="0" err="1"/>
+              <a:rPr lang="de-DE" b="1" dirty="0" err="1"/>
               <a:t>can‘t</a:t>
             </a:r>
             <a:r>
-              <a:rPr lang="de-DE" dirty="0"/>
-              <a:t> </a:t>
-            </a:r>
-            <a:r>
-              <a:rPr lang="de-DE" dirty="0" err="1"/>
+              <a:rPr lang="de-DE" b="1" dirty="0"/>
+              <a:t> </a:t>
+            </a:r>
+            <a:r>
+              <a:rPr lang="de-DE" b="1" dirty="0" err="1"/>
               <a:t>we</a:t>
             </a:r>
             <a:r>
-              <a:rPr lang="de-DE" dirty="0"/>
-              <a:t> </a:t>
-            </a:r>
-            <a:r>
-              <a:rPr lang="de-DE" dirty="0" err="1"/>
+              <a:rPr lang="de-DE" b="1" dirty="0"/>
+              <a:t> </a:t>
+            </a:r>
+            <a:r>
+              <a:rPr lang="de-DE" b="1" dirty="0" err="1"/>
               <a:t>explain</a:t>
             </a:r>
             <a:r>
-              <a:rPr lang="de-DE" dirty="0"/>
-              <a:t> </a:t>
-            </a:r>
-            <a:r>
-              <a:rPr lang="de-DE" dirty="0" err="1"/>
+              <a:rPr lang="de-DE" b="1" dirty="0"/>
+              <a:t> </a:t>
+            </a:r>
+            <a:r>
+              <a:rPr lang="de-DE" b="1" dirty="0" err="1"/>
               <a:t>it</a:t>
             </a:r>
             <a:r>
-              <a:rPr lang="de-DE" dirty="0"/>
+              <a:rPr lang="de-DE" b="1" dirty="0"/>
               <a:t>?</a:t>
             </a:r>
           </a:p>
           <a:p>
-            <a:endParaRPr lang="de-DE" dirty="0"/>
+            <a:pPr algn="ctr"/>
+            <a:endParaRPr lang="de-DE" b="1" dirty="0"/>
           </a:p>
         </p:txBody>
       </p:sp>
@@ -5417,13 +5561,15 @@
               </a:ext>
             </a:extLst>
           </p:cNvPr>
-          <p:cNvCxnSpPr/>
+          <p:cNvCxnSpPr>
+            <a:cxnSpLocks/>
+          </p:cNvCxnSpPr>
           <p:nvPr/>
         </p:nvCxnSpPr>
         <p:spPr>
           <a:xfrm>
-            <a:off x="1219200" y="4425950"/>
-            <a:ext cx="9480550" cy="88900"/>
+            <a:off x="0" y="5323557"/>
+            <a:ext cx="12045950" cy="33891"/>
           </a:xfrm>
           <a:prstGeom prst="straightConnector1">
             <a:avLst/>
@@ -5461,8 +5607,8 @@
         </p:nvSpPr>
         <p:spPr>
           <a:xfrm>
-            <a:off x="1562100" y="2795369"/>
-            <a:ext cx="850900" cy="646331"/>
+            <a:off x="31745" y="1569045"/>
+            <a:ext cx="2298698" cy="1477328"/>
           </a:xfrm>
           <a:prstGeom prst="rect">
             <a:avLst/>
@@ -5477,14 +5623,41 @@
           <a:p>
             <a:r>
               <a:rPr lang="de-DE" dirty="0"/>
-              <a:t>19XX</a:t>
+              <a:t>350 BCE</a:t>
             </a:r>
             <a:br>
               <a:rPr lang="de-DE" dirty="0"/>
             </a:br>
             <a:r>
-              <a:rPr lang="de-DE" dirty="0" err="1"/>
-              <a:t>turing</a:t>
+              <a:rPr lang="de-DE" dirty="0"/>
+              <a:t>Aristotle in </a:t>
+            </a:r>
+            <a:r>
+              <a:rPr lang="de-DE" i="1" dirty="0"/>
+              <a:t>De Anima</a:t>
+            </a:r>
+            <a:br>
+              <a:rPr lang="de-DE" dirty="0"/>
+            </a:br>
+            <a:r>
+              <a:rPr lang="de-DE" dirty="0" err="1"/>
+              <a:t>substrate-independece</a:t>
+            </a:r>
+            <a:r>
+              <a:rPr lang="de-DE" dirty="0"/>
+              <a:t> </a:t>
+            </a:r>
+            <a:r>
+              <a:rPr lang="de-DE" dirty="0" err="1"/>
+              <a:t>of</a:t>
+            </a:r>
+            <a:r>
+              <a:rPr lang="de-DE" dirty="0"/>
+              <a:t> </a:t>
+            </a:r>
+            <a:r>
+              <a:rPr lang="de-DE" dirty="0" err="1"/>
+              <a:t>thought</a:t>
             </a:r>
             <a:endParaRPr lang="de-DE" dirty="0"/>
           </a:p>
@@ -5504,8 +5677,8 @@
         </p:nvSpPr>
         <p:spPr>
           <a:xfrm>
-            <a:off x="3498850" y="2808069"/>
-            <a:ext cx="1092200" cy="646331"/>
+            <a:off x="879477" y="3035828"/>
+            <a:ext cx="2298699" cy="923330"/>
           </a:xfrm>
           <a:prstGeom prst="rect">
             <a:avLst/>
@@ -5520,16 +5693,46 @@
           <a:p>
             <a:r>
               <a:rPr lang="de-DE" dirty="0"/>
-              <a:t>19XX</a:t>
-            </a:r>
-            <a:br>
-              <a:rPr lang="de-DE" dirty="0"/>
-            </a:br>
-            <a:r>
-              <a:rPr lang="de-DE" dirty="0" err="1"/>
-              <a:t>hopfield</a:t>
-            </a:r>
-            <a:endParaRPr lang="de-DE" dirty="0"/>
+              <a:t>1859 Darwin</a:t>
+            </a:r>
+          </a:p>
+          <a:p>
+            <a:r>
+              <a:rPr lang="de-DE" dirty="0"/>
+              <a:t>‚</a:t>
+            </a:r>
+            <a:r>
+              <a:rPr lang="de-DE" dirty="0" err="1"/>
+              <a:t>brains</a:t>
+            </a:r>
+            <a:r>
+              <a:rPr lang="de-DE" dirty="0"/>
+              <a:t> </a:t>
+            </a:r>
+            <a:r>
+              <a:rPr lang="de-DE" dirty="0" err="1"/>
+              <a:t>that</a:t>
+            </a:r>
+            <a:r>
+              <a:rPr lang="de-DE" dirty="0"/>
+              <a:t> </a:t>
+            </a:r>
+            <a:r>
+              <a:rPr lang="de-DE" dirty="0" err="1"/>
+              <a:t>generalize</a:t>
+            </a:r>
+            <a:r>
+              <a:rPr lang="de-DE" dirty="0"/>
+              <a:t> </a:t>
+            </a:r>
+            <a:r>
+              <a:rPr lang="de-DE" dirty="0" err="1"/>
+              <a:t>survive</a:t>
+            </a:r>
+            <a:r>
+              <a:rPr lang="de-DE" dirty="0"/>
+              <a:t>‘</a:t>
+            </a:r>
           </a:p>
         </p:txBody>
       </p:sp>
@@ -5547,8 +5750,8 @@
         </p:nvSpPr>
         <p:spPr>
           <a:xfrm>
-            <a:off x="5959475" y="2808069"/>
-            <a:ext cx="1092200" cy="646331"/>
+            <a:off x="2549524" y="2281314"/>
+            <a:ext cx="1495419" cy="923330"/>
           </a:xfrm>
           <a:prstGeom prst="rect">
             <a:avLst/>
@@ -5563,15 +5766,32 @@
           <a:p>
             <a:r>
               <a:rPr lang="de-DE" dirty="0"/>
-              <a:t>20XX</a:t>
+              <a:t>1890s Cajal</a:t>
             </a:r>
             <a:br>
               <a:rPr lang="de-DE" dirty="0"/>
             </a:br>
             <a:r>
-              <a:rPr lang="de-DE" dirty="0"/>
-              <a:t>de Beer</a:t>
-            </a:r>
+              <a:rPr lang="de-DE" dirty="0" err="1"/>
+              <a:t>Importance</a:t>
+            </a:r>
+            <a:r>
+              <a:rPr lang="de-DE" dirty="0"/>
+              <a:t> </a:t>
+            </a:r>
+            <a:r>
+              <a:rPr lang="de-DE" dirty="0" err="1"/>
+              <a:t>of</a:t>
+            </a:r>
+            <a:r>
+              <a:rPr lang="de-DE" dirty="0"/>
+              <a:t> </a:t>
+            </a:r>
+            <a:r>
+              <a:rPr lang="de-DE" dirty="0" err="1"/>
+              <a:t>plasticity</a:t>
+            </a:r>
+            <a:endParaRPr lang="de-DE" dirty="0"/>
           </a:p>
         </p:txBody>
       </p:sp>
@@ -5589,8 +5809,8 @@
         </p:nvSpPr>
         <p:spPr>
           <a:xfrm>
-            <a:off x="7988300" y="2808069"/>
-            <a:ext cx="1092200" cy="646331"/>
+            <a:off x="6056189" y="1496640"/>
+            <a:ext cx="2905119" cy="1477328"/>
           </a:xfrm>
           <a:prstGeom prst="rect">
             <a:avLst/>
@@ -5605,15 +5825,47 @@
           <a:p>
             <a:r>
               <a:rPr lang="de-DE" dirty="0"/>
-              <a:t>20XX</a:t>
+              <a:t>1943 </a:t>
+            </a:r>
+            <a:r>
+              <a:rPr lang="de-DE" dirty="0" err="1"/>
+              <a:t>Mc</a:t>
+            </a:r>
+            <a:r>
+              <a:rPr lang="de-DE" dirty="0"/>
+              <a:t> Culloch and Pitts</a:t>
             </a:r>
             <a:br>
               <a:rPr lang="de-DE" dirty="0"/>
             </a:br>
             <a:r>
               <a:rPr lang="de-DE" dirty="0"/>
-              <a:t>Bongard</a:t>
-            </a:r>
+              <a:t>immense </a:t>
+            </a:r>
+            <a:r>
+              <a:rPr lang="de-DE" dirty="0" err="1"/>
+              <a:t>computational</a:t>
+            </a:r>
+            <a:r>
+              <a:rPr lang="de-DE" dirty="0"/>
+              <a:t> power </a:t>
+            </a:r>
+            <a:r>
+              <a:rPr lang="de-DE" dirty="0" err="1"/>
+              <a:t>of</a:t>
+            </a:r>
+            <a:r>
+              <a:rPr lang="de-DE" dirty="0"/>
+              <a:t> simple neuronal </a:t>
+            </a:r>
+            <a:r>
+              <a:rPr lang="de-DE" dirty="0" err="1"/>
+              <a:t>networks</a:t>
+            </a:r>
+            <a:br>
+              <a:rPr lang="de-DE" dirty="0"/>
+            </a:br>
+            <a:endParaRPr lang="de-DE" dirty="0"/>
           </a:p>
         </p:txBody>
       </p:sp>
@@ -5626,13 +5878,15 @@
               </a:ext>
             </a:extLst>
           </p:cNvPr>
-          <p:cNvCxnSpPr/>
+          <p:cNvCxnSpPr>
+            <a:cxnSpLocks/>
+          </p:cNvCxnSpPr>
           <p:nvPr/>
         </p:nvCxnSpPr>
         <p:spPr>
           <a:xfrm>
-            <a:off x="1835150" y="3524250"/>
-            <a:ext cx="0" cy="901700"/>
+            <a:off x="146050" y="3110376"/>
+            <a:ext cx="0" cy="2238710"/>
           </a:xfrm>
           <a:prstGeom prst="line">
             <a:avLst/>
@@ -5662,13 +5916,15 @@
               </a:ext>
             </a:extLst>
           </p:cNvPr>
-          <p:cNvCxnSpPr/>
+          <p:cNvCxnSpPr>
+            <a:cxnSpLocks/>
+          </p:cNvCxnSpPr>
           <p:nvPr/>
         </p:nvCxnSpPr>
         <p:spPr>
           <a:xfrm>
-            <a:off x="3987800" y="3568700"/>
-            <a:ext cx="0" cy="901700"/>
+            <a:off x="1676400" y="4216760"/>
+            <a:ext cx="0" cy="1157856"/>
           </a:xfrm>
           <a:prstGeom prst="line">
             <a:avLst/>
@@ -5698,13 +5954,15 @@
               </a:ext>
             </a:extLst>
           </p:cNvPr>
-          <p:cNvCxnSpPr/>
+          <p:cNvCxnSpPr>
+            <a:cxnSpLocks/>
+          </p:cNvCxnSpPr>
           <p:nvPr/>
         </p:nvCxnSpPr>
         <p:spPr>
           <a:xfrm>
-            <a:off x="6375400" y="3568700"/>
-            <a:ext cx="0" cy="901700"/>
+            <a:off x="3297233" y="3429000"/>
+            <a:ext cx="0" cy="1894557"/>
           </a:xfrm>
           <a:prstGeom prst="line">
             <a:avLst/>
@@ -5734,13 +5992,550 @@
               </a:ext>
             </a:extLst>
           </p:cNvPr>
-          <p:cNvCxnSpPr/>
+          <p:cNvCxnSpPr>
+            <a:cxnSpLocks/>
+          </p:cNvCxnSpPr>
           <p:nvPr/>
         </p:nvCxnSpPr>
         <p:spPr>
           <a:xfrm>
-            <a:off x="8509000" y="3568700"/>
-            <a:ext cx="0" cy="901700"/>
+            <a:off x="6845300" y="4902960"/>
+            <a:ext cx="0" cy="446126"/>
+          </a:xfrm>
+          <a:prstGeom prst="line">
+            <a:avLst/>
+          </a:prstGeom>
+        </p:spPr>
+        <p:style>
+          <a:lnRef idx="2">
+            <a:schemeClr val="accent1"/>
+          </a:lnRef>
+          <a:fillRef idx="0">
+            <a:schemeClr val="accent1"/>
+          </a:fillRef>
+          <a:effectRef idx="1">
+            <a:schemeClr val="accent1"/>
+          </a:effectRef>
+          <a:fontRef idx="minor">
+            <a:schemeClr val="tx1"/>
+          </a:fontRef>
+        </p:style>
+      </p:cxnSp>
+      <p:sp>
+        <p:nvSpPr>
+          <p:cNvPr id="11" name="Textfeld 10">
+            <a:extLst>
+              <a:ext uri="{FF2B5EF4-FFF2-40B4-BE49-F238E27FC236}">
+                <a16:creationId xmlns:a16="http://schemas.microsoft.com/office/drawing/2014/main" id="{367E3794-57D9-5D89-0D73-95E4F798EA65}"/>
+              </a:ext>
+            </a:extLst>
+          </p:cNvPr>
+          <p:cNvSpPr txBox="1"/>
+          <p:nvPr/>
+        </p:nvSpPr>
+        <p:spPr>
+          <a:xfrm>
+            <a:off x="4337052" y="2967335"/>
+            <a:ext cx="1589023" cy="923330"/>
+          </a:xfrm>
+          <a:prstGeom prst="rect">
+            <a:avLst/>
+          </a:prstGeom>
+          <a:noFill/>
+        </p:spPr>
+        <p:txBody>
+          <a:bodyPr wrap="square" rtlCol="0">
+            <a:spAutoFit/>
+          </a:bodyPr>
+          <a:lstStyle/>
+          <a:p>
+            <a:r>
+              <a:rPr lang="de-DE" dirty="0"/>
+              <a:t>1930s Alan Turing</a:t>
+            </a:r>
+            <a:br>
+              <a:rPr lang="de-DE" dirty="0"/>
+            </a:br>
+            <a:r>
+              <a:rPr lang="de-DE" dirty="0" err="1"/>
+              <a:t>Computability</a:t>
+            </a:r>
+            <a:endParaRPr lang="de-DE" dirty="0"/>
+          </a:p>
+        </p:txBody>
+      </p:sp>
+      <p:sp>
+        <p:nvSpPr>
+          <p:cNvPr id="12" name="Textfeld 11">
+            <a:extLst>
+              <a:ext uri="{FF2B5EF4-FFF2-40B4-BE49-F238E27FC236}">
+                <a16:creationId xmlns:a16="http://schemas.microsoft.com/office/drawing/2014/main" id="{998ADDA6-F112-68B2-B6B7-6F95A5C020E7}"/>
+              </a:ext>
+            </a:extLst>
+          </p:cNvPr>
+          <p:cNvSpPr txBox="1"/>
+          <p:nvPr/>
+        </p:nvSpPr>
+        <p:spPr>
+          <a:xfrm>
+            <a:off x="9033210" y="1628362"/>
+            <a:ext cx="1472399" cy="1477328"/>
+          </a:xfrm>
+          <a:prstGeom prst="rect">
+            <a:avLst/>
+          </a:prstGeom>
+          <a:noFill/>
+        </p:spPr>
+        <p:txBody>
+          <a:bodyPr wrap="square" rtlCol="0">
+            <a:spAutoFit/>
+          </a:bodyPr>
+          <a:lstStyle/>
+          <a:p>
+            <a:r>
+              <a:rPr lang="de-DE" dirty="0"/>
+              <a:t>1982 </a:t>
+            </a:r>
+            <a:r>
+              <a:rPr lang="de-DE" dirty="0" err="1"/>
+              <a:t>Hopfield</a:t>
+            </a:r>
+            <a:br>
+              <a:rPr lang="de-DE" dirty="0"/>
+            </a:br>
+            <a:r>
+              <a:rPr lang="de-DE" dirty="0" err="1"/>
+              <a:t>Associative</a:t>
+            </a:r>
+            <a:r>
+              <a:rPr lang="de-DE" dirty="0"/>
+              <a:t> neuronal </a:t>
+            </a:r>
+            <a:r>
+              <a:rPr lang="de-DE" dirty="0" err="1"/>
+              <a:t>networks</a:t>
+            </a:r>
+            <a:endParaRPr lang="de-DE" dirty="0"/>
+          </a:p>
+        </p:txBody>
+      </p:sp>
+      <p:sp>
+        <p:nvSpPr>
+          <p:cNvPr id="13" name="Textfeld 12">
+            <a:extLst>
+              <a:ext uri="{FF2B5EF4-FFF2-40B4-BE49-F238E27FC236}">
+                <a16:creationId xmlns:a16="http://schemas.microsoft.com/office/drawing/2014/main" id="{85E86178-8AB5-1631-D072-E8EA050673F7}"/>
+              </a:ext>
+            </a:extLst>
+          </p:cNvPr>
+          <p:cNvSpPr txBox="1"/>
+          <p:nvPr/>
+        </p:nvSpPr>
+        <p:spPr>
+          <a:xfrm>
+            <a:off x="6056189" y="2808855"/>
+            <a:ext cx="2905115" cy="646331"/>
+          </a:xfrm>
+          <a:prstGeom prst="rect">
+            <a:avLst/>
+          </a:prstGeom>
+          <a:noFill/>
+        </p:spPr>
+        <p:txBody>
+          <a:bodyPr wrap="square" rtlCol="0">
+            <a:spAutoFit/>
+          </a:bodyPr>
+          <a:lstStyle/>
+          <a:p>
+            <a:r>
+              <a:rPr lang="de-DE" dirty="0"/>
+              <a:t>1949 Hebb</a:t>
+            </a:r>
+            <a:br>
+              <a:rPr lang="de-DE" dirty="0"/>
+            </a:br>
+            <a:r>
+              <a:rPr lang="de-DE" dirty="0" err="1"/>
+              <a:t>plasticity</a:t>
+            </a:r>
+            <a:r>
+              <a:rPr lang="de-DE" dirty="0"/>
+              <a:t> </a:t>
+            </a:r>
+            <a:r>
+              <a:rPr lang="de-DE" dirty="0" err="1"/>
+              <a:t>mechanism</a:t>
+            </a:r>
+            <a:endParaRPr lang="de-DE" dirty="0"/>
+          </a:p>
+        </p:txBody>
+      </p:sp>
+      <p:sp>
+        <p:nvSpPr>
+          <p:cNvPr id="18" name="Textfeld 17">
+            <a:extLst>
+              <a:ext uri="{FF2B5EF4-FFF2-40B4-BE49-F238E27FC236}">
+                <a16:creationId xmlns:a16="http://schemas.microsoft.com/office/drawing/2014/main" id="{CA3095A3-8778-65B6-64F6-3DB8A6C48E08}"/>
+              </a:ext>
+            </a:extLst>
+          </p:cNvPr>
+          <p:cNvSpPr txBox="1"/>
+          <p:nvPr/>
+        </p:nvSpPr>
+        <p:spPr>
+          <a:xfrm>
+            <a:off x="6153052" y="3616596"/>
+            <a:ext cx="1803400" cy="1200329"/>
+          </a:xfrm>
+          <a:prstGeom prst="rect">
+            <a:avLst/>
+          </a:prstGeom>
+          <a:noFill/>
+        </p:spPr>
+        <p:txBody>
+          <a:bodyPr wrap="square" rtlCol="0">
+            <a:spAutoFit/>
+          </a:bodyPr>
+          <a:lstStyle/>
+          <a:p>
+            <a:r>
+              <a:rPr lang="de-DE" dirty="0"/>
+              <a:t>1948 Wiener</a:t>
+            </a:r>
+            <a:br>
+              <a:rPr lang="de-DE" dirty="0"/>
+            </a:br>
+            <a:r>
+              <a:rPr lang="de-DE" dirty="0" err="1"/>
+              <a:t>information</a:t>
+            </a:r>
+            <a:r>
+              <a:rPr lang="de-DE" dirty="0"/>
+              <a:t> </a:t>
+            </a:r>
+            <a:r>
+              <a:rPr lang="de-DE" dirty="0" err="1"/>
+              <a:t>processing</a:t>
+            </a:r>
+            <a:r>
+              <a:rPr lang="de-DE" dirty="0"/>
+              <a:t> and </a:t>
+            </a:r>
+            <a:r>
+              <a:rPr lang="de-DE" dirty="0" err="1"/>
+              <a:t>feedback</a:t>
+            </a:r>
+            <a:endParaRPr lang="de-DE" dirty="0"/>
+          </a:p>
+        </p:txBody>
+      </p:sp>
+      <p:sp>
+        <p:nvSpPr>
+          <p:cNvPr id="19" name="Textfeld 18">
+            <a:extLst>
+              <a:ext uri="{FF2B5EF4-FFF2-40B4-BE49-F238E27FC236}">
+                <a16:creationId xmlns:a16="http://schemas.microsoft.com/office/drawing/2014/main" id="{E75B8176-6099-F77E-8E55-AE57C4B2DFA4}"/>
+              </a:ext>
+            </a:extLst>
+          </p:cNvPr>
+          <p:cNvSpPr txBox="1"/>
+          <p:nvPr/>
+        </p:nvSpPr>
+        <p:spPr>
+          <a:xfrm>
+            <a:off x="9736894" y="3220494"/>
+            <a:ext cx="1535115" cy="1477328"/>
+          </a:xfrm>
+          <a:prstGeom prst="rect">
+            <a:avLst/>
+          </a:prstGeom>
+          <a:noFill/>
+        </p:spPr>
+        <p:txBody>
+          <a:bodyPr wrap="square" rtlCol="0">
+            <a:spAutoFit/>
+          </a:bodyPr>
+          <a:lstStyle/>
+          <a:p>
+            <a:r>
+              <a:rPr lang="de-DE" dirty="0"/>
+              <a:t>1990 Randall Beer</a:t>
+            </a:r>
+            <a:br>
+              <a:rPr lang="de-DE" dirty="0"/>
+            </a:br>
+            <a:r>
+              <a:rPr lang="de-DE" dirty="0" err="1"/>
+              <a:t>Intelligence</a:t>
+            </a:r>
+            <a:r>
+              <a:rPr lang="de-DE" dirty="0"/>
+              <a:t> </a:t>
+            </a:r>
+            <a:r>
+              <a:rPr lang="de-DE" dirty="0" err="1"/>
+              <a:t>as</a:t>
+            </a:r>
+            <a:r>
+              <a:rPr lang="de-DE" dirty="0"/>
+              <a:t> Adaptive </a:t>
+            </a:r>
+            <a:r>
+              <a:rPr lang="de-DE" dirty="0" err="1"/>
+              <a:t>Behavior</a:t>
+            </a:r>
+            <a:endParaRPr lang="de-DE" dirty="0"/>
+          </a:p>
+        </p:txBody>
+      </p:sp>
+      <p:cxnSp>
+        <p:nvCxnSpPr>
+          <p:cNvPr id="21" name="Gerader Verbinder 20">
+            <a:extLst>
+              <a:ext uri="{FF2B5EF4-FFF2-40B4-BE49-F238E27FC236}">
+                <a16:creationId xmlns:a16="http://schemas.microsoft.com/office/drawing/2014/main" id="{2F22C57F-0549-0A40-716B-5DF367C7D267}"/>
+              </a:ext>
+            </a:extLst>
+          </p:cNvPr>
+          <p:cNvCxnSpPr>
+            <a:cxnSpLocks/>
+          </p:cNvCxnSpPr>
+          <p:nvPr/>
+        </p:nvCxnSpPr>
+        <p:spPr>
+          <a:xfrm>
+            <a:off x="4978400" y="3969703"/>
+            <a:ext cx="0" cy="1379383"/>
+          </a:xfrm>
+          <a:prstGeom prst="line">
+            <a:avLst/>
+          </a:prstGeom>
+        </p:spPr>
+        <p:style>
+          <a:lnRef idx="2">
+            <a:schemeClr val="accent1"/>
+          </a:lnRef>
+          <a:fillRef idx="0">
+            <a:schemeClr val="accent1"/>
+          </a:fillRef>
+          <a:effectRef idx="1">
+            <a:schemeClr val="accent1"/>
+          </a:effectRef>
+          <a:fontRef idx="minor">
+            <a:schemeClr val="tx1"/>
+          </a:fontRef>
+        </p:style>
+      </p:cxnSp>
+      <p:sp>
+        <p:nvSpPr>
+          <p:cNvPr id="22" name="Textfeld 21">
+            <a:extLst>
+              <a:ext uri="{FF2B5EF4-FFF2-40B4-BE49-F238E27FC236}">
+                <a16:creationId xmlns:a16="http://schemas.microsoft.com/office/drawing/2014/main" id="{4B0D44BF-7AF3-9D14-53A8-44081AE3946D}"/>
+              </a:ext>
+            </a:extLst>
+          </p:cNvPr>
+          <p:cNvSpPr txBox="1"/>
+          <p:nvPr/>
+        </p:nvSpPr>
+        <p:spPr>
+          <a:xfrm>
+            <a:off x="2952257" y="5497678"/>
+            <a:ext cx="8535190" cy="1477328"/>
+          </a:xfrm>
+          <a:prstGeom prst="rect">
+            <a:avLst/>
+          </a:prstGeom>
+          <a:noFill/>
+        </p:spPr>
+        <p:txBody>
+          <a:bodyPr wrap="square" rtlCol="0">
+            <a:spAutoFit/>
+          </a:bodyPr>
+          <a:lstStyle/>
+          <a:p>
+            <a:pPr algn="r"/>
+            <a:r>
+              <a:rPr lang="de-DE" dirty="0"/>
+              <a:t>Today – </a:t>
+            </a:r>
+            <a:r>
+              <a:rPr lang="de-DE" dirty="0" err="1"/>
+              <a:t>we</a:t>
+            </a:r>
+            <a:r>
+              <a:rPr lang="de-DE" dirty="0"/>
+              <a:t> still </a:t>
+            </a:r>
+            <a:r>
+              <a:rPr lang="de-DE" dirty="0" err="1"/>
+              <a:t>don‘t</a:t>
+            </a:r>
+            <a:r>
+              <a:rPr lang="de-DE" dirty="0"/>
+              <a:t> </a:t>
+            </a:r>
+            <a:r>
+              <a:rPr lang="de-DE" dirty="0" err="1"/>
+              <a:t>know</a:t>
+            </a:r>
+            <a:r>
+              <a:rPr lang="de-DE" dirty="0"/>
+              <a:t>:</a:t>
+            </a:r>
+            <a:br>
+              <a:rPr lang="de-DE" dirty="0"/>
+            </a:br>
+            <a:r>
+              <a:rPr lang="de-DE" dirty="0"/>
+              <a:t>Rolf Pfeifer, Josh Bongard Embedded </a:t>
+            </a:r>
+            <a:r>
+              <a:rPr lang="de-DE" dirty="0" err="1"/>
+              <a:t>cognition</a:t>
+            </a:r>
+            <a:endParaRPr lang="de-DE" dirty="0"/>
+          </a:p>
+          <a:p>
+            <a:pPr algn="r"/>
+            <a:r>
+              <a:rPr lang="de-DE" dirty="0"/>
+              <a:t>Kenneth Stanley NEAT </a:t>
+            </a:r>
+            <a:r>
+              <a:rPr lang="de-DE" dirty="0" err="1"/>
+              <a:t>algorithm</a:t>
+            </a:r>
+            <a:endParaRPr lang="de-DE" dirty="0"/>
+          </a:p>
+          <a:p>
+            <a:pPr algn="r"/>
+            <a:r>
+              <a:rPr lang="de-DE" dirty="0"/>
+              <a:t>Izquierdo, Di Paolo Egbert – </a:t>
+            </a:r>
+            <a:r>
+              <a:rPr lang="de-DE" dirty="0" err="1"/>
+              <a:t>chemotaxis</a:t>
+            </a:r>
+            <a:r>
+              <a:rPr lang="de-DE" dirty="0"/>
+              <a:t> </a:t>
+            </a:r>
+            <a:r>
+              <a:rPr lang="de-DE" dirty="0" err="1"/>
+              <a:t>models</a:t>
+            </a:r>
+            <a:r>
+              <a:rPr lang="de-DE" dirty="0"/>
+              <a:t> / minimal </a:t>
+            </a:r>
+            <a:r>
+              <a:rPr lang="de-DE" dirty="0" err="1"/>
+              <a:t>life</a:t>
+            </a:r>
+            <a:endParaRPr lang="de-DE" dirty="0"/>
+          </a:p>
+          <a:p>
+            <a:pPr algn="r"/>
+            <a:endParaRPr lang="de-DE" dirty="0"/>
+          </a:p>
+        </p:txBody>
+      </p:sp>
+      <p:cxnSp>
+        <p:nvCxnSpPr>
+          <p:cNvPr id="26" name="Gerader Verbinder 25">
+            <a:extLst>
+              <a:ext uri="{FF2B5EF4-FFF2-40B4-BE49-F238E27FC236}">
+                <a16:creationId xmlns:a16="http://schemas.microsoft.com/office/drawing/2014/main" id="{2EE525FE-8203-A89A-A34E-2EFFF9902AE8}"/>
+              </a:ext>
+            </a:extLst>
+          </p:cNvPr>
+          <p:cNvCxnSpPr>
+            <a:cxnSpLocks/>
+          </p:cNvCxnSpPr>
+          <p:nvPr/>
+        </p:nvCxnSpPr>
+        <p:spPr>
+          <a:xfrm>
+            <a:off x="9499600" y="3204644"/>
+            <a:ext cx="0" cy="2118913"/>
+          </a:xfrm>
+          <a:prstGeom prst="line">
+            <a:avLst/>
+          </a:prstGeom>
+        </p:spPr>
+        <p:style>
+          <a:lnRef idx="2">
+            <a:schemeClr val="accent1"/>
+          </a:lnRef>
+          <a:fillRef idx="0">
+            <a:schemeClr val="accent1"/>
+          </a:fillRef>
+          <a:effectRef idx="1">
+            <a:schemeClr val="accent1"/>
+          </a:effectRef>
+          <a:fontRef idx="minor">
+            <a:schemeClr val="tx1"/>
+          </a:fontRef>
+        </p:style>
+      </p:cxnSp>
+      <p:cxnSp>
+        <p:nvCxnSpPr>
+          <p:cNvPr id="28" name="Gerader Verbinder 27">
+            <a:extLst>
+              <a:ext uri="{FF2B5EF4-FFF2-40B4-BE49-F238E27FC236}">
+                <a16:creationId xmlns:a16="http://schemas.microsoft.com/office/drawing/2014/main" id="{B8939105-A446-17A8-A54F-E1FFBC8DA441}"/>
+              </a:ext>
+            </a:extLst>
+          </p:cNvPr>
+          <p:cNvCxnSpPr>
+            <a:cxnSpLocks/>
+          </p:cNvCxnSpPr>
+          <p:nvPr/>
+        </p:nvCxnSpPr>
+        <p:spPr>
+          <a:xfrm>
+            <a:off x="10274300" y="4816925"/>
+            <a:ext cx="0" cy="506632"/>
+          </a:xfrm>
+          <a:prstGeom prst="line">
+            <a:avLst/>
+          </a:prstGeom>
+        </p:spPr>
+        <p:style>
+          <a:lnRef idx="2">
+            <a:schemeClr val="accent1"/>
+          </a:lnRef>
+          <a:fillRef idx="0">
+            <a:schemeClr val="accent1"/>
+          </a:fillRef>
+          <a:effectRef idx="1">
+            <a:schemeClr val="accent1"/>
+          </a:effectRef>
+          <a:fontRef idx="minor">
+            <a:schemeClr val="tx1"/>
+          </a:fontRef>
+        </p:style>
+      </p:cxnSp>
+      <p:cxnSp>
+        <p:nvCxnSpPr>
+          <p:cNvPr id="41" name="Gerader Verbinder 40">
+            <a:extLst>
+              <a:ext uri="{FF2B5EF4-FFF2-40B4-BE49-F238E27FC236}">
+                <a16:creationId xmlns:a16="http://schemas.microsoft.com/office/drawing/2014/main" id="{502FF7C3-A2A3-CF23-E852-B0CE07EE9398}"/>
+              </a:ext>
+            </a:extLst>
+          </p:cNvPr>
+          <p:cNvCxnSpPr>
+            <a:cxnSpLocks/>
+          </p:cNvCxnSpPr>
+          <p:nvPr/>
+        </p:nvCxnSpPr>
+        <p:spPr>
+          <a:xfrm>
+            <a:off x="11442700" y="5349086"/>
+            <a:ext cx="0" cy="506632"/>
           </a:xfrm>
           <a:prstGeom prst="line">
             <a:avLst/>

</xml_diff>

<commit_message>
first ea analysis done
</commit_message>
<xml_diff>
--- a/scicom/skeleton_presentation.pptx
+++ b/scicom/skeleton_presentation.pptx
@@ -5,7 +5,7 @@
     <p:sldMasterId id="2147483672" r:id="rId1"/>
   </p:sldMasterIdLst>
   <p:notesMasterIdLst>
-    <p:notesMasterId r:id="rId16"/>
+    <p:notesMasterId r:id="rId19"/>
   </p:notesMasterIdLst>
   <p:sldIdLst>
     <p:sldId id="256" r:id="rId2"/>
@@ -20,8 +20,11 @@
     <p:sldId id="264" r:id="rId11"/>
     <p:sldId id="265" r:id="rId12"/>
     <p:sldId id="266" r:id="rId13"/>
-    <p:sldId id="267" r:id="rId14"/>
-    <p:sldId id="268" r:id="rId15"/>
+    <p:sldId id="274" r:id="rId14"/>
+    <p:sldId id="275" r:id="rId15"/>
+    <p:sldId id="276" r:id="rId16"/>
+    <p:sldId id="267" r:id="rId17"/>
+    <p:sldId id="268" r:id="rId18"/>
   </p:sldIdLst>
   <p:sldSz cx="12192000" cy="6858000"/>
   <p:notesSz cx="6858000" cy="9144000"/>
@@ -210,7 +213,7 @@
           <a:p>
             <a:fld id="{D45AE30C-70B0-42A3-87DE-9CC4A3E6D756}" type="datetimeFigureOut">
               <a:rPr lang="de-DE" smtClean="0"/>
-              <a:t>21.05.2026</a:t>
+              <a:t>22.05.2026</a:t>
             </a:fld>
             <a:endParaRPr lang="de-DE"/>
           </a:p>
@@ -606,7 +609,7 @@
       </p:sp>
       <p:sp>
         <p:nvSpPr>
-          <p:cNvPr id="11" name="Freihandform: Form 10">
+          <p:cNvPr id="11" name="Bildplatzhalter 10">
             <a:extLst>
               <a:ext uri="{FF2B5EF4-FFF2-40B4-BE49-F238E27FC236}">
                 <a16:creationId xmlns:a16="http://schemas.microsoft.com/office/drawing/2014/main" id="{0BE99575-E147-F93F-806D-EFBBEA19C613}"/>
@@ -2966,42 +2969,6 @@
       </p:sp>
       <p:sp>
         <p:nvSpPr>
-          <p:cNvPr id="4" name="Fußzeilenplatzhalter 3">
-            <a:extLst>
-              <a:ext uri="{FF2B5EF4-FFF2-40B4-BE49-F238E27FC236}">
-                <a16:creationId xmlns:a16="http://schemas.microsoft.com/office/drawing/2014/main" id="{E0C68328-73DA-E0F1-F32F-FA77A9035546}"/>
-              </a:ext>
-            </a:extLst>
-          </p:cNvPr>
-          <p:cNvSpPr>
-            <a:spLocks noGrp="1"/>
-          </p:cNvSpPr>
-          <p:nvPr>
-            <p:ph type="ftr" sz="quarter" idx="4294967295"/>
-          </p:nvPr>
-        </p:nvSpPr>
-        <p:spPr>
-          <a:xfrm>
-            <a:off x="4038600" y="6356350"/>
-            <a:ext cx="4114800" cy="365125"/>
-          </a:xfrm>
-          <a:prstGeom prst="rect">
-            <a:avLst/>
-          </a:prstGeom>
-        </p:spPr>
-        <p:txBody>
-          <a:bodyPr/>
-          <a:lstStyle/>
-          <a:p>
-            <a:r>
-              <a:rPr lang="de-DE"/>
-              <a:t>Dr. Jana Dahlmanns – Jana.Dahlmanns@fau.de</a:t>
-            </a:r>
-          </a:p>
-        </p:txBody>
-      </p:sp>
-      <p:sp>
-        <p:nvSpPr>
           <p:cNvPr id="5" name="Foliennummernplatzhalter 4">
             <a:extLst>
               <a:ext uri="{FF2B5EF4-FFF2-40B4-BE49-F238E27FC236}">
@@ -3048,6 +3015,1716 @@
 </file>
 
 <file path=ppt/slides/slide13.xml><?xml version="1.0" encoding="utf-8"?>
+<p:sld xmlns:a="http://schemas.openxmlformats.org/drawingml/2006/main" xmlns:r="http://schemas.openxmlformats.org/officeDocument/2006/relationships" xmlns:p="http://schemas.openxmlformats.org/presentationml/2006/main">
+  <p:cSld>
+    <p:spTree>
+      <p:nvGrpSpPr>
+        <p:cNvPr id="1" name=""/>
+        <p:cNvGrpSpPr/>
+        <p:nvPr/>
+      </p:nvGrpSpPr>
+      <p:grpSpPr>
+        <a:xfrm>
+          <a:off x="0" y="0"/>
+          <a:ext cx="0" cy="0"/>
+          <a:chOff x="0" y="0"/>
+          <a:chExt cx="0" cy="0"/>
+        </a:xfrm>
+      </p:grpSpPr>
+      <p:sp>
+        <p:nvSpPr>
+          <p:cNvPr id="2" name="Freihandform: Form 1">
+            <a:extLst>
+              <a:ext uri="{FF2B5EF4-FFF2-40B4-BE49-F238E27FC236}">
+                <a16:creationId xmlns:a16="http://schemas.microsoft.com/office/drawing/2014/main" id="{80F24036-86EB-92D8-75F6-99D5EE080D6F}"/>
+              </a:ext>
+            </a:extLst>
+          </p:cNvPr>
+          <p:cNvSpPr/>
+          <p:nvPr/>
+        </p:nvSpPr>
+        <p:spPr>
+          <a:xfrm flipH="1">
+            <a:off x="8657661" y="-2930196"/>
+            <a:ext cx="6300782" cy="3481390"/>
+          </a:xfrm>
+          <a:custGeom>
+            <a:avLst/>
+            <a:gdLst>
+              <a:gd name="csX0" fmla="*/ 0 w 6300782"/>
+              <a:gd name="csY0" fmla="*/ 0 h 3481390"/>
+              <a:gd name="csX1" fmla="*/ 4560087 w 6300782"/>
+              <a:gd name="csY1" fmla="*/ 0 h 3481390"/>
+              <a:gd name="csX2" fmla="*/ 4562473 w 6300782"/>
+              <a:gd name="csY2" fmla="*/ 0 h 3481390"/>
+              <a:gd name="csX3" fmla="*/ 4562473 w 6300782"/>
+              <a:gd name="csY3" fmla="*/ 121 h 3481390"/>
+              <a:gd name="csX4" fmla="*/ 4738063 w 6300782"/>
+              <a:gd name="csY4" fmla="*/ 8987 h 3481390"/>
+              <a:gd name="csX5" fmla="*/ 6300782 w 6300782"/>
+              <a:gd name="csY5" fmla="*/ 1740695 h 3481390"/>
+              <a:gd name="csX6" fmla="*/ 4738063 w 6300782"/>
+              <a:gd name="csY6" fmla="*/ 3472403 h 3481390"/>
+              <a:gd name="csX7" fmla="*/ 4562473 w 6300782"/>
+              <a:gd name="csY7" fmla="*/ 3481270 h 3481390"/>
+              <a:gd name="csX8" fmla="*/ 4562473 w 6300782"/>
+              <a:gd name="csY8" fmla="*/ 3481390 h 3481390"/>
+              <a:gd name="csX9" fmla="*/ 4560087 w 6300782"/>
+              <a:gd name="csY9" fmla="*/ 3481390 h 3481390"/>
+              <a:gd name="csX10" fmla="*/ 0 w 6300782"/>
+              <a:gd name="csY10" fmla="*/ 3481390 h 3481390"/>
+            </a:gdLst>
+            <a:ahLst/>
+            <a:cxnLst>
+              <a:cxn ang="0">
+                <a:pos x="csX0" y="csY0"/>
+              </a:cxn>
+              <a:cxn ang="0">
+                <a:pos x="csX1" y="csY1"/>
+              </a:cxn>
+              <a:cxn ang="0">
+                <a:pos x="csX2" y="csY2"/>
+              </a:cxn>
+              <a:cxn ang="0">
+                <a:pos x="csX3" y="csY3"/>
+              </a:cxn>
+              <a:cxn ang="0">
+                <a:pos x="csX4" y="csY4"/>
+              </a:cxn>
+              <a:cxn ang="0">
+                <a:pos x="csX5" y="csY5"/>
+              </a:cxn>
+              <a:cxn ang="0">
+                <a:pos x="csX6" y="csY6"/>
+              </a:cxn>
+              <a:cxn ang="0">
+                <a:pos x="csX7" y="csY7"/>
+              </a:cxn>
+              <a:cxn ang="0">
+                <a:pos x="csX8" y="csY8"/>
+              </a:cxn>
+              <a:cxn ang="0">
+                <a:pos x="csX9" y="csY9"/>
+              </a:cxn>
+              <a:cxn ang="0">
+                <a:pos x="csX10" y="csY10"/>
+              </a:cxn>
+            </a:cxnLst>
+            <a:rect l="l" t="t" r="r" b="b"/>
+            <a:pathLst>
+              <a:path w="6300782" h="3481390">
+                <a:moveTo>
+                  <a:pt x="0" y="0"/>
+                </a:moveTo>
+                <a:lnTo>
+                  <a:pt x="4560087" y="0"/>
+                </a:lnTo>
+                <a:lnTo>
+                  <a:pt x="4562473" y="0"/>
+                </a:lnTo>
+                <a:lnTo>
+                  <a:pt x="4562473" y="121"/>
+                </a:lnTo>
+                <a:lnTo>
+                  <a:pt x="4738063" y="8987"/>
+                </a:lnTo>
+                <a:cubicBezTo>
+                  <a:pt x="5615819" y="98128"/>
+                  <a:pt x="6300782" y="839421"/>
+                  <a:pt x="6300782" y="1740695"/>
+                </a:cubicBezTo>
+                <a:cubicBezTo>
+                  <a:pt x="6300782" y="2641969"/>
+                  <a:pt x="5615819" y="3383262"/>
+                  <a:pt x="4738063" y="3472403"/>
+                </a:cubicBezTo>
+                <a:lnTo>
+                  <a:pt x="4562473" y="3481270"/>
+                </a:lnTo>
+                <a:lnTo>
+                  <a:pt x="4562473" y="3481390"/>
+                </a:lnTo>
+                <a:lnTo>
+                  <a:pt x="4560087" y="3481390"/>
+                </a:lnTo>
+                <a:lnTo>
+                  <a:pt x="0" y="3481390"/>
+                </a:lnTo>
+                <a:close/>
+              </a:path>
+            </a:pathLst>
+          </a:custGeom>
+          <a:solidFill>
+            <a:srgbClr val="E3E9EA"/>
+          </a:solidFill>
+          <a:ln>
+            <a:noFill/>
+          </a:ln>
+        </p:spPr>
+        <p:style>
+          <a:lnRef idx="2">
+            <a:schemeClr val="accent1">
+              <a:shade val="15000"/>
+            </a:schemeClr>
+          </a:lnRef>
+          <a:fillRef idx="1">
+            <a:schemeClr val="accent1"/>
+          </a:fillRef>
+          <a:effectRef idx="0">
+            <a:schemeClr val="accent1"/>
+          </a:effectRef>
+          <a:fontRef idx="minor">
+            <a:schemeClr val="lt1"/>
+          </a:fontRef>
+        </p:style>
+        <p:txBody>
+          <a:bodyPr lIns="0" tIns="0" rIns="0" bIns="0" rtlCol="0" anchor="ctr"/>
+          <a:lstStyle/>
+          <a:p>
+            <a:pPr algn="ctr"/>
+            <a:endParaRPr lang="de-DE" sz="1600" b="1">
+              <a:solidFill>
+                <a:schemeClr val="tx1"/>
+              </a:solidFill>
+            </a:endParaRPr>
+          </a:p>
+        </p:txBody>
+      </p:sp>
+      <p:sp>
+        <p:nvSpPr>
+          <p:cNvPr id="3" name="Textfeld 2">
+            <a:extLst>
+              <a:ext uri="{FF2B5EF4-FFF2-40B4-BE49-F238E27FC236}">
+                <a16:creationId xmlns:a16="http://schemas.microsoft.com/office/drawing/2014/main" id="{0A253A0D-1AD4-85BB-B175-E77C4442F053}"/>
+              </a:ext>
+            </a:extLst>
+          </p:cNvPr>
+          <p:cNvSpPr txBox="1"/>
+          <p:nvPr/>
+        </p:nvSpPr>
+        <p:spPr>
+          <a:xfrm>
+            <a:off x="10287922" y="153126"/>
+            <a:ext cx="1904078" cy="461665"/>
+          </a:xfrm>
+          <a:prstGeom prst="rect">
+            <a:avLst/>
+          </a:prstGeom>
+          <a:noFill/>
+        </p:spPr>
+        <p:txBody>
+          <a:bodyPr wrap="square" rtlCol="0">
+            <a:spAutoFit/>
+          </a:bodyPr>
+          <a:lstStyle/>
+          <a:p>
+            <a:pPr algn="ctr"/>
+            <a:r>
+              <a:rPr lang="de-DE" sz="2400" dirty="0">
+                <a:solidFill>
+                  <a:srgbClr val="00336E"/>
+                </a:solidFill>
+                <a:ea typeface="Cormorant Garamond" pitchFamily="2" charset="0"/>
+                <a:cs typeface="Cormorant Garamond" pitchFamily="2" charset="0"/>
+              </a:rPr>
+              <a:t>First </a:t>
+            </a:r>
+            <a:r>
+              <a:rPr lang="de-DE" sz="2400" dirty="0" err="1">
+                <a:solidFill>
+                  <a:srgbClr val="00336E"/>
+                </a:solidFill>
+                <a:ea typeface="Cormorant Garamond" pitchFamily="2" charset="0"/>
+                <a:cs typeface="Cormorant Garamond" pitchFamily="2" charset="0"/>
+              </a:rPr>
+              <a:t>results</a:t>
+            </a:r>
+            <a:endParaRPr lang="de-DE" sz="2400" b="1" dirty="0">
+              <a:solidFill>
+                <a:srgbClr val="00336E"/>
+              </a:solidFill>
+              <a:ea typeface="Cormorant Garamond" pitchFamily="2" charset="0"/>
+              <a:cs typeface="Cormorant Garamond" pitchFamily="2" charset="0"/>
+            </a:endParaRPr>
+          </a:p>
+        </p:txBody>
+      </p:sp>
+      <p:pic>
+        <p:nvPicPr>
+          <p:cNvPr id="5" name="Grafik 4">
+            <a:extLst>
+              <a:ext uri="{FF2B5EF4-FFF2-40B4-BE49-F238E27FC236}">
+                <a16:creationId xmlns:a16="http://schemas.microsoft.com/office/drawing/2014/main" id="{E1D48006-8B7F-A500-8300-9AA2D1B461A6}"/>
+              </a:ext>
+            </a:extLst>
+          </p:cNvPr>
+          <p:cNvPicPr>
+            <a:picLocks noChangeAspect="1"/>
+          </p:cNvPicPr>
+          <p:nvPr/>
+        </p:nvPicPr>
+        <p:blipFill>
+          <a:blip r:embed="rId2">
+            <a:extLst>
+              <a:ext uri="{28A0092B-C50C-407E-A947-70E740481C1C}">
+                <a14:useLocalDpi xmlns:a14="http://schemas.microsoft.com/office/drawing/2010/main" val="0"/>
+              </a:ext>
+            </a:extLst>
+          </a:blip>
+          <a:stretch>
+            <a:fillRect/>
+          </a:stretch>
+        </p:blipFill>
+        <p:spPr>
+          <a:xfrm>
+            <a:off x="1545536" y="745367"/>
+            <a:ext cx="9100927" cy="4494284"/>
+          </a:xfrm>
+          <a:prstGeom prst="rect">
+            <a:avLst/>
+          </a:prstGeom>
+        </p:spPr>
+      </p:pic>
+      <p:sp>
+        <p:nvSpPr>
+          <p:cNvPr id="7" name="Textfeld 6">
+            <a:extLst>
+              <a:ext uri="{FF2B5EF4-FFF2-40B4-BE49-F238E27FC236}">
+                <a16:creationId xmlns:a16="http://schemas.microsoft.com/office/drawing/2014/main" id="{1B6950D7-4A94-4227-75D2-A44BA0FB54EA}"/>
+              </a:ext>
+            </a:extLst>
+          </p:cNvPr>
+          <p:cNvSpPr txBox="1"/>
+          <p:nvPr/>
+        </p:nvSpPr>
+        <p:spPr>
+          <a:xfrm>
+            <a:off x="3119757" y="5239651"/>
+            <a:ext cx="8120204" cy="1149097"/>
+          </a:xfrm>
+          <a:prstGeom prst="rect">
+            <a:avLst/>
+          </a:prstGeom>
+          <a:noFill/>
+        </p:spPr>
+        <p:txBody>
+          <a:bodyPr wrap="square">
+            <a:spAutoFit/>
+          </a:bodyPr>
+          <a:lstStyle/>
+          <a:p>
+            <a:pPr>
+              <a:lnSpc>
+                <a:spcPct val="115000"/>
+              </a:lnSpc>
+              <a:spcAft>
+                <a:spcPts val="1000"/>
+              </a:spcAft>
+              <a:buNone/>
+            </a:pPr>
+            <a:r>
+              <a:rPr lang="en-US" sz="1800" dirty="0">
+                <a:effectLst/>
+                <a:ea typeface="MS Mincho" panose="02020609040205080304" pitchFamily="49" charset="-128"/>
+                <a:cs typeface="Times New Roman" panose="02020603050405020304" pitchFamily="18" charset="0"/>
+              </a:rPr>
+              <a:t>EA evolved from random network initialization. Population size = 250, elite = 10</a:t>
+            </a:r>
+            <a:endParaRPr lang="en-US" dirty="0">
+              <a:ea typeface="MS Mincho" panose="02020609040205080304" pitchFamily="49" charset="-128"/>
+              <a:cs typeface="Times New Roman" panose="02020603050405020304" pitchFamily="18" charset="0"/>
+            </a:endParaRPr>
+          </a:p>
+          <a:p>
+            <a:pPr>
+              <a:lnSpc>
+                <a:spcPct val="115000"/>
+              </a:lnSpc>
+              <a:spcAft>
+                <a:spcPts val="1000"/>
+              </a:spcAft>
+              <a:buNone/>
+            </a:pPr>
+            <a:r>
+              <a:rPr lang="en-US" sz="1800" dirty="0">
+                <a:effectLst/>
+                <a:ea typeface="MS Mincho" panose="02020609040205080304" pitchFamily="49" charset="-128"/>
+                <a:cs typeface="Times New Roman" panose="02020603050405020304" pitchFamily="18" charset="0"/>
+              </a:rPr>
+              <a:t>In generation 0:	mean = 19.5,	median = 19.2,	max = 29.7</a:t>
+            </a:r>
+            <a:br>
+              <a:rPr lang="en-US" sz="1800" dirty="0">
+                <a:effectLst/>
+                <a:ea typeface="MS Mincho" panose="02020609040205080304" pitchFamily="49" charset="-128"/>
+                <a:cs typeface="Times New Roman" panose="02020603050405020304" pitchFamily="18" charset="0"/>
+              </a:rPr>
+            </a:br>
+            <a:r>
+              <a:rPr lang="en-US" sz="1800" dirty="0">
+                <a:effectLst/>
+                <a:ea typeface="MS Mincho" panose="02020609040205080304" pitchFamily="49" charset="-128"/>
+                <a:cs typeface="Times New Roman" panose="02020603050405020304" pitchFamily="18" charset="0"/>
+              </a:rPr>
+              <a:t>In generation 50:	mean = 69.0,	median = 74.22,	max = 131.59</a:t>
+            </a:r>
+            <a:endParaRPr lang="de-DE" sz="1800" dirty="0">
+              <a:effectLst/>
+              <a:ea typeface="MS Mincho" panose="02020609040205080304" pitchFamily="49" charset="-128"/>
+              <a:cs typeface="Times New Roman" panose="02020603050405020304" pitchFamily="18" charset="0"/>
+            </a:endParaRPr>
+          </a:p>
+        </p:txBody>
+      </p:sp>
+    </p:spTree>
+    <p:extLst>
+      <p:ext uri="{BB962C8B-B14F-4D97-AF65-F5344CB8AC3E}">
+        <p14:creationId xmlns:p14="http://schemas.microsoft.com/office/powerpoint/2010/main" val="487920200"/>
+      </p:ext>
+    </p:extLst>
+  </p:cSld>
+  <p:clrMapOvr>
+    <a:masterClrMapping/>
+  </p:clrMapOvr>
+</p:sld>
+</file>
+
+<file path=ppt/slides/slide14.xml><?xml version="1.0" encoding="utf-8"?>
+<p:sld xmlns:a="http://schemas.openxmlformats.org/drawingml/2006/main" xmlns:r="http://schemas.openxmlformats.org/officeDocument/2006/relationships" xmlns:p="http://schemas.openxmlformats.org/presentationml/2006/main">
+  <p:cSld>
+    <p:spTree>
+      <p:nvGrpSpPr>
+        <p:cNvPr id="1" name="">
+          <a:extLst>
+            <a:ext uri="{FF2B5EF4-FFF2-40B4-BE49-F238E27FC236}">
+              <a16:creationId xmlns:a16="http://schemas.microsoft.com/office/drawing/2014/main" id="{A8994726-CD7B-F7EB-CA98-E91B156BA6E0}"/>
+            </a:ext>
+          </a:extLst>
+        </p:cNvPr>
+        <p:cNvGrpSpPr/>
+        <p:nvPr/>
+      </p:nvGrpSpPr>
+      <p:grpSpPr>
+        <a:xfrm>
+          <a:off x="0" y="0"/>
+          <a:ext cx="0" cy="0"/>
+          <a:chOff x="0" y="0"/>
+          <a:chExt cx="0" cy="0"/>
+        </a:xfrm>
+      </p:grpSpPr>
+      <p:sp>
+        <p:nvSpPr>
+          <p:cNvPr id="2" name="Freihandform: Form 1">
+            <a:extLst>
+              <a:ext uri="{FF2B5EF4-FFF2-40B4-BE49-F238E27FC236}">
+                <a16:creationId xmlns:a16="http://schemas.microsoft.com/office/drawing/2014/main" id="{52F93A49-5049-7E4C-7F4F-9C5919C4B5A5}"/>
+              </a:ext>
+            </a:extLst>
+          </p:cNvPr>
+          <p:cNvSpPr/>
+          <p:nvPr/>
+        </p:nvSpPr>
+        <p:spPr>
+          <a:xfrm flipH="1">
+            <a:off x="8657661" y="-2930196"/>
+            <a:ext cx="6300782" cy="3481390"/>
+          </a:xfrm>
+          <a:custGeom>
+            <a:avLst/>
+            <a:gdLst>
+              <a:gd name="csX0" fmla="*/ 0 w 6300782"/>
+              <a:gd name="csY0" fmla="*/ 0 h 3481390"/>
+              <a:gd name="csX1" fmla="*/ 4560087 w 6300782"/>
+              <a:gd name="csY1" fmla="*/ 0 h 3481390"/>
+              <a:gd name="csX2" fmla="*/ 4562473 w 6300782"/>
+              <a:gd name="csY2" fmla="*/ 0 h 3481390"/>
+              <a:gd name="csX3" fmla="*/ 4562473 w 6300782"/>
+              <a:gd name="csY3" fmla="*/ 121 h 3481390"/>
+              <a:gd name="csX4" fmla="*/ 4738063 w 6300782"/>
+              <a:gd name="csY4" fmla="*/ 8987 h 3481390"/>
+              <a:gd name="csX5" fmla="*/ 6300782 w 6300782"/>
+              <a:gd name="csY5" fmla="*/ 1740695 h 3481390"/>
+              <a:gd name="csX6" fmla="*/ 4738063 w 6300782"/>
+              <a:gd name="csY6" fmla="*/ 3472403 h 3481390"/>
+              <a:gd name="csX7" fmla="*/ 4562473 w 6300782"/>
+              <a:gd name="csY7" fmla="*/ 3481270 h 3481390"/>
+              <a:gd name="csX8" fmla="*/ 4562473 w 6300782"/>
+              <a:gd name="csY8" fmla="*/ 3481390 h 3481390"/>
+              <a:gd name="csX9" fmla="*/ 4560087 w 6300782"/>
+              <a:gd name="csY9" fmla="*/ 3481390 h 3481390"/>
+              <a:gd name="csX10" fmla="*/ 0 w 6300782"/>
+              <a:gd name="csY10" fmla="*/ 3481390 h 3481390"/>
+            </a:gdLst>
+            <a:ahLst/>
+            <a:cxnLst>
+              <a:cxn ang="0">
+                <a:pos x="csX0" y="csY0"/>
+              </a:cxn>
+              <a:cxn ang="0">
+                <a:pos x="csX1" y="csY1"/>
+              </a:cxn>
+              <a:cxn ang="0">
+                <a:pos x="csX2" y="csY2"/>
+              </a:cxn>
+              <a:cxn ang="0">
+                <a:pos x="csX3" y="csY3"/>
+              </a:cxn>
+              <a:cxn ang="0">
+                <a:pos x="csX4" y="csY4"/>
+              </a:cxn>
+              <a:cxn ang="0">
+                <a:pos x="csX5" y="csY5"/>
+              </a:cxn>
+              <a:cxn ang="0">
+                <a:pos x="csX6" y="csY6"/>
+              </a:cxn>
+              <a:cxn ang="0">
+                <a:pos x="csX7" y="csY7"/>
+              </a:cxn>
+              <a:cxn ang="0">
+                <a:pos x="csX8" y="csY8"/>
+              </a:cxn>
+              <a:cxn ang="0">
+                <a:pos x="csX9" y="csY9"/>
+              </a:cxn>
+              <a:cxn ang="0">
+                <a:pos x="csX10" y="csY10"/>
+              </a:cxn>
+            </a:cxnLst>
+            <a:rect l="l" t="t" r="r" b="b"/>
+            <a:pathLst>
+              <a:path w="6300782" h="3481390">
+                <a:moveTo>
+                  <a:pt x="0" y="0"/>
+                </a:moveTo>
+                <a:lnTo>
+                  <a:pt x="4560087" y="0"/>
+                </a:lnTo>
+                <a:lnTo>
+                  <a:pt x="4562473" y="0"/>
+                </a:lnTo>
+                <a:lnTo>
+                  <a:pt x="4562473" y="121"/>
+                </a:lnTo>
+                <a:lnTo>
+                  <a:pt x="4738063" y="8987"/>
+                </a:lnTo>
+                <a:cubicBezTo>
+                  <a:pt x="5615819" y="98128"/>
+                  <a:pt x="6300782" y="839421"/>
+                  <a:pt x="6300782" y="1740695"/>
+                </a:cubicBezTo>
+                <a:cubicBezTo>
+                  <a:pt x="6300782" y="2641969"/>
+                  <a:pt x="5615819" y="3383262"/>
+                  <a:pt x="4738063" y="3472403"/>
+                </a:cubicBezTo>
+                <a:lnTo>
+                  <a:pt x="4562473" y="3481270"/>
+                </a:lnTo>
+                <a:lnTo>
+                  <a:pt x="4562473" y="3481390"/>
+                </a:lnTo>
+                <a:lnTo>
+                  <a:pt x="4560087" y="3481390"/>
+                </a:lnTo>
+                <a:lnTo>
+                  <a:pt x="0" y="3481390"/>
+                </a:lnTo>
+                <a:close/>
+              </a:path>
+            </a:pathLst>
+          </a:custGeom>
+          <a:solidFill>
+            <a:srgbClr val="E3E9EA"/>
+          </a:solidFill>
+          <a:ln>
+            <a:noFill/>
+          </a:ln>
+        </p:spPr>
+        <p:style>
+          <a:lnRef idx="2">
+            <a:schemeClr val="accent1">
+              <a:shade val="15000"/>
+            </a:schemeClr>
+          </a:lnRef>
+          <a:fillRef idx="1">
+            <a:schemeClr val="accent1"/>
+          </a:fillRef>
+          <a:effectRef idx="0">
+            <a:schemeClr val="accent1"/>
+          </a:effectRef>
+          <a:fontRef idx="minor">
+            <a:schemeClr val="lt1"/>
+          </a:fontRef>
+        </p:style>
+        <p:txBody>
+          <a:bodyPr lIns="0" tIns="0" rIns="0" bIns="0" rtlCol="0" anchor="ctr"/>
+          <a:lstStyle/>
+          <a:p>
+            <a:pPr algn="ctr"/>
+            <a:endParaRPr lang="de-DE" sz="1600" b="1">
+              <a:solidFill>
+                <a:schemeClr val="tx1"/>
+              </a:solidFill>
+            </a:endParaRPr>
+          </a:p>
+        </p:txBody>
+      </p:sp>
+      <p:sp>
+        <p:nvSpPr>
+          <p:cNvPr id="3" name="Textfeld 2">
+            <a:extLst>
+              <a:ext uri="{FF2B5EF4-FFF2-40B4-BE49-F238E27FC236}">
+                <a16:creationId xmlns:a16="http://schemas.microsoft.com/office/drawing/2014/main" id="{8D75CC9B-9E4B-B18B-A128-5BA123A97C84}"/>
+              </a:ext>
+            </a:extLst>
+          </p:cNvPr>
+          <p:cNvSpPr txBox="1"/>
+          <p:nvPr/>
+        </p:nvSpPr>
+        <p:spPr>
+          <a:xfrm>
+            <a:off x="10287922" y="153126"/>
+            <a:ext cx="1904078" cy="461665"/>
+          </a:xfrm>
+          <a:prstGeom prst="rect">
+            <a:avLst/>
+          </a:prstGeom>
+          <a:noFill/>
+        </p:spPr>
+        <p:txBody>
+          <a:bodyPr wrap="square" rtlCol="0">
+            <a:spAutoFit/>
+          </a:bodyPr>
+          <a:lstStyle/>
+          <a:p>
+            <a:pPr algn="ctr"/>
+            <a:r>
+              <a:rPr lang="de-DE" sz="2400" dirty="0">
+                <a:solidFill>
+                  <a:srgbClr val="00336E"/>
+                </a:solidFill>
+                <a:ea typeface="Cormorant Garamond" pitchFamily="2" charset="0"/>
+                <a:cs typeface="Cormorant Garamond" pitchFamily="2" charset="0"/>
+              </a:rPr>
+              <a:t>First </a:t>
+            </a:r>
+            <a:r>
+              <a:rPr lang="de-DE" sz="2400" dirty="0" err="1">
+                <a:solidFill>
+                  <a:srgbClr val="00336E"/>
+                </a:solidFill>
+                <a:ea typeface="Cormorant Garamond" pitchFamily="2" charset="0"/>
+                <a:cs typeface="Cormorant Garamond" pitchFamily="2" charset="0"/>
+              </a:rPr>
+              <a:t>results</a:t>
+            </a:r>
+            <a:endParaRPr lang="de-DE" sz="2400" b="1" dirty="0">
+              <a:solidFill>
+                <a:srgbClr val="00336E"/>
+              </a:solidFill>
+              <a:ea typeface="Cormorant Garamond" pitchFamily="2" charset="0"/>
+              <a:cs typeface="Cormorant Garamond" pitchFamily="2" charset="0"/>
+            </a:endParaRPr>
+          </a:p>
+        </p:txBody>
+      </p:sp>
+      <p:sp>
+        <p:nvSpPr>
+          <p:cNvPr id="7" name="Textfeld 6">
+            <a:extLst>
+              <a:ext uri="{FF2B5EF4-FFF2-40B4-BE49-F238E27FC236}">
+                <a16:creationId xmlns:a16="http://schemas.microsoft.com/office/drawing/2014/main" id="{462CA17C-D3A2-BD63-7ACB-E8ABDA6D8657}"/>
+              </a:ext>
+            </a:extLst>
+          </p:cNvPr>
+          <p:cNvSpPr txBox="1"/>
+          <p:nvPr/>
+        </p:nvSpPr>
+        <p:spPr>
+          <a:xfrm>
+            <a:off x="304129" y="957362"/>
+            <a:ext cx="5674176" cy="2179315"/>
+          </a:xfrm>
+          <a:prstGeom prst="rect">
+            <a:avLst/>
+          </a:prstGeom>
+          <a:noFill/>
+        </p:spPr>
+        <p:txBody>
+          <a:bodyPr wrap="square">
+            <a:spAutoFit/>
+          </a:bodyPr>
+          <a:lstStyle/>
+          <a:p>
+            <a:pPr>
+              <a:lnSpc>
+                <a:spcPct val="115000"/>
+              </a:lnSpc>
+              <a:spcAft>
+                <a:spcPts val="1000"/>
+              </a:spcAft>
+              <a:buNone/>
+            </a:pPr>
+            <a:r>
+              <a:rPr lang="en-US" sz="1800" dirty="0">
+                <a:effectLst/>
+                <a:ea typeface="MS Mincho" panose="02020609040205080304" pitchFamily="49" charset="-128"/>
+                <a:cs typeface="Times New Roman" panose="02020603050405020304" pitchFamily="18" charset="0"/>
+              </a:rPr>
+              <a:t>Optimal solution?</a:t>
+            </a:r>
+          </a:p>
+          <a:p>
+            <a:pPr>
+              <a:lnSpc>
+                <a:spcPct val="115000"/>
+              </a:lnSpc>
+              <a:spcAft>
+                <a:spcPts val="1000"/>
+              </a:spcAft>
+              <a:buNone/>
+            </a:pPr>
+            <a:endParaRPr lang="en-US" dirty="0">
+              <a:ea typeface="MS Mincho" panose="02020609040205080304" pitchFamily="49" charset="-128"/>
+              <a:cs typeface="Times New Roman" panose="02020603050405020304" pitchFamily="18" charset="0"/>
+            </a:endParaRPr>
+          </a:p>
+          <a:p>
+            <a:pPr>
+              <a:lnSpc>
+                <a:spcPct val="115000"/>
+              </a:lnSpc>
+              <a:spcAft>
+                <a:spcPts val="1000"/>
+              </a:spcAft>
+              <a:buNone/>
+            </a:pPr>
+            <a:r>
+              <a:rPr lang="en-US" sz="1800" dirty="0">
+                <a:effectLst/>
+                <a:ea typeface="MS Mincho" panose="02020609040205080304" pitchFamily="49" charset="-128"/>
+                <a:cs typeface="Times New Roman" panose="02020603050405020304" pitchFamily="18" charset="0"/>
+              </a:rPr>
+              <a:t>If on food → stay and eat</a:t>
+            </a:r>
+          </a:p>
+          <a:p>
+            <a:pPr>
+              <a:lnSpc>
+                <a:spcPct val="115000"/>
+              </a:lnSpc>
+              <a:spcAft>
+                <a:spcPts val="1000"/>
+              </a:spcAft>
+              <a:buNone/>
+            </a:pPr>
+            <a:r>
+              <a:rPr lang="en-US" sz="1800" dirty="0">
+                <a:effectLst/>
+                <a:ea typeface="MS Mincho" panose="02020609040205080304" pitchFamily="49" charset="-128"/>
+                <a:cs typeface="Times New Roman" panose="02020603050405020304" pitchFamily="18" charset="0"/>
+              </a:rPr>
+              <a:t>If sensing food in </a:t>
+            </a:r>
+            <a:r>
+              <a:rPr lang="en-US" dirty="0">
+                <a:ea typeface="MS Mincho" panose="02020609040205080304" pitchFamily="49" charset="-128"/>
+                <a:cs typeface="Times New Roman" panose="02020603050405020304" pitchFamily="18" charset="0"/>
+              </a:rPr>
+              <a:t>one direction → move in that direction</a:t>
+            </a:r>
+          </a:p>
+          <a:p>
+            <a:pPr>
+              <a:lnSpc>
+                <a:spcPct val="115000"/>
+              </a:lnSpc>
+              <a:spcAft>
+                <a:spcPts val="1000"/>
+              </a:spcAft>
+              <a:buNone/>
+            </a:pPr>
+            <a:r>
+              <a:rPr lang="en-US" dirty="0">
+                <a:ea typeface="MS Mincho" panose="02020609040205080304" pitchFamily="49" charset="-128"/>
+                <a:cs typeface="Times New Roman" panose="02020603050405020304" pitchFamily="18" charset="0"/>
+              </a:rPr>
+              <a:t>If not sensing any food → move away  </a:t>
+            </a:r>
+            <a:endParaRPr lang="de-DE" sz="1800" dirty="0">
+              <a:effectLst/>
+              <a:ea typeface="MS Mincho" panose="02020609040205080304" pitchFamily="49" charset="-128"/>
+              <a:cs typeface="Times New Roman" panose="02020603050405020304" pitchFamily="18" charset="0"/>
+            </a:endParaRPr>
+          </a:p>
+        </p:txBody>
+      </p:sp>
+      <p:pic>
+        <p:nvPicPr>
+          <p:cNvPr id="9" name="Grafik 8">
+            <a:extLst>
+              <a:ext uri="{FF2B5EF4-FFF2-40B4-BE49-F238E27FC236}">
+                <a16:creationId xmlns:a16="http://schemas.microsoft.com/office/drawing/2014/main" id="{2CDF4BD9-04AD-868F-5E50-A05E5AF09D15}"/>
+              </a:ext>
+            </a:extLst>
+          </p:cNvPr>
+          <p:cNvPicPr>
+            <a:picLocks noChangeAspect="1"/>
+          </p:cNvPicPr>
+          <p:nvPr/>
+        </p:nvPicPr>
+        <p:blipFill>
+          <a:blip r:embed="rId2">
+            <a:extLst>
+              <a:ext uri="{28A0092B-C50C-407E-A947-70E740481C1C}">
+                <a14:useLocalDpi xmlns:a14="http://schemas.microsoft.com/office/drawing/2010/main" val="0"/>
+              </a:ext>
+            </a:extLst>
+          </a:blip>
+          <a:stretch>
+            <a:fillRect/>
+          </a:stretch>
+        </p:blipFill>
+        <p:spPr>
+          <a:xfrm>
+            <a:off x="5978305" y="857873"/>
+            <a:ext cx="5797649" cy="5289430"/>
+          </a:xfrm>
+          <a:prstGeom prst="rect">
+            <a:avLst/>
+          </a:prstGeom>
+        </p:spPr>
+      </p:pic>
+      <p:sp>
+        <p:nvSpPr>
+          <p:cNvPr id="10" name="Textfeld 9">
+            <a:extLst>
+              <a:ext uri="{FF2B5EF4-FFF2-40B4-BE49-F238E27FC236}">
+                <a16:creationId xmlns:a16="http://schemas.microsoft.com/office/drawing/2014/main" id="{3BE16239-1F16-68AE-0F57-A3946EFBB65B}"/>
+              </a:ext>
+            </a:extLst>
+          </p:cNvPr>
+          <p:cNvSpPr txBox="1"/>
+          <p:nvPr/>
+        </p:nvSpPr>
+        <p:spPr>
+          <a:xfrm>
+            <a:off x="6096000" y="5105227"/>
+            <a:ext cx="736099" cy="369332"/>
+          </a:xfrm>
+          <a:prstGeom prst="rect">
+            <a:avLst/>
+          </a:prstGeom>
+          <a:noFill/>
+        </p:spPr>
+        <p:txBody>
+          <a:bodyPr wrap="none" rtlCol="0">
+            <a:spAutoFit/>
+          </a:bodyPr>
+          <a:lstStyle/>
+          <a:p>
+            <a:r>
+              <a:rPr lang="de-DE" dirty="0" err="1">
+                <a:latin typeface="Courier New" panose="02070309020205020404" pitchFamily="49" charset="0"/>
+                <a:cs typeface="Courier New" panose="02070309020205020404" pitchFamily="49" charset="0"/>
+              </a:rPr>
+              <a:t>stay</a:t>
+            </a:r>
+            <a:endParaRPr lang="de-DE" dirty="0">
+              <a:latin typeface="Courier New" panose="02070309020205020404" pitchFamily="49" charset="0"/>
+              <a:cs typeface="Courier New" panose="02070309020205020404" pitchFamily="49" charset="0"/>
+            </a:endParaRPr>
+          </a:p>
+        </p:txBody>
+      </p:sp>
+      <p:sp>
+        <p:nvSpPr>
+          <p:cNvPr id="11" name="Textfeld 10">
+            <a:extLst>
+              <a:ext uri="{FF2B5EF4-FFF2-40B4-BE49-F238E27FC236}">
+                <a16:creationId xmlns:a16="http://schemas.microsoft.com/office/drawing/2014/main" id="{75587D1E-BB4D-2FFE-382F-9A73D4BE4336}"/>
+              </a:ext>
+            </a:extLst>
+          </p:cNvPr>
+          <p:cNvSpPr txBox="1"/>
+          <p:nvPr/>
+        </p:nvSpPr>
+        <p:spPr>
+          <a:xfrm>
+            <a:off x="7161042" y="5105227"/>
+            <a:ext cx="1011815" cy="369332"/>
+          </a:xfrm>
+          <a:prstGeom prst="rect">
+            <a:avLst/>
+          </a:prstGeom>
+          <a:noFill/>
+        </p:spPr>
+        <p:txBody>
+          <a:bodyPr wrap="none" rtlCol="0">
+            <a:spAutoFit/>
+          </a:bodyPr>
+          <a:lstStyle/>
+          <a:p>
+            <a:r>
+              <a:rPr lang="de-DE" dirty="0" err="1">
+                <a:latin typeface="Courier New" panose="02070309020205020404" pitchFamily="49" charset="0"/>
+                <a:cs typeface="Courier New" panose="02070309020205020404" pitchFamily="49" charset="0"/>
+              </a:rPr>
+              <a:t>move</a:t>
+            </a:r>
+            <a:r>
+              <a:rPr lang="de-DE" dirty="0">
+                <a:latin typeface="Courier New" panose="02070309020205020404" pitchFamily="49" charset="0"/>
+                <a:cs typeface="Courier New" panose="02070309020205020404" pitchFamily="49" charset="0"/>
+              </a:rPr>
+              <a:t> N</a:t>
+            </a:r>
+          </a:p>
+        </p:txBody>
+      </p:sp>
+      <p:sp>
+        <p:nvSpPr>
+          <p:cNvPr id="12" name="Textfeld 11">
+            <a:extLst>
+              <a:ext uri="{FF2B5EF4-FFF2-40B4-BE49-F238E27FC236}">
+                <a16:creationId xmlns:a16="http://schemas.microsoft.com/office/drawing/2014/main" id="{ADDA3C6D-4D64-984D-082E-A43517FF916D}"/>
+              </a:ext>
+            </a:extLst>
+          </p:cNvPr>
+          <p:cNvSpPr txBox="1"/>
+          <p:nvPr/>
+        </p:nvSpPr>
+        <p:spPr>
+          <a:xfrm>
+            <a:off x="8381661" y="5105227"/>
+            <a:ext cx="1011815" cy="369332"/>
+          </a:xfrm>
+          <a:prstGeom prst="rect">
+            <a:avLst/>
+          </a:prstGeom>
+          <a:noFill/>
+        </p:spPr>
+        <p:txBody>
+          <a:bodyPr wrap="none" rtlCol="0">
+            <a:spAutoFit/>
+          </a:bodyPr>
+          <a:lstStyle/>
+          <a:p>
+            <a:r>
+              <a:rPr lang="de-DE" dirty="0" err="1">
+                <a:latin typeface="Courier New" panose="02070309020205020404" pitchFamily="49" charset="0"/>
+                <a:cs typeface="Courier New" panose="02070309020205020404" pitchFamily="49" charset="0"/>
+              </a:rPr>
+              <a:t>move</a:t>
+            </a:r>
+            <a:r>
+              <a:rPr lang="de-DE" dirty="0">
+                <a:latin typeface="Courier New" panose="02070309020205020404" pitchFamily="49" charset="0"/>
+                <a:cs typeface="Courier New" panose="02070309020205020404" pitchFamily="49" charset="0"/>
+              </a:rPr>
+              <a:t> E</a:t>
+            </a:r>
+          </a:p>
+        </p:txBody>
+      </p:sp>
+      <p:sp>
+        <p:nvSpPr>
+          <p:cNvPr id="13" name="Textfeld 12">
+            <a:extLst>
+              <a:ext uri="{FF2B5EF4-FFF2-40B4-BE49-F238E27FC236}">
+                <a16:creationId xmlns:a16="http://schemas.microsoft.com/office/drawing/2014/main" id="{97E61C76-8072-88C4-6EBC-CB651B477053}"/>
+              </a:ext>
+            </a:extLst>
+          </p:cNvPr>
+          <p:cNvSpPr txBox="1"/>
+          <p:nvPr/>
+        </p:nvSpPr>
+        <p:spPr>
+          <a:xfrm>
+            <a:off x="9613021" y="5105227"/>
+            <a:ext cx="1011815" cy="369332"/>
+          </a:xfrm>
+          <a:prstGeom prst="rect">
+            <a:avLst/>
+          </a:prstGeom>
+          <a:noFill/>
+        </p:spPr>
+        <p:txBody>
+          <a:bodyPr wrap="none" rtlCol="0">
+            <a:spAutoFit/>
+          </a:bodyPr>
+          <a:lstStyle/>
+          <a:p>
+            <a:r>
+              <a:rPr lang="de-DE" dirty="0" err="1">
+                <a:latin typeface="Courier New" panose="02070309020205020404" pitchFamily="49" charset="0"/>
+                <a:cs typeface="Courier New" panose="02070309020205020404" pitchFamily="49" charset="0"/>
+              </a:rPr>
+              <a:t>move</a:t>
+            </a:r>
+            <a:r>
+              <a:rPr lang="de-DE" dirty="0">
+                <a:latin typeface="Courier New" panose="02070309020205020404" pitchFamily="49" charset="0"/>
+                <a:cs typeface="Courier New" panose="02070309020205020404" pitchFamily="49" charset="0"/>
+              </a:rPr>
+              <a:t> S</a:t>
+            </a:r>
+          </a:p>
+        </p:txBody>
+      </p:sp>
+      <p:sp>
+        <p:nvSpPr>
+          <p:cNvPr id="14" name="Textfeld 13">
+            <a:extLst>
+              <a:ext uri="{FF2B5EF4-FFF2-40B4-BE49-F238E27FC236}">
+                <a16:creationId xmlns:a16="http://schemas.microsoft.com/office/drawing/2014/main" id="{E12D5DC5-7A66-E0FC-B75F-AB1E87413F17}"/>
+              </a:ext>
+            </a:extLst>
+          </p:cNvPr>
+          <p:cNvSpPr txBox="1"/>
+          <p:nvPr/>
+        </p:nvSpPr>
+        <p:spPr>
+          <a:xfrm>
+            <a:off x="10744365" y="5105227"/>
+            <a:ext cx="1011815" cy="369332"/>
+          </a:xfrm>
+          <a:prstGeom prst="rect">
+            <a:avLst/>
+          </a:prstGeom>
+          <a:noFill/>
+        </p:spPr>
+        <p:txBody>
+          <a:bodyPr wrap="none" rtlCol="0">
+            <a:spAutoFit/>
+          </a:bodyPr>
+          <a:lstStyle/>
+          <a:p>
+            <a:r>
+              <a:rPr lang="de-DE" dirty="0" err="1">
+                <a:latin typeface="Courier New" panose="02070309020205020404" pitchFamily="49" charset="0"/>
+                <a:cs typeface="Courier New" panose="02070309020205020404" pitchFamily="49" charset="0"/>
+              </a:rPr>
+              <a:t>move</a:t>
+            </a:r>
+            <a:r>
+              <a:rPr lang="de-DE" dirty="0">
+                <a:latin typeface="Courier New" panose="02070309020205020404" pitchFamily="49" charset="0"/>
+                <a:cs typeface="Courier New" panose="02070309020205020404" pitchFamily="49" charset="0"/>
+              </a:rPr>
+              <a:t> W</a:t>
+            </a:r>
+          </a:p>
+        </p:txBody>
+      </p:sp>
+      <p:sp>
+        <p:nvSpPr>
+          <p:cNvPr id="15" name="Textfeld 14">
+            <a:extLst>
+              <a:ext uri="{FF2B5EF4-FFF2-40B4-BE49-F238E27FC236}">
+                <a16:creationId xmlns:a16="http://schemas.microsoft.com/office/drawing/2014/main" id="{F1353E1B-0D72-EB8B-A6A2-A31D3D463054}"/>
+              </a:ext>
+            </a:extLst>
+          </p:cNvPr>
+          <p:cNvSpPr txBox="1"/>
+          <p:nvPr/>
+        </p:nvSpPr>
+        <p:spPr>
+          <a:xfrm>
+            <a:off x="6025042" y="1356282"/>
+            <a:ext cx="1149674" cy="369332"/>
+          </a:xfrm>
+          <a:prstGeom prst="rect">
+            <a:avLst/>
+          </a:prstGeom>
+          <a:noFill/>
+        </p:spPr>
+        <p:txBody>
+          <a:bodyPr wrap="none" rtlCol="0">
+            <a:spAutoFit/>
+          </a:bodyPr>
+          <a:lstStyle/>
+          <a:p>
+            <a:r>
+              <a:rPr lang="de-DE" dirty="0">
+                <a:latin typeface="Courier New" panose="02070309020205020404" pitchFamily="49" charset="0"/>
+                <a:cs typeface="Courier New" panose="02070309020205020404" pitchFamily="49" charset="0"/>
+              </a:rPr>
+              <a:t>on </a:t>
+            </a:r>
+            <a:r>
+              <a:rPr lang="de-DE" dirty="0" err="1">
+                <a:latin typeface="Courier New" panose="02070309020205020404" pitchFamily="49" charset="0"/>
+                <a:cs typeface="Courier New" panose="02070309020205020404" pitchFamily="49" charset="0"/>
+              </a:rPr>
+              <a:t>food</a:t>
+            </a:r>
+            <a:endParaRPr lang="de-DE" dirty="0">
+              <a:latin typeface="Courier New" panose="02070309020205020404" pitchFamily="49" charset="0"/>
+              <a:cs typeface="Courier New" panose="02070309020205020404" pitchFamily="49" charset="0"/>
+            </a:endParaRPr>
+          </a:p>
+        </p:txBody>
+      </p:sp>
+      <p:sp>
+        <p:nvSpPr>
+          <p:cNvPr id="16" name="Textfeld 15">
+            <a:extLst>
+              <a:ext uri="{FF2B5EF4-FFF2-40B4-BE49-F238E27FC236}">
+                <a16:creationId xmlns:a16="http://schemas.microsoft.com/office/drawing/2014/main" id="{C330CB92-1783-94C1-A8C6-EFE912692C6F}"/>
+              </a:ext>
+            </a:extLst>
+          </p:cNvPr>
+          <p:cNvSpPr txBox="1"/>
+          <p:nvPr/>
+        </p:nvSpPr>
+        <p:spPr>
+          <a:xfrm>
+            <a:off x="7281837" y="1356282"/>
+            <a:ext cx="1011815" cy="369332"/>
+          </a:xfrm>
+          <a:prstGeom prst="rect">
+            <a:avLst/>
+          </a:prstGeom>
+          <a:noFill/>
+        </p:spPr>
+        <p:txBody>
+          <a:bodyPr wrap="none" rtlCol="0">
+            <a:spAutoFit/>
+          </a:bodyPr>
+          <a:lstStyle/>
+          <a:p>
+            <a:r>
+              <a:rPr lang="de-DE" dirty="0" err="1">
+                <a:latin typeface="Courier New" panose="02070309020205020404" pitchFamily="49" charset="0"/>
+                <a:cs typeface="Courier New" panose="02070309020205020404" pitchFamily="49" charset="0"/>
+              </a:rPr>
+              <a:t>food</a:t>
+            </a:r>
+            <a:r>
+              <a:rPr lang="de-DE" dirty="0">
+                <a:latin typeface="Courier New" panose="02070309020205020404" pitchFamily="49" charset="0"/>
+                <a:cs typeface="Courier New" panose="02070309020205020404" pitchFamily="49" charset="0"/>
+              </a:rPr>
+              <a:t> N</a:t>
+            </a:r>
+          </a:p>
+        </p:txBody>
+      </p:sp>
+      <p:sp>
+        <p:nvSpPr>
+          <p:cNvPr id="17" name="Textfeld 16">
+            <a:extLst>
+              <a:ext uri="{FF2B5EF4-FFF2-40B4-BE49-F238E27FC236}">
+                <a16:creationId xmlns:a16="http://schemas.microsoft.com/office/drawing/2014/main" id="{942A1F51-9153-0948-FD60-C38605FA4317}"/>
+              </a:ext>
+            </a:extLst>
+          </p:cNvPr>
+          <p:cNvSpPr txBox="1"/>
+          <p:nvPr/>
+        </p:nvSpPr>
+        <p:spPr>
+          <a:xfrm>
+            <a:off x="8455099" y="1356282"/>
+            <a:ext cx="1011815" cy="369332"/>
+          </a:xfrm>
+          <a:prstGeom prst="rect">
+            <a:avLst/>
+          </a:prstGeom>
+          <a:noFill/>
+        </p:spPr>
+        <p:txBody>
+          <a:bodyPr wrap="none" rtlCol="0">
+            <a:spAutoFit/>
+          </a:bodyPr>
+          <a:lstStyle/>
+          <a:p>
+            <a:r>
+              <a:rPr lang="de-DE" dirty="0" err="1">
+                <a:latin typeface="Courier New" panose="02070309020205020404" pitchFamily="49" charset="0"/>
+                <a:cs typeface="Courier New" panose="02070309020205020404" pitchFamily="49" charset="0"/>
+              </a:rPr>
+              <a:t>food</a:t>
+            </a:r>
+            <a:r>
+              <a:rPr lang="de-DE" dirty="0">
+                <a:latin typeface="Courier New" panose="02070309020205020404" pitchFamily="49" charset="0"/>
+                <a:cs typeface="Courier New" panose="02070309020205020404" pitchFamily="49" charset="0"/>
+              </a:rPr>
+              <a:t> E</a:t>
+            </a:r>
+          </a:p>
+        </p:txBody>
+      </p:sp>
+      <p:sp>
+        <p:nvSpPr>
+          <p:cNvPr id="18" name="Textfeld 17">
+            <a:extLst>
+              <a:ext uri="{FF2B5EF4-FFF2-40B4-BE49-F238E27FC236}">
+                <a16:creationId xmlns:a16="http://schemas.microsoft.com/office/drawing/2014/main" id="{0654D465-8DF4-5FFE-6158-6FAD28C5C9C3}"/>
+              </a:ext>
+            </a:extLst>
+          </p:cNvPr>
+          <p:cNvSpPr txBox="1"/>
+          <p:nvPr/>
+        </p:nvSpPr>
+        <p:spPr>
+          <a:xfrm>
+            <a:off x="9597184" y="1356282"/>
+            <a:ext cx="1011815" cy="369332"/>
+          </a:xfrm>
+          <a:prstGeom prst="rect">
+            <a:avLst/>
+          </a:prstGeom>
+          <a:noFill/>
+        </p:spPr>
+        <p:txBody>
+          <a:bodyPr wrap="none" rtlCol="0">
+            <a:spAutoFit/>
+          </a:bodyPr>
+          <a:lstStyle/>
+          <a:p>
+            <a:r>
+              <a:rPr lang="de-DE" dirty="0" err="1">
+                <a:latin typeface="Courier New" panose="02070309020205020404" pitchFamily="49" charset="0"/>
+                <a:cs typeface="Courier New" panose="02070309020205020404" pitchFamily="49" charset="0"/>
+              </a:rPr>
+              <a:t>food</a:t>
+            </a:r>
+            <a:r>
+              <a:rPr lang="de-DE" dirty="0">
+                <a:latin typeface="Courier New" panose="02070309020205020404" pitchFamily="49" charset="0"/>
+                <a:cs typeface="Courier New" panose="02070309020205020404" pitchFamily="49" charset="0"/>
+              </a:rPr>
+              <a:t> S</a:t>
+            </a:r>
+          </a:p>
+        </p:txBody>
+      </p:sp>
+      <p:sp>
+        <p:nvSpPr>
+          <p:cNvPr id="19" name="Textfeld 18">
+            <a:extLst>
+              <a:ext uri="{FF2B5EF4-FFF2-40B4-BE49-F238E27FC236}">
+                <a16:creationId xmlns:a16="http://schemas.microsoft.com/office/drawing/2014/main" id="{BD475DCA-C9D5-BE70-081A-B8D088EFAD7F}"/>
+              </a:ext>
+            </a:extLst>
+          </p:cNvPr>
+          <p:cNvSpPr txBox="1"/>
+          <p:nvPr/>
+        </p:nvSpPr>
+        <p:spPr>
+          <a:xfrm>
+            <a:off x="10686569" y="1356282"/>
+            <a:ext cx="1011815" cy="369332"/>
+          </a:xfrm>
+          <a:prstGeom prst="rect">
+            <a:avLst/>
+          </a:prstGeom>
+          <a:noFill/>
+        </p:spPr>
+        <p:txBody>
+          <a:bodyPr wrap="none" rtlCol="0">
+            <a:spAutoFit/>
+          </a:bodyPr>
+          <a:lstStyle/>
+          <a:p>
+            <a:r>
+              <a:rPr lang="de-DE" dirty="0" err="1">
+                <a:latin typeface="Courier New" panose="02070309020205020404" pitchFamily="49" charset="0"/>
+                <a:cs typeface="Courier New" panose="02070309020205020404" pitchFamily="49" charset="0"/>
+              </a:rPr>
+              <a:t>food</a:t>
+            </a:r>
+            <a:r>
+              <a:rPr lang="de-DE" dirty="0">
+                <a:latin typeface="Courier New" panose="02070309020205020404" pitchFamily="49" charset="0"/>
+                <a:cs typeface="Courier New" panose="02070309020205020404" pitchFamily="49" charset="0"/>
+              </a:rPr>
+              <a:t> W</a:t>
+            </a:r>
+          </a:p>
+        </p:txBody>
+      </p:sp>
+    </p:spTree>
+    <p:extLst>
+      <p:ext uri="{BB962C8B-B14F-4D97-AF65-F5344CB8AC3E}">
+        <p14:creationId xmlns:p14="http://schemas.microsoft.com/office/powerpoint/2010/main" val="2547762634"/>
+      </p:ext>
+    </p:extLst>
+  </p:cSld>
+  <p:clrMapOvr>
+    <a:masterClrMapping/>
+  </p:clrMapOvr>
+</p:sld>
+</file>
+
+<file path=ppt/slides/slide15.xml><?xml version="1.0" encoding="utf-8"?>
+<p:sld xmlns:a="http://schemas.openxmlformats.org/drawingml/2006/main" xmlns:r="http://schemas.openxmlformats.org/officeDocument/2006/relationships" xmlns:p="http://schemas.openxmlformats.org/presentationml/2006/main">
+  <p:cSld>
+    <p:spTree>
+      <p:nvGrpSpPr>
+        <p:cNvPr id="1" name="">
+          <a:extLst>
+            <a:ext uri="{FF2B5EF4-FFF2-40B4-BE49-F238E27FC236}">
+              <a16:creationId xmlns:a16="http://schemas.microsoft.com/office/drawing/2014/main" id="{C192ACF1-A625-E91A-426D-0FB1CB25D58A}"/>
+            </a:ext>
+          </a:extLst>
+        </p:cNvPr>
+        <p:cNvGrpSpPr/>
+        <p:nvPr/>
+      </p:nvGrpSpPr>
+      <p:grpSpPr>
+        <a:xfrm>
+          <a:off x="0" y="0"/>
+          <a:ext cx="0" cy="0"/>
+          <a:chOff x="0" y="0"/>
+          <a:chExt cx="0" cy="0"/>
+        </a:xfrm>
+      </p:grpSpPr>
+      <p:sp>
+        <p:nvSpPr>
+          <p:cNvPr id="2" name="Freihandform: Form 1">
+            <a:extLst>
+              <a:ext uri="{FF2B5EF4-FFF2-40B4-BE49-F238E27FC236}">
+                <a16:creationId xmlns:a16="http://schemas.microsoft.com/office/drawing/2014/main" id="{6C65E094-D373-3EC1-CA69-7C3E3FB3F81F}"/>
+              </a:ext>
+            </a:extLst>
+          </p:cNvPr>
+          <p:cNvSpPr/>
+          <p:nvPr/>
+        </p:nvSpPr>
+        <p:spPr>
+          <a:xfrm flipH="1">
+            <a:off x="8657661" y="-2930196"/>
+            <a:ext cx="6300782" cy="3481390"/>
+          </a:xfrm>
+          <a:custGeom>
+            <a:avLst/>
+            <a:gdLst>
+              <a:gd name="csX0" fmla="*/ 0 w 6300782"/>
+              <a:gd name="csY0" fmla="*/ 0 h 3481390"/>
+              <a:gd name="csX1" fmla="*/ 4560087 w 6300782"/>
+              <a:gd name="csY1" fmla="*/ 0 h 3481390"/>
+              <a:gd name="csX2" fmla="*/ 4562473 w 6300782"/>
+              <a:gd name="csY2" fmla="*/ 0 h 3481390"/>
+              <a:gd name="csX3" fmla="*/ 4562473 w 6300782"/>
+              <a:gd name="csY3" fmla="*/ 121 h 3481390"/>
+              <a:gd name="csX4" fmla="*/ 4738063 w 6300782"/>
+              <a:gd name="csY4" fmla="*/ 8987 h 3481390"/>
+              <a:gd name="csX5" fmla="*/ 6300782 w 6300782"/>
+              <a:gd name="csY5" fmla="*/ 1740695 h 3481390"/>
+              <a:gd name="csX6" fmla="*/ 4738063 w 6300782"/>
+              <a:gd name="csY6" fmla="*/ 3472403 h 3481390"/>
+              <a:gd name="csX7" fmla="*/ 4562473 w 6300782"/>
+              <a:gd name="csY7" fmla="*/ 3481270 h 3481390"/>
+              <a:gd name="csX8" fmla="*/ 4562473 w 6300782"/>
+              <a:gd name="csY8" fmla="*/ 3481390 h 3481390"/>
+              <a:gd name="csX9" fmla="*/ 4560087 w 6300782"/>
+              <a:gd name="csY9" fmla="*/ 3481390 h 3481390"/>
+              <a:gd name="csX10" fmla="*/ 0 w 6300782"/>
+              <a:gd name="csY10" fmla="*/ 3481390 h 3481390"/>
+            </a:gdLst>
+            <a:ahLst/>
+            <a:cxnLst>
+              <a:cxn ang="0">
+                <a:pos x="csX0" y="csY0"/>
+              </a:cxn>
+              <a:cxn ang="0">
+                <a:pos x="csX1" y="csY1"/>
+              </a:cxn>
+              <a:cxn ang="0">
+                <a:pos x="csX2" y="csY2"/>
+              </a:cxn>
+              <a:cxn ang="0">
+                <a:pos x="csX3" y="csY3"/>
+              </a:cxn>
+              <a:cxn ang="0">
+                <a:pos x="csX4" y="csY4"/>
+              </a:cxn>
+              <a:cxn ang="0">
+                <a:pos x="csX5" y="csY5"/>
+              </a:cxn>
+              <a:cxn ang="0">
+                <a:pos x="csX6" y="csY6"/>
+              </a:cxn>
+              <a:cxn ang="0">
+                <a:pos x="csX7" y="csY7"/>
+              </a:cxn>
+              <a:cxn ang="0">
+                <a:pos x="csX8" y="csY8"/>
+              </a:cxn>
+              <a:cxn ang="0">
+                <a:pos x="csX9" y="csY9"/>
+              </a:cxn>
+              <a:cxn ang="0">
+                <a:pos x="csX10" y="csY10"/>
+              </a:cxn>
+            </a:cxnLst>
+            <a:rect l="l" t="t" r="r" b="b"/>
+            <a:pathLst>
+              <a:path w="6300782" h="3481390">
+                <a:moveTo>
+                  <a:pt x="0" y="0"/>
+                </a:moveTo>
+                <a:lnTo>
+                  <a:pt x="4560087" y="0"/>
+                </a:lnTo>
+                <a:lnTo>
+                  <a:pt x="4562473" y="0"/>
+                </a:lnTo>
+                <a:lnTo>
+                  <a:pt x="4562473" y="121"/>
+                </a:lnTo>
+                <a:lnTo>
+                  <a:pt x="4738063" y="8987"/>
+                </a:lnTo>
+                <a:cubicBezTo>
+                  <a:pt x="5615819" y="98128"/>
+                  <a:pt x="6300782" y="839421"/>
+                  <a:pt x="6300782" y="1740695"/>
+                </a:cubicBezTo>
+                <a:cubicBezTo>
+                  <a:pt x="6300782" y="2641969"/>
+                  <a:pt x="5615819" y="3383262"/>
+                  <a:pt x="4738063" y="3472403"/>
+                </a:cubicBezTo>
+                <a:lnTo>
+                  <a:pt x="4562473" y="3481270"/>
+                </a:lnTo>
+                <a:lnTo>
+                  <a:pt x="4562473" y="3481390"/>
+                </a:lnTo>
+                <a:lnTo>
+                  <a:pt x="4560087" y="3481390"/>
+                </a:lnTo>
+                <a:lnTo>
+                  <a:pt x="0" y="3481390"/>
+                </a:lnTo>
+                <a:close/>
+              </a:path>
+            </a:pathLst>
+          </a:custGeom>
+          <a:solidFill>
+            <a:srgbClr val="E3E9EA"/>
+          </a:solidFill>
+          <a:ln>
+            <a:noFill/>
+          </a:ln>
+        </p:spPr>
+        <p:style>
+          <a:lnRef idx="2">
+            <a:schemeClr val="accent1">
+              <a:shade val="15000"/>
+            </a:schemeClr>
+          </a:lnRef>
+          <a:fillRef idx="1">
+            <a:schemeClr val="accent1"/>
+          </a:fillRef>
+          <a:effectRef idx="0">
+            <a:schemeClr val="accent1"/>
+          </a:effectRef>
+          <a:fontRef idx="minor">
+            <a:schemeClr val="lt1"/>
+          </a:fontRef>
+        </p:style>
+        <p:txBody>
+          <a:bodyPr lIns="0" tIns="0" rIns="0" bIns="0" rtlCol="0" anchor="ctr"/>
+          <a:lstStyle/>
+          <a:p>
+            <a:pPr algn="ctr"/>
+            <a:endParaRPr lang="de-DE" sz="1600" b="1">
+              <a:solidFill>
+                <a:schemeClr val="tx1"/>
+              </a:solidFill>
+            </a:endParaRPr>
+          </a:p>
+        </p:txBody>
+      </p:sp>
+      <p:sp>
+        <p:nvSpPr>
+          <p:cNvPr id="3" name="Textfeld 2">
+            <a:extLst>
+              <a:ext uri="{FF2B5EF4-FFF2-40B4-BE49-F238E27FC236}">
+                <a16:creationId xmlns:a16="http://schemas.microsoft.com/office/drawing/2014/main" id="{D27CF4BF-86ED-A0D7-3D85-662FDB7CC8DF}"/>
+              </a:ext>
+            </a:extLst>
+          </p:cNvPr>
+          <p:cNvSpPr txBox="1"/>
+          <p:nvPr/>
+        </p:nvSpPr>
+        <p:spPr>
+          <a:xfrm>
+            <a:off x="10287922" y="153126"/>
+            <a:ext cx="1904078" cy="461665"/>
+          </a:xfrm>
+          <a:prstGeom prst="rect">
+            <a:avLst/>
+          </a:prstGeom>
+          <a:noFill/>
+        </p:spPr>
+        <p:txBody>
+          <a:bodyPr wrap="square" rtlCol="0">
+            <a:spAutoFit/>
+          </a:bodyPr>
+          <a:lstStyle/>
+          <a:p>
+            <a:pPr algn="ctr"/>
+            <a:r>
+              <a:rPr lang="de-DE" sz="2400" dirty="0">
+                <a:solidFill>
+                  <a:srgbClr val="00336E"/>
+                </a:solidFill>
+                <a:ea typeface="Cormorant Garamond" pitchFamily="2" charset="0"/>
+                <a:cs typeface="Cormorant Garamond" pitchFamily="2" charset="0"/>
+              </a:rPr>
+              <a:t>First </a:t>
+            </a:r>
+            <a:r>
+              <a:rPr lang="de-DE" sz="2400" dirty="0" err="1">
+                <a:solidFill>
+                  <a:srgbClr val="00336E"/>
+                </a:solidFill>
+                <a:ea typeface="Cormorant Garamond" pitchFamily="2" charset="0"/>
+                <a:cs typeface="Cormorant Garamond" pitchFamily="2" charset="0"/>
+              </a:rPr>
+              <a:t>results</a:t>
+            </a:r>
+            <a:endParaRPr lang="de-DE" sz="2400" b="1" dirty="0">
+              <a:solidFill>
+                <a:srgbClr val="00336E"/>
+              </a:solidFill>
+              <a:ea typeface="Cormorant Garamond" pitchFamily="2" charset="0"/>
+              <a:cs typeface="Cormorant Garamond" pitchFamily="2" charset="0"/>
+            </a:endParaRPr>
+          </a:p>
+        </p:txBody>
+      </p:sp>
+      <p:sp>
+        <p:nvSpPr>
+          <p:cNvPr id="7" name="Textfeld 6">
+            <a:extLst>
+              <a:ext uri="{FF2B5EF4-FFF2-40B4-BE49-F238E27FC236}">
+                <a16:creationId xmlns:a16="http://schemas.microsoft.com/office/drawing/2014/main" id="{5375FF69-E05C-B6D4-58CC-B60D0A366EE3}"/>
+              </a:ext>
+            </a:extLst>
+          </p:cNvPr>
+          <p:cNvSpPr txBox="1"/>
+          <p:nvPr/>
+        </p:nvSpPr>
+        <p:spPr>
+          <a:xfrm>
+            <a:off x="304129" y="957362"/>
+            <a:ext cx="5674176" cy="1285737"/>
+          </a:xfrm>
+          <a:prstGeom prst="rect">
+            <a:avLst/>
+          </a:prstGeom>
+          <a:noFill/>
+        </p:spPr>
+        <p:txBody>
+          <a:bodyPr wrap="square">
+            <a:spAutoFit/>
+          </a:bodyPr>
+          <a:lstStyle/>
+          <a:p>
+            <a:pPr>
+              <a:lnSpc>
+                <a:spcPct val="115000"/>
+              </a:lnSpc>
+              <a:spcAft>
+                <a:spcPts val="1000"/>
+              </a:spcAft>
+              <a:buNone/>
+            </a:pPr>
+            <a:r>
+              <a:rPr lang="en-US" sz="1800" dirty="0">
+                <a:effectLst/>
+                <a:ea typeface="MS Mincho" panose="02020609040205080304" pitchFamily="49" charset="-128"/>
+                <a:cs typeface="Times New Roman" panose="02020603050405020304" pitchFamily="18" charset="0"/>
+              </a:rPr>
+              <a:t>Optimal solution?</a:t>
+            </a:r>
+          </a:p>
+          <a:p>
+            <a:pPr>
+              <a:lnSpc>
+                <a:spcPct val="115000"/>
+              </a:lnSpc>
+              <a:spcAft>
+                <a:spcPts val="1000"/>
+              </a:spcAft>
+              <a:buNone/>
+            </a:pPr>
+            <a:endParaRPr lang="en-US" dirty="0">
+              <a:ea typeface="MS Mincho" panose="02020609040205080304" pitchFamily="49" charset="-128"/>
+              <a:cs typeface="Times New Roman" panose="02020603050405020304" pitchFamily="18" charset="0"/>
+            </a:endParaRPr>
+          </a:p>
+          <a:p>
+            <a:pPr>
+              <a:lnSpc>
+                <a:spcPct val="115000"/>
+              </a:lnSpc>
+              <a:spcAft>
+                <a:spcPts val="1000"/>
+              </a:spcAft>
+              <a:buNone/>
+            </a:pPr>
+            <a:r>
+              <a:rPr lang="en-US" sz="1800" dirty="0">
+                <a:effectLst/>
+                <a:ea typeface="MS Mincho" panose="02020609040205080304" pitchFamily="49" charset="-128"/>
+                <a:cs typeface="Times New Roman" panose="02020603050405020304" pitchFamily="18" charset="0"/>
+              </a:rPr>
+              <a:t>No! </a:t>
+            </a:r>
+            <a:r>
+              <a:rPr lang="en-US" dirty="0">
+                <a:ea typeface="MS Mincho" panose="02020609040205080304" pitchFamily="49" charset="-128"/>
+                <a:cs typeface="Times New Roman" panose="02020603050405020304" pitchFamily="18" charset="0"/>
+              </a:rPr>
+              <a:t>Why?</a:t>
+            </a:r>
+            <a:endParaRPr lang="de-DE" sz="1800" dirty="0">
+              <a:effectLst/>
+              <a:ea typeface="MS Mincho" panose="02020609040205080304" pitchFamily="49" charset="-128"/>
+              <a:cs typeface="Times New Roman" panose="02020603050405020304" pitchFamily="18" charset="0"/>
+            </a:endParaRPr>
+          </a:p>
+        </p:txBody>
+      </p:sp>
+      <p:pic>
+        <p:nvPicPr>
+          <p:cNvPr id="5" name="Grafik 4">
+            <a:extLst>
+              <a:ext uri="{FF2B5EF4-FFF2-40B4-BE49-F238E27FC236}">
+                <a16:creationId xmlns:a16="http://schemas.microsoft.com/office/drawing/2014/main" id="{5A6EBD22-5AEA-EC11-6FD8-B3D2E33611D7}"/>
+              </a:ext>
+            </a:extLst>
+          </p:cNvPr>
+          <p:cNvPicPr>
+            <a:picLocks noChangeAspect="1"/>
+          </p:cNvPicPr>
+          <p:nvPr/>
+        </p:nvPicPr>
+        <p:blipFill>
+          <a:blip r:embed="rId2">
+            <a:extLst>
+              <a:ext uri="{28A0092B-C50C-407E-A947-70E740481C1C}">
+                <a14:useLocalDpi xmlns:a14="http://schemas.microsoft.com/office/drawing/2010/main" val="0"/>
+              </a:ext>
+            </a:extLst>
+          </a:blip>
+          <a:stretch>
+            <a:fillRect/>
+          </a:stretch>
+        </p:blipFill>
+        <p:spPr>
+          <a:xfrm>
+            <a:off x="4381500" y="1157736"/>
+            <a:ext cx="7152505" cy="4742902"/>
+          </a:xfrm>
+          <a:prstGeom prst="rect">
+            <a:avLst/>
+          </a:prstGeom>
+        </p:spPr>
+      </p:pic>
+    </p:spTree>
+    <p:extLst>
+      <p:ext uri="{BB962C8B-B14F-4D97-AF65-F5344CB8AC3E}">
+        <p14:creationId xmlns:p14="http://schemas.microsoft.com/office/powerpoint/2010/main" val="2806308508"/>
+      </p:ext>
+    </p:extLst>
+  </p:cSld>
+  <p:clrMapOvr>
+    <a:masterClrMapping/>
+  </p:clrMapOvr>
+  <p:timing>
+    <p:tnLst>
+      <p:par>
+        <p:cTn id="1" dur="indefinite" restart="never" nodeType="tmRoot">
+          <p:childTnLst>
+            <p:seq concurrent="1" nextAc="seek">
+              <p:cTn id="2" dur="indefinite" nodeType="mainSeq">
+                <p:childTnLst>
+                  <p:par>
+                    <p:cTn id="3" fill="hold">
+                      <p:stCondLst>
+                        <p:cond delay="indefinite"/>
+                      </p:stCondLst>
+                      <p:childTnLst>
+                        <p:par>
+                          <p:cTn id="4" fill="hold">
+                            <p:stCondLst>
+                              <p:cond delay="0"/>
+                            </p:stCondLst>
+                            <p:childTnLst>
+                              <p:par>
+                                <p:cTn id="5" presetID="1" presetClass="entr" presetSubtype="0" fill="hold" nodeType="clickEffect">
+                                  <p:stCondLst>
+                                    <p:cond delay="0"/>
+                                  </p:stCondLst>
+                                  <p:childTnLst>
+                                    <p:set>
+                                      <p:cBhvr>
+                                        <p:cTn id="6" dur="1" fill="hold">
+                                          <p:stCondLst>
+                                            <p:cond delay="0"/>
+                                          </p:stCondLst>
+                                        </p:cTn>
+                                        <p:tgtEl>
+                                          <p:spTgt spid="7">
+                                            <p:txEl>
+                                              <p:pRg st="2" end="2"/>
+                                            </p:txEl>
+                                          </p:spTgt>
+                                        </p:tgtEl>
+                                        <p:attrNameLst>
+                                          <p:attrName>style.visibility</p:attrName>
+                                        </p:attrNameLst>
+                                      </p:cBhvr>
+                                      <p:to>
+                                        <p:strVal val="visible"/>
+                                      </p:to>
+                                    </p:set>
+                                  </p:childTnLst>
+                                </p:cTn>
+                              </p:par>
+                            </p:childTnLst>
+                          </p:cTn>
+                        </p:par>
+                      </p:childTnLst>
+                    </p:cTn>
+                  </p:par>
+                </p:childTnLst>
+              </p:cTn>
+              <p:prevCondLst>
+                <p:cond evt="onPrev" delay="0">
+                  <p:tgtEl>
+                    <p:sldTgt/>
+                  </p:tgtEl>
+                </p:cond>
+              </p:prevCondLst>
+              <p:nextCondLst>
+                <p:cond evt="onNext" delay="0">
+                  <p:tgtEl>
+                    <p:sldTgt/>
+                  </p:tgtEl>
+                </p:cond>
+              </p:nextCondLst>
+            </p:seq>
+          </p:childTnLst>
+        </p:cTn>
+      </p:par>
+    </p:tnLst>
+  </p:timing>
+</p:sld>
+</file>
+
+<file path=ppt/slides/slide16.xml><?xml version="1.0" encoding="utf-8"?>
 <p:sld xmlns:a="http://schemas.openxmlformats.org/drawingml/2006/main" xmlns:r="http://schemas.openxmlformats.org/officeDocument/2006/relationships" xmlns:p="http://schemas.openxmlformats.org/presentationml/2006/main">
   <p:cSld>
     <p:spTree>
@@ -3382,7 +5059,7 @@
           <a:p>
             <a:fld id="{001D04CD-A18E-4C48-A0D4-2F175BEDACF1}" type="slidenum">
               <a:rPr lang="de-DE" smtClean="0"/>
-              <a:t>13</a:t>
+              <a:t>16</a:t>
             </a:fld>
             <a:endParaRPr lang="de-DE"/>
           </a:p>
@@ -3401,7 +5078,7 @@
 </p:sld>
 </file>
 
-<file path=ppt/slides/slide14.xml><?xml version="1.0" encoding="utf-8"?>
+<file path=ppt/slides/slide17.xml><?xml version="1.0" encoding="utf-8"?>
 <p:sld xmlns:a="http://schemas.openxmlformats.org/drawingml/2006/main" xmlns:r="http://schemas.openxmlformats.org/officeDocument/2006/relationships" xmlns:p="http://schemas.openxmlformats.org/presentationml/2006/main">
   <p:cSld>
     <p:spTree>
@@ -3914,7 +5591,7 @@
           <a:p>
             <a:fld id="{001D04CD-A18E-4C48-A0D4-2F175BEDACF1}" type="slidenum">
               <a:rPr lang="de-DE" smtClean="0"/>
-              <a:t>14</a:t>
+              <a:t>17</a:t>
             </a:fld>
             <a:endParaRPr lang="de-DE"/>
           </a:p>
@@ -6575,7 +8252,7 @@
         <p:spPr>
           <a:xfrm>
             <a:off x="-11904" y="2045078"/>
-            <a:ext cx="2847973" cy="2677656"/>
+            <a:ext cx="2847973" cy="2308324"/>
           </a:xfrm>
           <a:prstGeom prst="rect">
             <a:avLst/>
@@ -6705,47 +8382,7 @@
           </a:p>
           <a:p>
             <a:pPr algn="ctr"/>
-            <a:r>
-              <a:rPr lang="de-DE" sz="2400" dirty="0">
-                <a:solidFill>
-                  <a:srgbClr val="00336E"/>
-                </a:solidFill>
-                <a:ea typeface="Cormorant Garamond" pitchFamily="2" charset="0"/>
-                <a:cs typeface="Cormorant Garamond" pitchFamily="2" charset="0"/>
-              </a:rPr>
-              <a:t>An </a:t>
-            </a:r>
-            <a:r>
-              <a:rPr lang="de-DE" sz="2400" dirty="0" err="1">
-                <a:solidFill>
-                  <a:srgbClr val="00336E"/>
-                </a:solidFill>
-                <a:ea typeface="Cormorant Garamond" pitchFamily="2" charset="0"/>
-                <a:cs typeface="Cormorant Garamond" pitchFamily="2" charset="0"/>
-              </a:rPr>
-              <a:t>age-old</a:t>
-            </a:r>
-            <a:r>
-              <a:rPr lang="de-DE" sz="2400" dirty="0">
-                <a:solidFill>
-                  <a:srgbClr val="00336E"/>
-                </a:solidFill>
-                <a:ea typeface="Cormorant Garamond" pitchFamily="2" charset="0"/>
-                <a:cs typeface="Cormorant Garamond" pitchFamily="2" charset="0"/>
-              </a:rPr>
-              <a:t> </a:t>
-            </a:r>
-            <a:r>
-              <a:rPr lang="de-DE" sz="2400" dirty="0" err="1">
-                <a:solidFill>
-                  <a:srgbClr val="00336E"/>
-                </a:solidFill>
-                <a:ea typeface="Cormorant Garamond" pitchFamily="2" charset="0"/>
-                <a:cs typeface="Cormorant Garamond" pitchFamily="2" charset="0"/>
-              </a:rPr>
-              <a:t>question</a:t>
-            </a:r>
-            <a:endParaRPr lang="de-DE" sz="2400" dirty="0">
+            <a:endParaRPr lang="de-DE" sz="2400" b="1" dirty="0">
               <a:solidFill>
                 <a:srgbClr val="00336E"/>
               </a:solidFill>

</xml_diff>

<commit_message>
benchmarks and replays are working now
</commit_message>
<xml_diff>
--- a/scicom/skeleton_presentation.pptx
+++ b/scicom/skeleton_presentation.pptx
@@ -5,7 +5,7 @@
     <p:sldMasterId id="2147483672" r:id="rId1"/>
   </p:sldMasterIdLst>
   <p:notesMasterIdLst>
-    <p:notesMasterId r:id="rId22"/>
+    <p:notesMasterId r:id="rId24"/>
   </p:notesMasterIdLst>
   <p:sldIdLst>
     <p:sldId id="256" r:id="rId2"/>
@@ -27,7 +27,9 @@
     <p:sldId id="281" r:id="rId18"/>
     <p:sldId id="282" r:id="rId19"/>
     <p:sldId id="284" r:id="rId20"/>
-    <p:sldId id="268" r:id="rId21"/>
+    <p:sldId id="286" r:id="rId21"/>
+    <p:sldId id="285" r:id="rId22"/>
+    <p:sldId id="268" r:id="rId23"/>
   </p:sldIdLst>
   <p:sldSz cx="12192000" cy="6858000"/>
   <p:notesSz cx="6858000" cy="9144000"/>
@@ -216,7 +218,7 @@
           <a:p>
             <a:fld id="{D45AE30C-70B0-42A3-87DE-9CC4A3E6D756}" type="datetimeFigureOut">
               <a:rPr lang="de-DE" smtClean="0"/>
-              <a:t>26.05.2026</a:t>
+              <a:t>27.05.2026</a:t>
             </a:fld>
             <a:endParaRPr lang="de-DE"/>
           </a:p>
@@ -882,6 +884,114 @@
     <p:extLst>
       <p:ext uri="{BB962C8B-B14F-4D97-AF65-F5344CB8AC3E}">
         <p14:creationId xmlns:p14="http://schemas.microsoft.com/office/powerpoint/2010/main" val="2419741675"/>
+      </p:ext>
+    </p:extLst>
+  </p:cSld>
+  <p:clrMapOvr>
+    <a:masterClrMapping/>
+  </p:clrMapOvr>
+</p:notes>
+</file>
+
+<file path=ppt/notesSlides/notesSlide5.xml><?xml version="1.0" encoding="utf-8"?>
+<p:notes xmlns:a="http://schemas.openxmlformats.org/drawingml/2006/main" xmlns:r="http://schemas.openxmlformats.org/officeDocument/2006/relationships" xmlns:p="http://schemas.openxmlformats.org/presentationml/2006/main">
+  <p:cSld>
+    <p:spTree>
+      <p:nvGrpSpPr>
+        <p:cNvPr id="1" name="">
+          <a:extLst>
+            <a:ext uri="{FF2B5EF4-FFF2-40B4-BE49-F238E27FC236}">
+              <a16:creationId xmlns:a16="http://schemas.microsoft.com/office/drawing/2014/main" id="{9134F01B-DE0E-3C64-9D06-6DCBDD650B15}"/>
+            </a:ext>
+          </a:extLst>
+        </p:cNvPr>
+        <p:cNvGrpSpPr/>
+        <p:nvPr/>
+      </p:nvGrpSpPr>
+      <p:grpSpPr>
+        <a:xfrm>
+          <a:off x="0" y="0"/>
+          <a:ext cx="0" cy="0"/>
+          <a:chOff x="0" y="0"/>
+          <a:chExt cx="0" cy="0"/>
+        </a:xfrm>
+      </p:grpSpPr>
+      <p:sp>
+        <p:nvSpPr>
+          <p:cNvPr id="2" name="Folienbildplatzhalter 1">
+            <a:extLst>
+              <a:ext uri="{FF2B5EF4-FFF2-40B4-BE49-F238E27FC236}">
+                <a16:creationId xmlns:a16="http://schemas.microsoft.com/office/drawing/2014/main" id="{9B359431-5298-F755-9B31-A53A9EBD4155}"/>
+              </a:ext>
+            </a:extLst>
+          </p:cNvPr>
+          <p:cNvSpPr>
+            <a:spLocks noGrp="1" noRot="1" noChangeAspect="1"/>
+          </p:cNvSpPr>
+          <p:nvPr>
+            <p:ph type="sldImg"/>
+          </p:nvPr>
+        </p:nvSpPr>
+        <p:spPr/>
+      </p:sp>
+      <p:sp>
+        <p:nvSpPr>
+          <p:cNvPr id="3" name="Notizenplatzhalter 2">
+            <a:extLst>
+              <a:ext uri="{FF2B5EF4-FFF2-40B4-BE49-F238E27FC236}">
+                <a16:creationId xmlns:a16="http://schemas.microsoft.com/office/drawing/2014/main" id="{5ECD6EA3-CC9E-EB77-CAE5-D712167DE44B}"/>
+              </a:ext>
+            </a:extLst>
+          </p:cNvPr>
+          <p:cNvSpPr>
+            <a:spLocks noGrp="1"/>
+          </p:cNvSpPr>
+          <p:nvPr>
+            <p:ph type="body" idx="1"/>
+          </p:nvPr>
+        </p:nvSpPr>
+        <p:spPr/>
+        <p:txBody>
+          <a:bodyPr/>
+          <a:lstStyle/>
+          <a:p>
+            <a:endParaRPr lang="de-DE" dirty="0"/>
+          </a:p>
+        </p:txBody>
+      </p:sp>
+      <p:sp>
+        <p:nvSpPr>
+          <p:cNvPr id="4" name="Foliennummernplatzhalter 3">
+            <a:extLst>
+              <a:ext uri="{FF2B5EF4-FFF2-40B4-BE49-F238E27FC236}">
+                <a16:creationId xmlns:a16="http://schemas.microsoft.com/office/drawing/2014/main" id="{A1451646-C5C2-A8F6-2239-1BFB668E9675}"/>
+              </a:ext>
+            </a:extLst>
+          </p:cNvPr>
+          <p:cNvSpPr>
+            <a:spLocks noGrp="1"/>
+          </p:cNvSpPr>
+          <p:nvPr>
+            <p:ph type="sldNum" sz="quarter" idx="5"/>
+          </p:nvPr>
+        </p:nvSpPr>
+        <p:spPr/>
+        <p:txBody>
+          <a:bodyPr/>
+          <a:lstStyle/>
+          <a:p>
+            <a:fld id="{BD810619-8C86-4E95-A074-DA0A2010136C}" type="slidenum">
+              <a:rPr lang="de-DE" smtClean="0"/>
+              <a:t>20</a:t>
+            </a:fld>
+            <a:endParaRPr lang="de-DE"/>
+          </a:p>
+        </p:txBody>
+      </p:sp>
+    </p:spTree>
+    <p:extLst>
+      <p:ext uri="{BB962C8B-B14F-4D97-AF65-F5344CB8AC3E}">
+        <p14:creationId xmlns:p14="http://schemas.microsoft.com/office/powerpoint/2010/main" val="1491723569"/>
       </p:ext>
     </p:extLst>
   </p:cSld>
@@ -4104,13 +4214,13 @@
   <p:clrMapOvr>
     <a:masterClrMapping/>
   </p:clrMapOvr>
-  <mc:AlternateContent xmlns:mc="http://schemas.openxmlformats.org/markup-compatibility/2006">
-    <mc:Choice xmlns:p159="http://schemas.microsoft.com/office/powerpoint/2015/09/main" Requires="p159">
+  <mc:AlternateContent xmlns:mc="http://schemas.openxmlformats.org/markup-compatibility/2006" xmlns:p159="http://schemas.microsoft.com/office/powerpoint/2015/09/main">
+    <mc:Choice Requires="p159">
       <p:transition xmlns:p14="http://schemas.microsoft.com/office/powerpoint/2010/main" spd="slow" p14:dur="2000">
         <p159:morph option="byObject"/>
       </p:transition>
     </mc:Choice>
-    <mc:Fallback>
+    <mc:Fallback xmlns="">
       <p:transition spd="slow">
         <p:fade/>
       </p:transition>
@@ -5203,14 +5313,13 @@
               </a:ext>
             </a:extLst>
           </a:blip>
-          <a:stretch>
-            <a:fillRect/>
-          </a:stretch>
+          <a:srcRect/>
+          <a:stretch/>
         </p:blipFill>
         <p:spPr>
           <a:xfrm>
-            <a:off x="3864673" y="957362"/>
-            <a:ext cx="7500940" cy="4973908"/>
+            <a:off x="3864673" y="961551"/>
+            <a:ext cx="7500940" cy="4965529"/>
           </a:xfrm>
           <a:prstGeom prst="rect">
             <a:avLst/>
@@ -5239,14 +5348,13 @@
               </a:ext>
             </a:extLst>
           </a:blip>
-          <a:stretch>
-            <a:fillRect/>
-          </a:stretch>
+          <a:srcRect/>
+          <a:stretch/>
         </p:blipFill>
         <p:spPr>
           <a:xfrm>
             <a:off x="3855948" y="957362"/>
-            <a:ext cx="7513596" cy="4973908"/>
+            <a:ext cx="7513595" cy="4973908"/>
           </a:xfrm>
           <a:prstGeom prst="rect">
             <a:avLst/>
@@ -5275,14 +5383,13 @@
               </a:ext>
             </a:extLst>
           </a:blip>
-          <a:stretch>
-            <a:fillRect/>
-          </a:stretch>
+          <a:srcRect/>
+          <a:stretch/>
         </p:blipFill>
         <p:spPr>
           <a:xfrm>
             <a:off x="3855948" y="957362"/>
-            <a:ext cx="7513596" cy="4973908"/>
+            <a:ext cx="7513595" cy="4973908"/>
           </a:xfrm>
           <a:prstGeom prst="rect">
             <a:avLst/>
@@ -5311,14 +5418,13 @@
               </a:ext>
             </a:extLst>
           </a:blip>
-          <a:stretch>
-            <a:fillRect/>
-          </a:stretch>
+          <a:srcRect/>
+          <a:stretch/>
         </p:blipFill>
         <p:spPr>
           <a:xfrm>
             <a:off x="3855948" y="957362"/>
-            <a:ext cx="7513596" cy="4973908"/>
+            <a:ext cx="7513595" cy="4973908"/>
           </a:xfrm>
           <a:prstGeom prst="rect">
             <a:avLst/>
@@ -5347,14 +5453,13 @@
               </a:ext>
             </a:extLst>
           </a:blip>
-          <a:stretch>
-            <a:fillRect/>
-          </a:stretch>
+          <a:srcRect/>
+          <a:stretch/>
         </p:blipFill>
         <p:spPr>
           <a:xfrm>
             <a:off x="3855948" y="957362"/>
-            <a:ext cx="7513596" cy="4973908"/>
+            <a:ext cx="7513595" cy="4973908"/>
           </a:xfrm>
           <a:prstGeom prst="rect">
             <a:avLst/>
@@ -6030,12 +6135,237 @@
           </a:p>
         </p:txBody>
       </p:sp>
+      <p:sp>
+        <p:nvSpPr>
+          <p:cNvPr id="8" name="Textfeld 7">
+            <a:extLst>
+              <a:ext uri="{FF2B5EF4-FFF2-40B4-BE49-F238E27FC236}">
+                <a16:creationId xmlns:a16="http://schemas.microsoft.com/office/drawing/2014/main" id="{39415EE7-D00F-C603-EEA2-139BA96482FE}"/>
+              </a:ext>
+            </a:extLst>
+          </p:cNvPr>
+          <p:cNvSpPr txBox="1"/>
+          <p:nvPr/>
+        </p:nvSpPr>
+        <p:spPr>
+          <a:xfrm>
+            <a:off x="4195989" y="5605807"/>
+            <a:ext cx="10203543" cy="1187376"/>
+          </a:xfrm>
+          <a:prstGeom prst="rect">
+            <a:avLst/>
+          </a:prstGeom>
+          <a:noFill/>
+        </p:spPr>
+        <p:txBody>
+          <a:bodyPr wrap="square">
+            <a:spAutoFit/>
+          </a:bodyPr>
+          <a:lstStyle/>
+          <a:p>
+            <a:pPr defTabSz="288000">
+              <a:lnSpc>
+                <a:spcPct val="115000"/>
+              </a:lnSpc>
+              <a:spcAft>
+                <a:spcPts val="1000"/>
+              </a:spcAft>
+              <a:buNone/>
+            </a:pPr>
+            <a:r>
+              <a:rPr lang="en-US" sz="800" dirty="0">
+                <a:effectLst/>
+                <a:ea typeface="MS Mincho" panose="02020609040205080304" pitchFamily="49" charset="-128"/>
+                <a:cs typeface="Times New Roman" panose="02020603050405020304" pitchFamily="18" charset="0"/>
+              </a:rPr>
+              <a:t>Kruskal-Wallis: p &lt;&lt; 0.01; </a:t>
+            </a:r>
+            <a:r>
+              <a:rPr lang="el-GR" sz="800" dirty="0">
+                <a:effectLst/>
+                <a:ea typeface="MS Mincho" panose="02020609040205080304" pitchFamily="49" charset="-128"/>
+                <a:cs typeface="Times New Roman" panose="02020603050405020304" pitchFamily="18" charset="0"/>
+              </a:rPr>
+              <a:t>ε</a:t>
+            </a:r>
+            <a:r>
+              <a:rPr lang="de-DE" sz="800" baseline="30000" dirty="0">
+                <a:effectLst/>
+                <a:ea typeface="MS Mincho" panose="02020609040205080304" pitchFamily="49" charset="-128"/>
+                <a:cs typeface="Times New Roman" panose="02020603050405020304" pitchFamily="18" charset="0"/>
+              </a:rPr>
+              <a:t>2</a:t>
+            </a:r>
+            <a:r>
+              <a:rPr lang="de-DE" sz="800" dirty="0">
+                <a:effectLst/>
+                <a:ea typeface="MS Mincho" panose="02020609040205080304" pitchFamily="49" charset="-128"/>
+                <a:cs typeface="Times New Roman" panose="02020603050405020304" pitchFamily="18" charset="0"/>
+              </a:rPr>
+              <a:t> = 0.4 (large </a:t>
+            </a:r>
+            <a:r>
+              <a:rPr lang="de-DE" sz="800" dirty="0" err="1">
+                <a:effectLst/>
+                <a:ea typeface="MS Mincho" panose="02020609040205080304" pitchFamily="49" charset="-128"/>
+                <a:cs typeface="Times New Roman" panose="02020603050405020304" pitchFamily="18" charset="0"/>
+              </a:rPr>
+              <a:t>effect</a:t>
+            </a:r>
+            <a:r>
+              <a:rPr lang="de-DE" sz="800" dirty="0">
+                <a:effectLst/>
+                <a:ea typeface="MS Mincho" panose="02020609040205080304" pitchFamily="49" charset="-128"/>
+                <a:cs typeface="Times New Roman" panose="02020603050405020304" pitchFamily="18" charset="0"/>
+              </a:rPr>
+              <a:t> </a:t>
+            </a:r>
+            <a:r>
+              <a:rPr lang="de-DE" sz="800" dirty="0" err="1">
+                <a:effectLst/>
+                <a:ea typeface="MS Mincho" panose="02020609040205080304" pitchFamily="49" charset="-128"/>
+                <a:cs typeface="Times New Roman" panose="02020603050405020304" pitchFamily="18" charset="0"/>
+              </a:rPr>
+              <a:t>size</a:t>
+            </a:r>
+            <a:r>
+              <a:rPr lang="de-DE" sz="800" dirty="0">
+                <a:effectLst/>
+                <a:ea typeface="MS Mincho" panose="02020609040205080304" pitchFamily="49" charset="-128"/>
+                <a:cs typeface="Times New Roman" panose="02020603050405020304" pitchFamily="18" charset="0"/>
+              </a:rPr>
+              <a:t>)</a:t>
+            </a:r>
+            <a:endParaRPr lang="en-US" sz="800" dirty="0">
+              <a:effectLst/>
+              <a:ea typeface="MS Mincho" panose="02020609040205080304" pitchFamily="49" charset="-128"/>
+              <a:cs typeface="Times New Roman" panose="02020603050405020304" pitchFamily="18" charset="0"/>
+            </a:endParaRPr>
+          </a:p>
+          <a:p>
+            <a:pPr defTabSz="288000">
+              <a:lnSpc>
+                <a:spcPct val="115000"/>
+              </a:lnSpc>
+              <a:spcAft>
+                <a:spcPts val="1000"/>
+              </a:spcAft>
+              <a:buNone/>
+            </a:pPr>
+            <a:r>
+              <a:rPr lang="en-US" sz="800" dirty="0">
+                <a:ea typeface="MS Mincho" panose="02020609040205080304" pitchFamily="49" charset="-128"/>
+                <a:cs typeface="Times New Roman" panose="02020603050405020304" pitchFamily="18" charset="0"/>
+              </a:rPr>
+              <a:t>MWU + Holm-Bonferroni: </a:t>
+            </a:r>
+            <a:br>
+              <a:rPr lang="en-US" sz="800" dirty="0">
+                <a:ea typeface="MS Mincho" panose="02020609040205080304" pitchFamily="49" charset="-128"/>
+                <a:cs typeface="Times New Roman" panose="02020603050405020304" pitchFamily="18" charset="0"/>
+              </a:rPr>
+            </a:br>
+            <a:r>
+              <a:rPr lang="en-US" sz="800" dirty="0">
+                <a:ea typeface="MS Mincho" panose="02020609040205080304" pitchFamily="49" charset="-128"/>
+                <a:cs typeface="Times New Roman" panose="02020603050405020304" pitchFamily="18" charset="0"/>
+              </a:rPr>
+              <a:t>Hard-Coded vs Random:	p &lt;&lt; 0.01;	r = -0.87 (large effect size)</a:t>
+            </a:r>
+            <a:br>
+              <a:rPr lang="en-US" sz="800" dirty="0">
+                <a:ea typeface="MS Mincho" panose="02020609040205080304" pitchFamily="49" charset="-128"/>
+                <a:cs typeface="Times New Roman" panose="02020603050405020304" pitchFamily="18" charset="0"/>
+              </a:rPr>
+            </a:br>
+            <a:r>
+              <a:rPr lang="en-US" sz="800" dirty="0">
+                <a:ea typeface="MS Mincho" panose="02020609040205080304" pitchFamily="49" charset="-128"/>
+                <a:cs typeface="Times New Roman" panose="02020603050405020304" pitchFamily="18" charset="0"/>
+              </a:rPr>
+              <a:t>EA vs Random:			p &lt;&lt; 0.01; 	r = -0.97 (large effect size)</a:t>
+            </a:r>
+            <a:br>
+              <a:rPr lang="en-US" sz="800" dirty="0">
+                <a:ea typeface="MS Mincho" panose="02020609040205080304" pitchFamily="49" charset="-128"/>
+                <a:cs typeface="Times New Roman" panose="02020603050405020304" pitchFamily="18" charset="0"/>
+              </a:rPr>
+            </a:br>
+            <a:r>
+              <a:rPr lang="en-US" sz="800" dirty="0">
+                <a:effectLst/>
+                <a:ea typeface="MS Mincho" panose="02020609040205080304" pitchFamily="49" charset="-128"/>
+                <a:cs typeface="Times New Roman" panose="02020603050405020304" pitchFamily="18" charset="0"/>
+              </a:rPr>
+              <a:t>EA vs Hard-Coded</a:t>
+            </a:r>
+            <a:r>
+              <a:rPr lang="en-US" sz="800" dirty="0">
+                <a:ea typeface="MS Mincho" panose="02020609040205080304" pitchFamily="49" charset="-128"/>
+                <a:cs typeface="Times New Roman" panose="02020603050405020304" pitchFamily="18" charset="0"/>
+              </a:rPr>
+              <a:t>:		</a:t>
+            </a:r>
+            <a:r>
+              <a:rPr lang="en-US" sz="800" dirty="0">
+                <a:effectLst/>
+                <a:ea typeface="MS Mincho" panose="02020609040205080304" pitchFamily="49" charset="-128"/>
+                <a:cs typeface="Times New Roman" panose="02020603050405020304" pitchFamily="18" charset="0"/>
+              </a:rPr>
+              <a:t>p = 9*10</a:t>
+            </a:r>
+            <a:r>
+              <a:rPr lang="en-US" sz="800" baseline="30000" dirty="0">
+                <a:effectLst/>
+                <a:ea typeface="MS Mincho" panose="02020609040205080304" pitchFamily="49" charset="-128"/>
+                <a:cs typeface="Times New Roman" panose="02020603050405020304" pitchFamily="18" charset="0"/>
+              </a:rPr>
+              <a:t>-</a:t>
+            </a:r>
+            <a:r>
+              <a:rPr lang="en-US" sz="800" baseline="30000" dirty="0">
+                <a:ea typeface="MS Mincho" panose="02020609040205080304" pitchFamily="49" charset="-128"/>
+                <a:cs typeface="Times New Roman" panose="02020603050405020304" pitchFamily="18" charset="0"/>
+              </a:rPr>
+              <a:t>90</a:t>
+            </a:r>
+            <a:r>
+              <a:rPr lang="en-US" sz="800" dirty="0">
+                <a:ea typeface="MS Mincho" panose="02020609040205080304" pitchFamily="49" charset="-128"/>
+                <a:cs typeface="Times New Roman" panose="02020603050405020304" pitchFamily="18" charset="0"/>
+              </a:rPr>
+              <a:t>;	r = -0.7 (large effect size)</a:t>
+            </a:r>
+            <a:endParaRPr lang="en-US" sz="800" dirty="0">
+              <a:effectLst/>
+              <a:ea typeface="MS Mincho" panose="02020609040205080304" pitchFamily="49" charset="-128"/>
+              <a:cs typeface="Times New Roman" panose="02020603050405020304" pitchFamily="18" charset="0"/>
+            </a:endParaRPr>
+          </a:p>
+          <a:p>
+            <a:pPr>
+              <a:lnSpc>
+                <a:spcPct val="115000"/>
+              </a:lnSpc>
+              <a:spcAft>
+                <a:spcPts val="1000"/>
+              </a:spcAft>
+              <a:buNone/>
+            </a:pPr>
+            <a:endParaRPr lang="de-DE" sz="800" dirty="0">
+              <a:effectLst/>
+              <a:ea typeface="MS Mincho" panose="02020609040205080304" pitchFamily="49" charset="-128"/>
+              <a:cs typeface="Times New Roman" panose="02020603050405020304" pitchFamily="18" charset="0"/>
+            </a:endParaRPr>
+          </a:p>
+        </p:txBody>
+      </p:sp>
       <p:grpSp>
         <p:nvGrpSpPr>
-          <p:cNvPr id="42" name="Gruppieren 41">
+          <p:cNvPr id="2" name="Gruppieren 1">
             <a:extLst>
               <a:ext uri="{FF2B5EF4-FFF2-40B4-BE49-F238E27FC236}">
-                <a16:creationId xmlns:a16="http://schemas.microsoft.com/office/drawing/2014/main" id="{61D35B51-BC7E-C69E-726A-D2E8E7263E08}"/>
+                <a16:creationId xmlns:a16="http://schemas.microsoft.com/office/drawing/2014/main" id="{51F5124E-F9D2-D2B1-077A-EF7659D5F3A4}"/>
               </a:ext>
             </a:extLst>
           </p:cNvPr>
@@ -6045,242 +6375,52 @@
         <p:grpSpPr>
           <a:xfrm>
             <a:off x="4195989" y="735357"/>
-            <a:ext cx="10203543" cy="6057826"/>
+            <a:ext cx="6957785" cy="4870450"/>
             <a:chOff x="4195989" y="735357"/>
-            <a:chExt cx="10203543" cy="6057826"/>
+            <a:chExt cx="6957785" cy="4870450"/>
           </a:xfrm>
         </p:grpSpPr>
-        <p:sp>
-          <p:nvSpPr>
-            <p:cNvPr id="8" name="Textfeld 7">
+        <p:pic>
+          <p:nvPicPr>
+            <p:cNvPr id="25" name="Grafik 24">
               <a:extLst>
                 <a:ext uri="{FF2B5EF4-FFF2-40B4-BE49-F238E27FC236}">
-                  <a16:creationId xmlns:a16="http://schemas.microsoft.com/office/drawing/2014/main" id="{39415EE7-D00F-C603-EEA2-139BA96482FE}"/>
+                  <a16:creationId xmlns:a16="http://schemas.microsoft.com/office/drawing/2014/main" id="{A16FEB82-BC73-606C-8212-BB85B7519BAE}"/>
                 </a:ext>
               </a:extLst>
             </p:cNvPr>
-            <p:cNvSpPr txBox="1"/>
+            <p:cNvPicPr>
+              <a:picLocks noChangeAspect="1"/>
+            </p:cNvPicPr>
             <p:nvPr/>
-          </p:nvSpPr>
+          </p:nvPicPr>
+          <p:blipFill>
+            <a:blip r:embed="rId3">
+              <a:extLst>
+                <a:ext uri="{28A0092B-C50C-407E-A947-70E740481C1C}">
+                  <a14:useLocalDpi xmlns:a14="http://schemas.microsoft.com/office/drawing/2010/main" val="0"/>
+                </a:ext>
+              </a:extLst>
+            </a:blip>
+            <a:srcRect/>
+            <a:stretch/>
+          </p:blipFill>
           <p:spPr>
             <a:xfrm>
-              <a:off x="4195989" y="5605807"/>
-              <a:ext cx="10203543" cy="1187376"/>
+              <a:off x="4195989" y="735357"/>
+              <a:ext cx="6957785" cy="4870450"/>
             </a:xfrm>
             <a:prstGeom prst="rect">
               <a:avLst/>
             </a:prstGeom>
-            <a:noFill/>
           </p:spPr>
-          <p:txBody>
-            <a:bodyPr wrap="square">
-              <a:spAutoFit/>
-            </a:bodyPr>
-            <a:lstStyle/>
-            <a:p>
-              <a:pPr defTabSz="288000">
-                <a:lnSpc>
-                  <a:spcPct val="115000"/>
-                </a:lnSpc>
-                <a:spcAft>
-                  <a:spcPts val="1000"/>
-                </a:spcAft>
-                <a:buNone/>
-              </a:pPr>
-              <a:r>
-                <a:rPr lang="en-US" sz="800" dirty="0">
-                  <a:effectLst/>
-                  <a:ea typeface="MS Mincho" panose="02020609040205080304" pitchFamily="49" charset="-128"/>
-                  <a:cs typeface="Times New Roman" panose="02020603050405020304" pitchFamily="18" charset="0"/>
-                </a:rPr>
-                <a:t>Kruskal-Wallis: p &lt;&lt; 0.01; </a:t>
-              </a:r>
-              <a:r>
-                <a:rPr lang="el-GR" sz="800" dirty="0">
-                  <a:effectLst/>
-                  <a:ea typeface="MS Mincho" panose="02020609040205080304" pitchFamily="49" charset="-128"/>
-                  <a:cs typeface="Times New Roman" panose="02020603050405020304" pitchFamily="18" charset="0"/>
-                </a:rPr>
-                <a:t>ε</a:t>
-              </a:r>
-              <a:r>
-                <a:rPr lang="de-DE" sz="800" baseline="30000" dirty="0">
-                  <a:effectLst/>
-                  <a:ea typeface="MS Mincho" panose="02020609040205080304" pitchFamily="49" charset="-128"/>
-                  <a:cs typeface="Times New Roman" panose="02020603050405020304" pitchFamily="18" charset="0"/>
-                </a:rPr>
-                <a:t>2</a:t>
-              </a:r>
-              <a:r>
-                <a:rPr lang="de-DE" sz="800" dirty="0">
-                  <a:effectLst/>
-                  <a:ea typeface="MS Mincho" panose="02020609040205080304" pitchFamily="49" charset="-128"/>
-                  <a:cs typeface="Times New Roman" panose="02020603050405020304" pitchFamily="18" charset="0"/>
-                </a:rPr>
-                <a:t> = 0.4 (large </a:t>
-              </a:r>
-              <a:r>
-                <a:rPr lang="de-DE" sz="800" dirty="0" err="1">
-                  <a:effectLst/>
-                  <a:ea typeface="MS Mincho" panose="02020609040205080304" pitchFamily="49" charset="-128"/>
-                  <a:cs typeface="Times New Roman" panose="02020603050405020304" pitchFamily="18" charset="0"/>
-                </a:rPr>
-                <a:t>effect</a:t>
-              </a:r>
-              <a:r>
-                <a:rPr lang="de-DE" sz="800" dirty="0">
-                  <a:effectLst/>
-                  <a:ea typeface="MS Mincho" panose="02020609040205080304" pitchFamily="49" charset="-128"/>
-                  <a:cs typeface="Times New Roman" panose="02020603050405020304" pitchFamily="18" charset="0"/>
-                </a:rPr>
-                <a:t> </a:t>
-              </a:r>
-              <a:r>
-                <a:rPr lang="de-DE" sz="800" dirty="0" err="1">
-                  <a:effectLst/>
-                  <a:ea typeface="MS Mincho" panose="02020609040205080304" pitchFamily="49" charset="-128"/>
-                  <a:cs typeface="Times New Roman" panose="02020603050405020304" pitchFamily="18" charset="0"/>
-                </a:rPr>
-                <a:t>size</a:t>
-              </a:r>
-              <a:r>
-                <a:rPr lang="de-DE" sz="800" dirty="0">
-                  <a:effectLst/>
-                  <a:ea typeface="MS Mincho" panose="02020609040205080304" pitchFamily="49" charset="-128"/>
-                  <a:cs typeface="Times New Roman" panose="02020603050405020304" pitchFamily="18" charset="0"/>
-                </a:rPr>
-                <a:t>)</a:t>
-              </a:r>
-              <a:endParaRPr lang="en-US" sz="800" dirty="0">
-                <a:effectLst/>
-                <a:ea typeface="MS Mincho" panose="02020609040205080304" pitchFamily="49" charset="-128"/>
-                <a:cs typeface="Times New Roman" panose="02020603050405020304" pitchFamily="18" charset="0"/>
-              </a:endParaRPr>
-            </a:p>
-            <a:p>
-              <a:pPr defTabSz="288000">
-                <a:lnSpc>
-                  <a:spcPct val="115000"/>
-                </a:lnSpc>
-                <a:spcAft>
-                  <a:spcPts val="1000"/>
-                </a:spcAft>
-                <a:buNone/>
-              </a:pPr>
-              <a:r>
-                <a:rPr lang="en-US" sz="800" dirty="0">
-                  <a:ea typeface="MS Mincho" panose="02020609040205080304" pitchFamily="49" charset="-128"/>
-                  <a:cs typeface="Times New Roman" panose="02020603050405020304" pitchFamily="18" charset="0"/>
-                </a:rPr>
-                <a:t>MWU + Holm-Bonferroni: </a:t>
-              </a:r>
-              <a:br>
-                <a:rPr lang="en-US" sz="800" dirty="0">
-                  <a:ea typeface="MS Mincho" panose="02020609040205080304" pitchFamily="49" charset="-128"/>
-                  <a:cs typeface="Times New Roman" panose="02020603050405020304" pitchFamily="18" charset="0"/>
-                </a:rPr>
-              </a:br>
-              <a:r>
-                <a:rPr lang="en-US" sz="800" dirty="0">
-                  <a:ea typeface="MS Mincho" panose="02020609040205080304" pitchFamily="49" charset="-128"/>
-                  <a:cs typeface="Times New Roman" panose="02020603050405020304" pitchFamily="18" charset="0"/>
-                </a:rPr>
-                <a:t>Hard-Coded vs Random:	p &lt;&lt; 0.01;	r = -0.87 (large effect size)</a:t>
-              </a:r>
-              <a:br>
-                <a:rPr lang="en-US" sz="800" dirty="0">
-                  <a:ea typeface="MS Mincho" panose="02020609040205080304" pitchFamily="49" charset="-128"/>
-                  <a:cs typeface="Times New Roman" panose="02020603050405020304" pitchFamily="18" charset="0"/>
-                </a:rPr>
-              </a:br>
-              <a:r>
-                <a:rPr lang="en-US" sz="800" dirty="0">
-                  <a:ea typeface="MS Mincho" panose="02020609040205080304" pitchFamily="49" charset="-128"/>
-                  <a:cs typeface="Times New Roman" panose="02020603050405020304" pitchFamily="18" charset="0"/>
-                </a:rPr>
-                <a:t>EA vs Random:			p &lt;&lt; 0.01; 	r = -0.97 (large effect size)</a:t>
-              </a:r>
-              <a:br>
-                <a:rPr lang="en-US" sz="800" dirty="0">
-                  <a:ea typeface="MS Mincho" panose="02020609040205080304" pitchFamily="49" charset="-128"/>
-                  <a:cs typeface="Times New Roman" panose="02020603050405020304" pitchFamily="18" charset="0"/>
-                </a:rPr>
-              </a:br>
-              <a:r>
-                <a:rPr lang="en-US" sz="800" dirty="0">
-                  <a:effectLst/>
-                  <a:ea typeface="MS Mincho" panose="02020609040205080304" pitchFamily="49" charset="-128"/>
-                  <a:cs typeface="Times New Roman" panose="02020603050405020304" pitchFamily="18" charset="0"/>
-                </a:rPr>
-                <a:t>EA vs Hard-Coded</a:t>
-              </a:r>
-              <a:r>
-                <a:rPr lang="en-US" sz="800" dirty="0">
-                  <a:ea typeface="MS Mincho" panose="02020609040205080304" pitchFamily="49" charset="-128"/>
-                  <a:cs typeface="Times New Roman" panose="02020603050405020304" pitchFamily="18" charset="0"/>
-                </a:rPr>
-                <a:t>:		</a:t>
-              </a:r>
-              <a:r>
-                <a:rPr lang="en-US" sz="800" dirty="0">
-                  <a:effectLst/>
-                  <a:ea typeface="MS Mincho" panose="02020609040205080304" pitchFamily="49" charset="-128"/>
-                  <a:cs typeface="Times New Roman" panose="02020603050405020304" pitchFamily="18" charset="0"/>
-                </a:rPr>
-                <a:t>p = 9*10</a:t>
-              </a:r>
-              <a:r>
-                <a:rPr lang="en-US" sz="800" baseline="30000" dirty="0">
-                  <a:effectLst/>
-                  <a:ea typeface="MS Mincho" panose="02020609040205080304" pitchFamily="49" charset="-128"/>
-                  <a:cs typeface="Times New Roman" panose="02020603050405020304" pitchFamily="18" charset="0"/>
-                </a:rPr>
-                <a:t>-</a:t>
-              </a:r>
-              <a:r>
-                <a:rPr lang="en-US" sz="800" baseline="30000" dirty="0">
-                  <a:ea typeface="MS Mincho" panose="02020609040205080304" pitchFamily="49" charset="-128"/>
-                  <a:cs typeface="Times New Roman" panose="02020603050405020304" pitchFamily="18" charset="0"/>
-                </a:rPr>
-                <a:t>90</a:t>
-              </a:r>
-              <a:r>
-                <a:rPr lang="en-US" sz="800" dirty="0">
-                  <a:ea typeface="MS Mincho" panose="02020609040205080304" pitchFamily="49" charset="-128"/>
-                  <a:cs typeface="Times New Roman" panose="02020603050405020304" pitchFamily="18" charset="0"/>
-                </a:rPr>
-                <a:t>;	r = -0.7 (large effect size)</a:t>
-              </a:r>
-              <a:endParaRPr lang="en-US" sz="800" dirty="0">
-                <a:effectLst/>
-                <a:ea typeface="MS Mincho" panose="02020609040205080304" pitchFamily="49" charset="-128"/>
-                <a:cs typeface="Times New Roman" panose="02020603050405020304" pitchFamily="18" charset="0"/>
-              </a:endParaRPr>
-            </a:p>
-            <a:p>
-              <a:pPr>
-                <a:lnSpc>
-                  <a:spcPct val="115000"/>
-                </a:lnSpc>
-                <a:spcAft>
-                  <a:spcPts val="1000"/>
-                </a:spcAft>
-                <a:buNone/>
-              </a:pPr>
-              <a:endParaRPr lang="de-DE" sz="800" dirty="0">
-                <a:effectLst/>
-                <a:ea typeface="MS Mincho" panose="02020609040205080304" pitchFamily="49" charset="-128"/>
-                <a:cs typeface="Times New Roman" panose="02020603050405020304" pitchFamily="18" charset="0"/>
-              </a:endParaRPr>
-            </a:p>
-          </p:txBody>
-        </p:sp>
+        </p:pic>
         <p:grpSp>
           <p:nvGrpSpPr>
-            <p:cNvPr id="41" name="Gruppieren 40">
+            <p:cNvPr id="40" name="Gruppieren 39">
               <a:extLst>
                 <a:ext uri="{FF2B5EF4-FFF2-40B4-BE49-F238E27FC236}">
-                  <a16:creationId xmlns:a16="http://schemas.microsoft.com/office/drawing/2014/main" id="{F204B855-5563-7A74-7C69-6AE301321926}"/>
+                  <a16:creationId xmlns:a16="http://schemas.microsoft.com/office/drawing/2014/main" id="{6F99784B-DEAC-D516-FD5C-D2F68B99A8D7}"/>
                 </a:ext>
               </a:extLst>
             </p:cNvPr>
@@ -6289,54 +6429,18 @@
           </p:nvGrpSpPr>
           <p:grpSpPr>
             <a:xfrm>
-              <a:off x="4195989" y="735357"/>
-              <a:ext cx="6957786" cy="4870450"/>
-              <a:chOff x="4195989" y="735357"/>
-              <a:chExt cx="6957786" cy="4870450"/>
+              <a:off x="5795963" y="1196059"/>
+              <a:ext cx="4205287" cy="429366"/>
+              <a:chOff x="5795963" y="1196059"/>
+              <a:chExt cx="4205287" cy="429366"/>
             </a:xfrm>
           </p:grpSpPr>
-          <p:pic>
-            <p:nvPicPr>
-              <p:cNvPr id="25" name="Grafik 24">
+          <p:grpSp>
+            <p:nvGrpSpPr>
+              <p:cNvPr id="39" name="Gruppieren 38">
                 <a:extLst>
                   <a:ext uri="{FF2B5EF4-FFF2-40B4-BE49-F238E27FC236}">
-                    <a16:creationId xmlns:a16="http://schemas.microsoft.com/office/drawing/2014/main" id="{A16FEB82-BC73-606C-8212-BB85B7519BAE}"/>
-                  </a:ext>
-                </a:extLst>
-              </p:cNvPr>
-              <p:cNvPicPr>
-                <a:picLocks noChangeAspect="1"/>
-              </p:cNvPicPr>
-              <p:nvPr/>
-            </p:nvPicPr>
-            <p:blipFill>
-              <a:blip r:embed="rId3">
-                <a:extLst>
-                  <a:ext uri="{28A0092B-C50C-407E-A947-70E740481C1C}">
-                    <a14:useLocalDpi xmlns:a14="http://schemas.microsoft.com/office/drawing/2010/main" val="0"/>
-                  </a:ext>
-                </a:extLst>
-              </a:blip>
-              <a:stretch>
-                <a:fillRect/>
-              </a:stretch>
-            </p:blipFill>
-            <p:spPr>
-              <a:xfrm>
-                <a:off x="4195989" y="735357"/>
-                <a:ext cx="6957786" cy="4870450"/>
-              </a:xfrm>
-              <a:prstGeom prst="rect">
-                <a:avLst/>
-              </a:prstGeom>
-            </p:spPr>
-          </p:pic>
-          <p:grpSp>
-            <p:nvGrpSpPr>
-              <p:cNvPr id="40" name="Gruppieren 39">
-                <a:extLst>
-                  <a:ext uri="{FF2B5EF4-FFF2-40B4-BE49-F238E27FC236}">
-                    <a16:creationId xmlns:a16="http://schemas.microsoft.com/office/drawing/2014/main" id="{6F99784B-DEAC-D516-FD5C-D2F68B99A8D7}"/>
+                    <a16:creationId xmlns:a16="http://schemas.microsoft.com/office/drawing/2014/main" id="{928CD72C-2642-FB87-37C5-11001206F7B3}"/>
                   </a:ext>
                 </a:extLst>
               </p:cNvPr>
@@ -6346,333 +6450,312 @@
             <p:grpSpPr>
               <a:xfrm>
                 <a:off x="5795963" y="1196059"/>
-                <a:ext cx="4205287" cy="429366"/>
+                <a:ext cx="4205287" cy="153888"/>
                 <a:chOff x="5795963" y="1196059"/>
-                <a:chExt cx="4205287" cy="429366"/>
+                <a:chExt cx="4205287" cy="153888"/>
               </a:xfrm>
             </p:grpSpPr>
-            <p:grpSp>
-              <p:nvGrpSpPr>
-                <p:cNvPr id="39" name="Gruppieren 38">
+            <p:cxnSp>
+              <p:nvCxnSpPr>
+                <p:cNvPr id="28" name="Gerader Verbinder 27">
                   <a:extLst>
                     <a:ext uri="{FF2B5EF4-FFF2-40B4-BE49-F238E27FC236}">
-                      <a16:creationId xmlns:a16="http://schemas.microsoft.com/office/drawing/2014/main" id="{928CD72C-2642-FB87-37C5-11001206F7B3}"/>
+                      <a16:creationId xmlns:a16="http://schemas.microsoft.com/office/drawing/2014/main" id="{33F3B53C-D96D-7C07-B258-EC028CF36C3C}"/>
                     </a:ext>
                   </a:extLst>
                 </p:cNvPr>
-                <p:cNvGrpSpPr/>
+                <p:cNvCxnSpPr>
+                  <a:cxnSpLocks/>
+                </p:cNvCxnSpPr>
                 <p:nvPr/>
-              </p:nvGrpSpPr>
-              <p:grpSpPr>
+              </p:nvCxnSpPr>
+              <p:spPr>
                 <a:xfrm>
-                  <a:off x="5795963" y="1196059"/>
-                  <a:ext cx="4205287" cy="153888"/>
-                  <a:chOff x="5795963" y="1196059"/>
-                  <a:chExt cx="4205287" cy="153888"/>
+                  <a:off x="5795963" y="1295998"/>
+                  <a:ext cx="4205287" cy="0"/>
                 </a:xfrm>
-              </p:grpSpPr>
-              <p:cxnSp>
-                <p:nvCxnSpPr>
-                  <p:cNvPr id="28" name="Gerader Verbinder 27">
-                    <a:extLst>
-                      <a:ext uri="{FF2B5EF4-FFF2-40B4-BE49-F238E27FC236}">
-                        <a16:creationId xmlns:a16="http://schemas.microsoft.com/office/drawing/2014/main" id="{33F3B53C-D96D-7C07-B258-EC028CF36C3C}"/>
-                      </a:ext>
-                    </a:extLst>
-                  </p:cNvPr>
-                  <p:cNvCxnSpPr>
-                    <a:cxnSpLocks/>
-                  </p:cNvCxnSpPr>
-                  <p:nvPr/>
-                </p:nvCxnSpPr>
-                <p:spPr>
-                  <a:xfrm>
-                    <a:off x="5795963" y="1295998"/>
-                    <a:ext cx="4205287" cy="0"/>
-                  </a:xfrm>
-                  <a:prstGeom prst="line">
-                    <a:avLst/>
-                  </a:prstGeom>
-                  <a:ln w="9525">
-                    <a:solidFill>
-                      <a:schemeClr val="tx1"/>
-                    </a:solidFill>
-                    <a:headEnd type="diamond" w="sm" len="sm"/>
-                    <a:tailEnd type="diamond" w="sm" len="sm"/>
-                  </a:ln>
-                </p:spPr>
-                <p:style>
-                  <a:lnRef idx="2">
-                    <a:schemeClr val="accent1"/>
-                  </a:lnRef>
-                  <a:fillRef idx="0">
-                    <a:schemeClr val="accent1"/>
-                  </a:fillRef>
-                  <a:effectRef idx="1">
-                    <a:schemeClr val="accent1"/>
-                  </a:effectRef>
-                  <a:fontRef idx="minor">
+                <a:prstGeom prst="line">
+                  <a:avLst/>
+                </a:prstGeom>
+                <a:ln w="9525">
+                  <a:solidFill>
                     <a:schemeClr val="tx1"/>
-                  </a:fontRef>
-                </p:style>
-              </p:cxnSp>
-              <p:sp>
-                <p:nvSpPr>
-                  <p:cNvPr id="34" name="Textfeld 33">
-                    <a:extLst>
-                      <a:ext uri="{FF2B5EF4-FFF2-40B4-BE49-F238E27FC236}">
-                        <a16:creationId xmlns:a16="http://schemas.microsoft.com/office/drawing/2014/main" id="{BFD885DD-9D36-4AE2-BE1F-226E80B6FF12}"/>
-                      </a:ext>
-                    </a:extLst>
-                  </p:cNvPr>
-                  <p:cNvSpPr txBox="1"/>
-                  <p:nvPr/>
-                </p:nvSpPr>
-                <p:spPr>
-                  <a:xfrm>
-                    <a:off x="7770366" y="1196059"/>
-                    <a:ext cx="256480" cy="153888"/>
-                  </a:xfrm>
-                  <a:prstGeom prst="rect">
-                    <a:avLst/>
-                  </a:prstGeom>
-                  <a:noFill/>
-                  <a:ln>
-                    <a:noFill/>
-                  </a:ln>
-                </p:spPr>
-                <p:txBody>
-                  <a:bodyPr wrap="none" lIns="0" tIns="0" rIns="0" bIns="0" rtlCol="0" anchor="b">
-                    <a:spAutoFit/>
-                  </a:bodyPr>
-                  <a:lstStyle/>
-                  <a:p>
-                    <a:r>
-                      <a:rPr lang="de-DE" sz="1000" dirty="0">
-                        <a:latin typeface="+mj-lt"/>
-                        <a:ea typeface="Cormorant Garamond" pitchFamily="2" charset="0"/>
-                        <a:cs typeface="Cormorant Garamond" pitchFamily="2" charset="0"/>
-                      </a:rPr>
-                      <a:t>****</a:t>
-                    </a:r>
-                  </a:p>
-                </p:txBody>
-              </p:sp>
-            </p:grpSp>
-            <p:grpSp>
-              <p:nvGrpSpPr>
-                <p:cNvPr id="37" name="Gruppieren 36">
+                  </a:solidFill>
+                  <a:headEnd type="diamond" w="sm" len="sm"/>
+                  <a:tailEnd type="diamond" w="sm" len="sm"/>
+                </a:ln>
+              </p:spPr>
+              <p:style>
+                <a:lnRef idx="2">
+                  <a:schemeClr val="accent1"/>
+                </a:lnRef>
+                <a:fillRef idx="0">
+                  <a:schemeClr val="accent1"/>
+                </a:fillRef>
+                <a:effectRef idx="1">
+                  <a:schemeClr val="accent1"/>
+                </a:effectRef>
+                <a:fontRef idx="minor">
+                  <a:schemeClr val="tx1"/>
+                </a:fontRef>
+              </p:style>
+            </p:cxnSp>
+            <p:sp>
+              <p:nvSpPr>
+                <p:cNvPr id="34" name="Textfeld 33">
                   <a:extLst>
                     <a:ext uri="{FF2B5EF4-FFF2-40B4-BE49-F238E27FC236}">
-                      <a16:creationId xmlns:a16="http://schemas.microsoft.com/office/drawing/2014/main" id="{40A8EA23-B109-136D-9368-BB6AE23A6140}"/>
+                      <a16:creationId xmlns:a16="http://schemas.microsoft.com/office/drawing/2014/main" id="{BFD885DD-9D36-4AE2-BE1F-226E80B6FF12}"/>
                     </a:ext>
                   </a:extLst>
                 </p:cNvPr>
-                <p:cNvGrpSpPr/>
+                <p:cNvSpPr txBox="1"/>
                 <p:nvPr/>
-              </p:nvGrpSpPr>
-              <p:grpSpPr>
+              </p:nvSpPr>
+              <p:spPr>
                 <a:xfrm>
-                  <a:off x="5795963" y="1471537"/>
-                  <a:ext cx="2095500" cy="153888"/>
-                  <a:chOff x="5795963" y="1471537"/>
-                  <a:chExt cx="2095500" cy="153888"/>
+                  <a:off x="7770366" y="1196059"/>
+                  <a:ext cx="256480" cy="153888"/>
                 </a:xfrm>
-              </p:grpSpPr>
-              <p:cxnSp>
-                <p:nvCxnSpPr>
-                  <p:cNvPr id="27" name="Gerader Verbinder 26">
-                    <a:extLst>
-                      <a:ext uri="{FF2B5EF4-FFF2-40B4-BE49-F238E27FC236}">
-                        <a16:creationId xmlns:a16="http://schemas.microsoft.com/office/drawing/2014/main" id="{16B4C276-179F-43B7-247E-E4F362A8E68C}"/>
-                      </a:ext>
-                    </a:extLst>
-                  </p:cNvPr>
-                  <p:cNvCxnSpPr/>
-                  <p:nvPr/>
-                </p:nvCxnSpPr>
-                <p:spPr>
-                  <a:xfrm>
-                    <a:off x="5795963" y="1567797"/>
-                    <a:ext cx="2095500" cy="0"/>
-                  </a:xfrm>
-                  <a:prstGeom prst="line">
-                    <a:avLst/>
-                  </a:prstGeom>
-                  <a:ln w="9525">
-                    <a:solidFill>
-                      <a:schemeClr val="tx1"/>
-                    </a:solidFill>
-                    <a:headEnd type="diamond" w="sm" len="sm"/>
-                    <a:tailEnd type="diamond" w="sm" len="sm"/>
-                  </a:ln>
-                </p:spPr>
-                <p:style>
-                  <a:lnRef idx="2">
-                    <a:schemeClr val="accent1"/>
-                  </a:lnRef>
-                  <a:fillRef idx="0">
-                    <a:schemeClr val="accent1"/>
-                  </a:fillRef>
-                  <a:effectRef idx="1">
-                    <a:schemeClr val="accent1"/>
-                  </a:effectRef>
-                  <a:fontRef idx="minor">
-                    <a:schemeClr val="tx1"/>
-                  </a:fontRef>
-                </p:style>
-              </p:cxnSp>
-              <p:sp>
-                <p:nvSpPr>
-                  <p:cNvPr id="35" name="Textfeld 34">
-                    <a:extLst>
-                      <a:ext uri="{FF2B5EF4-FFF2-40B4-BE49-F238E27FC236}">
-                        <a16:creationId xmlns:a16="http://schemas.microsoft.com/office/drawing/2014/main" id="{C218FAF5-7FBA-89F4-D1BB-A0AA365621B1}"/>
-                      </a:ext>
-                    </a:extLst>
-                  </p:cNvPr>
-                  <p:cNvSpPr txBox="1"/>
-                  <p:nvPr/>
-                </p:nvSpPr>
-                <p:spPr>
-                  <a:xfrm>
-                    <a:off x="6715473" y="1471537"/>
-                    <a:ext cx="256480" cy="153888"/>
-                  </a:xfrm>
-                  <a:prstGeom prst="rect">
-                    <a:avLst/>
-                  </a:prstGeom>
+                <a:prstGeom prst="rect">
+                  <a:avLst/>
+                </a:prstGeom>
+                <a:noFill/>
+                <a:ln>
                   <a:noFill/>
-                  <a:ln>
-                    <a:noFill/>
-                  </a:ln>
-                </p:spPr>
-                <p:txBody>
-                  <a:bodyPr wrap="none" lIns="0" tIns="0" rIns="0" bIns="0" rtlCol="0">
-                    <a:spAutoFit/>
-                  </a:bodyPr>
-                  <a:lstStyle/>
-                  <a:p>
-                    <a:r>
-                      <a:rPr lang="de-DE" sz="1000" dirty="0">
-                        <a:latin typeface="+mj-lt"/>
-                        <a:ea typeface="Cormorant Garamond" pitchFamily="2" charset="0"/>
-                        <a:cs typeface="Cormorant Garamond" pitchFamily="2" charset="0"/>
-                      </a:rPr>
-                      <a:t>****</a:t>
-                    </a:r>
-                  </a:p>
-                </p:txBody>
-              </p:sp>
-            </p:grpSp>
-            <p:grpSp>
-              <p:nvGrpSpPr>
-                <p:cNvPr id="38" name="Gruppieren 37">
+                </a:ln>
+              </p:spPr>
+              <p:txBody>
+                <a:bodyPr wrap="none" lIns="0" tIns="0" rIns="0" bIns="0" rtlCol="0" anchor="b">
+                  <a:spAutoFit/>
+                </a:bodyPr>
+                <a:lstStyle/>
+                <a:p>
+                  <a:r>
+                    <a:rPr lang="de-DE" sz="1000" dirty="0">
+                      <a:latin typeface="+mj-lt"/>
+                      <a:ea typeface="Cormorant Garamond" pitchFamily="2" charset="0"/>
+                      <a:cs typeface="Cormorant Garamond" pitchFamily="2" charset="0"/>
+                    </a:rPr>
+                    <a:t>****</a:t>
+                  </a:r>
+                </a:p>
+              </p:txBody>
+            </p:sp>
+          </p:grpSp>
+          <p:grpSp>
+            <p:nvGrpSpPr>
+              <p:cNvPr id="37" name="Gruppieren 36">
+                <a:extLst>
+                  <a:ext uri="{FF2B5EF4-FFF2-40B4-BE49-F238E27FC236}">
+                    <a16:creationId xmlns:a16="http://schemas.microsoft.com/office/drawing/2014/main" id="{40A8EA23-B109-136D-9368-BB6AE23A6140}"/>
+                  </a:ext>
+                </a:extLst>
+              </p:cNvPr>
+              <p:cNvGrpSpPr/>
+              <p:nvPr/>
+            </p:nvGrpSpPr>
+            <p:grpSpPr>
+              <a:xfrm>
+                <a:off x="5795963" y="1471537"/>
+                <a:ext cx="2095500" cy="153888"/>
+                <a:chOff x="5795963" y="1471537"/>
+                <a:chExt cx="2095500" cy="153888"/>
+              </a:xfrm>
+            </p:grpSpPr>
+            <p:cxnSp>
+              <p:nvCxnSpPr>
+                <p:cNvPr id="27" name="Gerader Verbinder 26">
                   <a:extLst>
                     <a:ext uri="{FF2B5EF4-FFF2-40B4-BE49-F238E27FC236}">
-                      <a16:creationId xmlns:a16="http://schemas.microsoft.com/office/drawing/2014/main" id="{0C164916-B0E8-1C90-62B6-FEAD759E7EEF}"/>
+                      <a16:creationId xmlns:a16="http://schemas.microsoft.com/office/drawing/2014/main" id="{16B4C276-179F-43B7-247E-E4F362A8E68C}"/>
                     </a:ext>
                   </a:extLst>
                 </p:cNvPr>
-                <p:cNvGrpSpPr/>
+                <p:cNvCxnSpPr/>
                 <p:nvPr/>
-              </p:nvGrpSpPr>
-              <p:grpSpPr>
+              </p:nvCxnSpPr>
+              <p:spPr>
                 <a:xfrm>
-                  <a:off x="7891463" y="1327944"/>
-                  <a:ext cx="2109787" cy="153888"/>
-                  <a:chOff x="7891463" y="1327944"/>
-                  <a:chExt cx="2109787" cy="153888"/>
+                  <a:off x="5795963" y="1567797"/>
+                  <a:ext cx="2095500" cy="0"/>
                 </a:xfrm>
-              </p:grpSpPr>
-              <p:cxnSp>
-                <p:nvCxnSpPr>
-                  <p:cNvPr id="31" name="Gerader Verbinder 30">
-                    <a:extLst>
-                      <a:ext uri="{FF2B5EF4-FFF2-40B4-BE49-F238E27FC236}">
-                        <a16:creationId xmlns:a16="http://schemas.microsoft.com/office/drawing/2014/main" id="{A56BB575-0721-5FCE-8A49-835914027559}"/>
-                      </a:ext>
-                    </a:extLst>
-                  </p:cNvPr>
-                  <p:cNvCxnSpPr>
-                    <a:cxnSpLocks/>
-                  </p:cNvCxnSpPr>
-                  <p:nvPr/>
-                </p:nvCxnSpPr>
-                <p:spPr>
-                  <a:xfrm>
-                    <a:off x="7891463" y="1432903"/>
-                    <a:ext cx="2109787" cy="0"/>
-                  </a:xfrm>
-                  <a:prstGeom prst="line">
-                    <a:avLst/>
-                  </a:prstGeom>
-                  <a:ln w="9525">
-                    <a:solidFill>
-                      <a:schemeClr val="tx1"/>
-                    </a:solidFill>
-                    <a:headEnd type="diamond" w="sm" len="sm"/>
-                    <a:tailEnd type="diamond" w="sm" len="sm"/>
-                  </a:ln>
-                </p:spPr>
-                <p:style>
-                  <a:lnRef idx="2">
-                    <a:schemeClr val="accent1"/>
-                  </a:lnRef>
-                  <a:fillRef idx="0">
-                    <a:schemeClr val="accent1"/>
-                  </a:fillRef>
-                  <a:effectRef idx="1">
-                    <a:schemeClr val="accent1"/>
-                  </a:effectRef>
-                  <a:fontRef idx="minor">
+                <a:prstGeom prst="line">
+                  <a:avLst/>
+                </a:prstGeom>
+                <a:ln w="9525">
+                  <a:solidFill>
                     <a:schemeClr val="tx1"/>
-                  </a:fontRef>
-                </p:style>
-              </p:cxnSp>
-              <p:sp>
-                <p:nvSpPr>
-                  <p:cNvPr id="36" name="Textfeld 35">
-                    <a:extLst>
-                      <a:ext uri="{FF2B5EF4-FFF2-40B4-BE49-F238E27FC236}">
-                        <a16:creationId xmlns:a16="http://schemas.microsoft.com/office/drawing/2014/main" id="{1C59633D-AE3D-345A-EA3E-8EFBA03EDB18}"/>
-                      </a:ext>
-                    </a:extLst>
-                  </p:cNvPr>
-                  <p:cNvSpPr txBox="1"/>
-                  <p:nvPr/>
-                </p:nvSpPr>
-                <p:spPr>
-                  <a:xfrm>
-                    <a:off x="8818116" y="1327944"/>
-                    <a:ext cx="256480" cy="153888"/>
-                  </a:xfrm>
-                  <a:prstGeom prst="rect">
-                    <a:avLst/>
-                  </a:prstGeom>
+                  </a:solidFill>
+                  <a:headEnd type="diamond" w="sm" len="sm"/>
+                  <a:tailEnd type="diamond" w="sm" len="sm"/>
+                </a:ln>
+              </p:spPr>
+              <p:style>
+                <a:lnRef idx="2">
+                  <a:schemeClr val="accent1"/>
+                </a:lnRef>
+                <a:fillRef idx="0">
+                  <a:schemeClr val="accent1"/>
+                </a:fillRef>
+                <a:effectRef idx="1">
+                  <a:schemeClr val="accent1"/>
+                </a:effectRef>
+                <a:fontRef idx="minor">
+                  <a:schemeClr val="tx1"/>
+                </a:fontRef>
+              </p:style>
+            </p:cxnSp>
+            <p:sp>
+              <p:nvSpPr>
+                <p:cNvPr id="35" name="Textfeld 34">
+                  <a:extLst>
+                    <a:ext uri="{FF2B5EF4-FFF2-40B4-BE49-F238E27FC236}">
+                      <a16:creationId xmlns:a16="http://schemas.microsoft.com/office/drawing/2014/main" id="{C218FAF5-7FBA-89F4-D1BB-A0AA365621B1}"/>
+                    </a:ext>
+                  </a:extLst>
+                </p:cNvPr>
+                <p:cNvSpPr txBox="1"/>
+                <p:nvPr/>
+              </p:nvSpPr>
+              <p:spPr>
+                <a:xfrm>
+                  <a:off x="6715473" y="1471537"/>
+                  <a:ext cx="256480" cy="153888"/>
+                </a:xfrm>
+                <a:prstGeom prst="rect">
+                  <a:avLst/>
+                </a:prstGeom>
+                <a:noFill/>
+                <a:ln>
                   <a:noFill/>
-                  <a:ln>
-                    <a:noFill/>
-                  </a:ln>
-                </p:spPr>
-                <p:txBody>
-                  <a:bodyPr wrap="none" lIns="0" tIns="0" rIns="0" bIns="0" rtlCol="0">
-                    <a:spAutoFit/>
-                  </a:bodyPr>
-                  <a:lstStyle/>
-                  <a:p>
-                    <a:r>
-                      <a:rPr lang="de-DE" sz="1000" dirty="0">
-                        <a:latin typeface="+mj-lt"/>
-                        <a:ea typeface="Cormorant Garamond" pitchFamily="2" charset="0"/>
-                        <a:cs typeface="Cormorant Garamond" pitchFamily="2" charset="0"/>
-                      </a:rPr>
-                      <a:t>****</a:t>
-                    </a:r>
-                  </a:p>
-                </p:txBody>
-              </p:sp>
-            </p:grpSp>
+                </a:ln>
+              </p:spPr>
+              <p:txBody>
+                <a:bodyPr wrap="none" lIns="0" tIns="0" rIns="0" bIns="0" rtlCol="0">
+                  <a:spAutoFit/>
+                </a:bodyPr>
+                <a:lstStyle/>
+                <a:p>
+                  <a:r>
+                    <a:rPr lang="de-DE" sz="1000" dirty="0">
+                      <a:latin typeface="+mj-lt"/>
+                      <a:ea typeface="Cormorant Garamond" pitchFamily="2" charset="0"/>
+                      <a:cs typeface="Cormorant Garamond" pitchFamily="2" charset="0"/>
+                    </a:rPr>
+                    <a:t>****</a:t>
+                  </a:r>
+                </a:p>
+              </p:txBody>
+            </p:sp>
+          </p:grpSp>
+          <p:grpSp>
+            <p:nvGrpSpPr>
+              <p:cNvPr id="38" name="Gruppieren 37">
+                <a:extLst>
+                  <a:ext uri="{FF2B5EF4-FFF2-40B4-BE49-F238E27FC236}">
+                    <a16:creationId xmlns:a16="http://schemas.microsoft.com/office/drawing/2014/main" id="{0C164916-B0E8-1C90-62B6-FEAD759E7EEF}"/>
+                  </a:ext>
+                </a:extLst>
+              </p:cNvPr>
+              <p:cNvGrpSpPr/>
+              <p:nvPr/>
+            </p:nvGrpSpPr>
+            <p:grpSpPr>
+              <a:xfrm>
+                <a:off x="7891463" y="1327944"/>
+                <a:ext cx="2109787" cy="153888"/>
+                <a:chOff x="7891463" y="1327944"/>
+                <a:chExt cx="2109787" cy="153888"/>
+              </a:xfrm>
+            </p:grpSpPr>
+            <p:cxnSp>
+              <p:nvCxnSpPr>
+                <p:cNvPr id="31" name="Gerader Verbinder 30">
+                  <a:extLst>
+                    <a:ext uri="{FF2B5EF4-FFF2-40B4-BE49-F238E27FC236}">
+                      <a16:creationId xmlns:a16="http://schemas.microsoft.com/office/drawing/2014/main" id="{A56BB575-0721-5FCE-8A49-835914027559}"/>
+                    </a:ext>
+                  </a:extLst>
+                </p:cNvPr>
+                <p:cNvCxnSpPr>
+                  <a:cxnSpLocks/>
+                </p:cNvCxnSpPr>
+                <p:nvPr/>
+              </p:nvCxnSpPr>
+              <p:spPr>
+                <a:xfrm>
+                  <a:off x="7891463" y="1432903"/>
+                  <a:ext cx="2109787" cy="0"/>
+                </a:xfrm>
+                <a:prstGeom prst="line">
+                  <a:avLst/>
+                </a:prstGeom>
+                <a:ln w="9525">
+                  <a:solidFill>
+                    <a:schemeClr val="tx1"/>
+                  </a:solidFill>
+                  <a:headEnd type="diamond" w="sm" len="sm"/>
+                  <a:tailEnd type="diamond" w="sm" len="sm"/>
+                </a:ln>
+              </p:spPr>
+              <p:style>
+                <a:lnRef idx="2">
+                  <a:schemeClr val="accent1"/>
+                </a:lnRef>
+                <a:fillRef idx="0">
+                  <a:schemeClr val="accent1"/>
+                </a:fillRef>
+                <a:effectRef idx="1">
+                  <a:schemeClr val="accent1"/>
+                </a:effectRef>
+                <a:fontRef idx="minor">
+                  <a:schemeClr val="tx1"/>
+                </a:fontRef>
+              </p:style>
+            </p:cxnSp>
+            <p:sp>
+              <p:nvSpPr>
+                <p:cNvPr id="36" name="Textfeld 35">
+                  <a:extLst>
+                    <a:ext uri="{FF2B5EF4-FFF2-40B4-BE49-F238E27FC236}">
+                      <a16:creationId xmlns:a16="http://schemas.microsoft.com/office/drawing/2014/main" id="{1C59633D-AE3D-345A-EA3E-8EFBA03EDB18}"/>
+                    </a:ext>
+                  </a:extLst>
+                </p:cNvPr>
+                <p:cNvSpPr txBox="1"/>
+                <p:nvPr/>
+              </p:nvSpPr>
+              <p:spPr>
+                <a:xfrm>
+                  <a:off x="8818116" y="1327944"/>
+                  <a:ext cx="256480" cy="153888"/>
+                </a:xfrm>
+                <a:prstGeom prst="rect">
+                  <a:avLst/>
+                </a:prstGeom>
+                <a:noFill/>
+                <a:ln>
+                  <a:noFill/>
+                </a:ln>
+              </p:spPr>
+              <p:txBody>
+                <a:bodyPr wrap="none" lIns="0" tIns="0" rIns="0" bIns="0" rtlCol="0">
+                  <a:spAutoFit/>
+                </a:bodyPr>
+                <a:lstStyle/>
+                <a:p>
+                  <a:r>
+                    <a:rPr lang="de-DE" sz="1000" dirty="0">
+                      <a:latin typeface="+mj-lt"/>
+                      <a:ea typeface="Cormorant Garamond" pitchFamily="2" charset="0"/>
+                      <a:cs typeface="Cormorant Garamond" pitchFamily="2" charset="0"/>
+                    </a:rPr>
+                    <a:t>****</a:t>
+                  </a:r>
+                </a:p>
+              </p:txBody>
+            </p:sp>
           </p:grpSp>
         </p:grpSp>
       </p:grpSp>
@@ -7979,7 +8062,7 @@
         <p:spPr>
           <a:xfrm>
             <a:off x="4195989" y="1141228"/>
-            <a:ext cx="6957786" cy="4058708"/>
+            <a:ext cx="6957785" cy="4058708"/>
           </a:xfrm>
           <a:prstGeom prst="rect">
             <a:avLst/>
@@ -9016,6 +9099,414 @@
   <p:cSld>
     <p:spTree>
       <p:nvGrpSpPr>
+        <p:cNvPr id="1" name="">
+          <a:extLst>
+            <a:ext uri="{FF2B5EF4-FFF2-40B4-BE49-F238E27FC236}">
+              <a16:creationId xmlns:a16="http://schemas.microsoft.com/office/drawing/2014/main" id="{0406C8DC-15EF-F850-DEF6-A9A3F6948B02}"/>
+            </a:ext>
+          </a:extLst>
+        </p:cNvPr>
+        <p:cNvGrpSpPr/>
+        <p:nvPr/>
+      </p:nvGrpSpPr>
+      <p:grpSpPr>
+        <a:xfrm>
+          <a:off x="0" y="0"/>
+          <a:ext cx="0" cy="0"/>
+          <a:chOff x="0" y="0"/>
+          <a:chExt cx="0" cy="0"/>
+        </a:xfrm>
+      </p:grpSpPr>
+      <p:sp>
+        <p:nvSpPr>
+          <p:cNvPr id="6" name="Freihandform: Form 5">
+            <a:extLst>
+              <a:ext uri="{FF2B5EF4-FFF2-40B4-BE49-F238E27FC236}">
+                <a16:creationId xmlns:a16="http://schemas.microsoft.com/office/drawing/2014/main" id="{ABEBB741-0364-004B-2D02-E82F306C82FD}"/>
+              </a:ext>
+            </a:extLst>
+          </p:cNvPr>
+          <p:cNvSpPr/>
+          <p:nvPr/>
+        </p:nvSpPr>
+        <p:spPr>
+          <a:xfrm flipH="1">
+            <a:off x="8657661" y="-2955952"/>
+            <a:ext cx="6300782" cy="3481390"/>
+          </a:xfrm>
+          <a:custGeom>
+            <a:avLst/>
+            <a:gdLst>
+              <a:gd name="csX0" fmla="*/ 0 w 6300782"/>
+              <a:gd name="csY0" fmla="*/ 0 h 3481390"/>
+              <a:gd name="csX1" fmla="*/ 4560087 w 6300782"/>
+              <a:gd name="csY1" fmla="*/ 0 h 3481390"/>
+              <a:gd name="csX2" fmla="*/ 4562473 w 6300782"/>
+              <a:gd name="csY2" fmla="*/ 0 h 3481390"/>
+              <a:gd name="csX3" fmla="*/ 4562473 w 6300782"/>
+              <a:gd name="csY3" fmla="*/ 121 h 3481390"/>
+              <a:gd name="csX4" fmla="*/ 4738063 w 6300782"/>
+              <a:gd name="csY4" fmla="*/ 8987 h 3481390"/>
+              <a:gd name="csX5" fmla="*/ 6300782 w 6300782"/>
+              <a:gd name="csY5" fmla="*/ 1740695 h 3481390"/>
+              <a:gd name="csX6" fmla="*/ 4738063 w 6300782"/>
+              <a:gd name="csY6" fmla="*/ 3472403 h 3481390"/>
+              <a:gd name="csX7" fmla="*/ 4562473 w 6300782"/>
+              <a:gd name="csY7" fmla="*/ 3481270 h 3481390"/>
+              <a:gd name="csX8" fmla="*/ 4562473 w 6300782"/>
+              <a:gd name="csY8" fmla="*/ 3481390 h 3481390"/>
+              <a:gd name="csX9" fmla="*/ 4560087 w 6300782"/>
+              <a:gd name="csY9" fmla="*/ 3481390 h 3481390"/>
+              <a:gd name="csX10" fmla="*/ 0 w 6300782"/>
+              <a:gd name="csY10" fmla="*/ 3481390 h 3481390"/>
+            </a:gdLst>
+            <a:ahLst/>
+            <a:cxnLst>
+              <a:cxn ang="0">
+                <a:pos x="csX0" y="csY0"/>
+              </a:cxn>
+              <a:cxn ang="0">
+                <a:pos x="csX1" y="csY1"/>
+              </a:cxn>
+              <a:cxn ang="0">
+                <a:pos x="csX2" y="csY2"/>
+              </a:cxn>
+              <a:cxn ang="0">
+                <a:pos x="csX3" y="csY3"/>
+              </a:cxn>
+              <a:cxn ang="0">
+                <a:pos x="csX4" y="csY4"/>
+              </a:cxn>
+              <a:cxn ang="0">
+                <a:pos x="csX5" y="csY5"/>
+              </a:cxn>
+              <a:cxn ang="0">
+                <a:pos x="csX6" y="csY6"/>
+              </a:cxn>
+              <a:cxn ang="0">
+                <a:pos x="csX7" y="csY7"/>
+              </a:cxn>
+              <a:cxn ang="0">
+                <a:pos x="csX8" y="csY8"/>
+              </a:cxn>
+              <a:cxn ang="0">
+                <a:pos x="csX9" y="csY9"/>
+              </a:cxn>
+              <a:cxn ang="0">
+                <a:pos x="csX10" y="csY10"/>
+              </a:cxn>
+            </a:cxnLst>
+            <a:rect l="l" t="t" r="r" b="b"/>
+            <a:pathLst>
+              <a:path w="6300782" h="3481390">
+                <a:moveTo>
+                  <a:pt x="0" y="0"/>
+                </a:moveTo>
+                <a:lnTo>
+                  <a:pt x="4560087" y="0"/>
+                </a:lnTo>
+                <a:lnTo>
+                  <a:pt x="4562473" y="0"/>
+                </a:lnTo>
+                <a:lnTo>
+                  <a:pt x="4562473" y="121"/>
+                </a:lnTo>
+                <a:lnTo>
+                  <a:pt x="4738063" y="8987"/>
+                </a:lnTo>
+                <a:cubicBezTo>
+                  <a:pt x="5615819" y="98128"/>
+                  <a:pt x="6300782" y="839421"/>
+                  <a:pt x="6300782" y="1740695"/>
+                </a:cubicBezTo>
+                <a:cubicBezTo>
+                  <a:pt x="6300782" y="2641969"/>
+                  <a:pt x="5615819" y="3383262"/>
+                  <a:pt x="4738063" y="3472403"/>
+                </a:cubicBezTo>
+                <a:lnTo>
+                  <a:pt x="4562473" y="3481270"/>
+                </a:lnTo>
+                <a:lnTo>
+                  <a:pt x="4562473" y="3481390"/>
+                </a:lnTo>
+                <a:lnTo>
+                  <a:pt x="4560087" y="3481390"/>
+                </a:lnTo>
+                <a:lnTo>
+                  <a:pt x="0" y="3481390"/>
+                </a:lnTo>
+                <a:close/>
+              </a:path>
+            </a:pathLst>
+          </a:custGeom>
+          <a:solidFill>
+            <a:srgbClr val="E3E9EA"/>
+          </a:solidFill>
+          <a:ln>
+            <a:noFill/>
+          </a:ln>
+        </p:spPr>
+        <p:style>
+          <a:lnRef idx="2">
+            <a:schemeClr val="accent1">
+              <a:shade val="15000"/>
+            </a:schemeClr>
+          </a:lnRef>
+          <a:fillRef idx="1">
+            <a:schemeClr val="accent1"/>
+          </a:fillRef>
+          <a:effectRef idx="0">
+            <a:schemeClr val="accent1"/>
+          </a:effectRef>
+          <a:fontRef idx="minor">
+            <a:schemeClr val="lt1"/>
+          </a:fontRef>
+        </p:style>
+        <p:txBody>
+          <a:bodyPr lIns="0" tIns="0" rIns="0" bIns="0" rtlCol="0" anchor="ctr"/>
+          <a:lstStyle/>
+          <a:p>
+            <a:pPr algn="ctr"/>
+            <a:endParaRPr lang="de-DE" sz="1600" b="1">
+              <a:solidFill>
+                <a:schemeClr val="tx1"/>
+              </a:solidFill>
+            </a:endParaRPr>
+          </a:p>
+        </p:txBody>
+      </p:sp>
+      <p:sp>
+        <p:nvSpPr>
+          <p:cNvPr id="7" name="Textfeld 6">
+            <a:extLst>
+              <a:ext uri="{FF2B5EF4-FFF2-40B4-BE49-F238E27FC236}">
+                <a16:creationId xmlns:a16="http://schemas.microsoft.com/office/drawing/2014/main" id="{8853670F-8444-2F05-CBDB-F72F6F8198A6}"/>
+              </a:ext>
+            </a:extLst>
+          </p:cNvPr>
+          <p:cNvSpPr txBox="1"/>
+          <p:nvPr/>
+        </p:nvSpPr>
+        <p:spPr>
+          <a:xfrm>
+            <a:off x="10287922" y="17905"/>
+            <a:ext cx="1904078" cy="461665"/>
+          </a:xfrm>
+          <a:prstGeom prst="rect">
+            <a:avLst/>
+          </a:prstGeom>
+          <a:noFill/>
+        </p:spPr>
+        <p:txBody>
+          <a:bodyPr wrap="square" rtlCol="0">
+            <a:spAutoFit/>
+          </a:bodyPr>
+          <a:lstStyle/>
+          <a:p>
+            <a:pPr algn="ctr"/>
+            <a:r>
+              <a:rPr lang="de-DE" sz="2400" dirty="0">
+                <a:solidFill>
+                  <a:srgbClr val="00336E"/>
+                </a:solidFill>
+                <a:ea typeface="Cormorant Garamond" pitchFamily="2" charset="0"/>
+                <a:cs typeface="Cormorant Garamond" pitchFamily="2" charset="0"/>
+              </a:rPr>
+              <a:t>First </a:t>
+            </a:r>
+            <a:r>
+              <a:rPr lang="de-DE" sz="2400" dirty="0" err="1">
+                <a:solidFill>
+                  <a:srgbClr val="00336E"/>
+                </a:solidFill>
+                <a:ea typeface="Cormorant Garamond" pitchFamily="2" charset="0"/>
+                <a:cs typeface="Cormorant Garamond" pitchFamily="2" charset="0"/>
+              </a:rPr>
+              <a:t>results</a:t>
+            </a:r>
+            <a:endParaRPr lang="de-DE" sz="2400" b="1" dirty="0">
+              <a:solidFill>
+                <a:srgbClr val="00336E"/>
+              </a:solidFill>
+              <a:ea typeface="Cormorant Garamond" pitchFamily="2" charset="0"/>
+              <a:cs typeface="Cormorant Garamond" pitchFamily="2" charset="0"/>
+            </a:endParaRPr>
+          </a:p>
+        </p:txBody>
+      </p:sp>
+      <p:sp>
+        <p:nvSpPr>
+          <p:cNvPr id="9" name="Ellipse 8">
+            <a:extLst>
+              <a:ext uri="{FF2B5EF4-FFF2-40B4-BE49-F238E27FC236}">
+                <a16:creationId xmlns:a16="http://schemas.microsoft.com/office/drawing/2014/main" id="{0C73F85F-C108-F261-F028-8C58D068EDEA}"/>
+              </a:ext>
+            </a:extLst>
+          </p:cNvPr>
+          <p:cNvSpPr/>
+          <p:nvPr/>
+        </p:nvSpPr>
+        <p:spPr>
+          <a:xfrm>
+            <a:off x="10012084" y="66307"/>
+            <a:ext cx="340233" cy="340233"/>
+          </a:xfrm>
+          <a:prstGeom prst="ellipse">
+            <a:avLst/>
+          </a:prstGeom>
+          <a:solidFill>
+            <a:srgbClr val="E3E9EA"/>
+          </a:solidFill>
+          <a:ln>
+            <a:solidFill>
+              <a:srgbClr val="00336E"/>
+            </a:solidFill>
+          </a:ln>
+        </p:spPr>
+        <p:style>
+          <a:lnRef idx="2">
+            <a:schemeClr val="accent1">
+              <a:shade val="15000"/>
+            </a:schemeClr>
+          </a:lnRef>
+          <a:fillRef idx="1">
+            <a:schemeClr val="accent1"/>
+          </a:fillRef>
+          <a:effectRef idx="0">
+            <a:schemeClr val="accent1"/>
+          </a:effectRef>
+          <a:fontRef idx="minor">
+            <a:schemeClr val="lt1"/>
+          </a:fontRef>
+        </p:style>
+        <p:txBody>
+          <a:bodyPr lIns="0" tIns="0" rIns="0" bIns="0" rtlCol="0" anchor="ctr"/>
+          <a:lstStyle/>
+          <a:p>
+            <a:pPr algn="ctr"/>
+            <a:r>
+              <a:rPr lang="de-DE" b="1" dirty="0">
+                <a:solidFill>
+                  <a:schemeClr val="tx1"/>
+                </a:solidFill>
+              </a:rPr>
+              <a:t>1</a:t>
+            </a:r>
+            <a:endParaRPr lang="de-DE" sz="900" b="1" dirty="0">
+              <a:solidFill>
+                <a:schemeClr val="tx1"/>
+              </a:solidFill>
+            </a:endParaRPr>
+          </a:p>
+        </p:txBody>
+      </p:sp>
+      <p:sp>
+        <p:nvSpPr>
+          <p:cNvPr id="2" name="Textfeld 1">
+            <a:extLst>
+              <a:ext uri="{FF2B5EF4-FFF2-40B4-BE49-F238E27FC236}">
+                <a16:creationId xmlns:a16="http://schemas.microsoft.com/office/drawing/2014/main" id="{39C1E9E8-8660-D120-53F2-7E4406178B30}"/>
+              </a:ext>
+            </a:extLst>
+          </p:cNvPr>
+          <p:cNvSpPr txBox="1"/>
+          <p:nvPr/>
+        </p:nvSpPr>
+        <p:spPr>
+          <a:xfrm>
+            <a:off x="2665712" y="1539240"/>
+            <a:ext cx="6860576" cy="1045414"/>
+          </a:xfrm>
+          <a:prstGeom prst="rect">
+            <a:avLst/>
+          </a:prstGeom>
+          <a:noFill/>
+        </p:spPr>
+        <p:txBody>
+          <a:bodyPr wrap="square">
+            <a:spAutoFit/>
+          </a:bodyPr>
+          <a:lstStyle/>
+          <a:p>
+            <a:pPr>
+              <a:lnSpc>
+                <a:spcPct val="115000"/>
+              </a:lnSpc>
+              <a:spcAft>
+                <a:spcPts val="1000"/>
+              </a:spcAft>
+              <a:buNone/>
+            </a:pPr>
+            <a:r>
+              <a:rPr lang="en-US" sz="2800" b="1" dirty="0">
+                <a:ea typeface="MS Mincho" panose="02020609040205080304" pitchFamily="49" charset="-128"/>
+                <a:cs typeface="Times New Roman" panose="02020603050405020304" pitchFamily="18" charset="0"/>
+              </a:rPr>
+              <a:t>Milestone</a:t>
+            </a:r>
+            <a:r>
+              <a:rPr lang="en-US" sz="2800" dirty="0">
+                <a:ea typeface="MS Mincho" panose="02020609040205080304" pitchFamily="49" charset="-128"/>
+                <a:cs typeface="Times New Roman" panose="02020603050405020304" pitchFamily="18" charset="0"/>
+              </a:rPr>
+              <a:t>: Evolutionary algorithm finds successful solutions to static tasks. </a:t>
+            </a:r>
+            <a:endParaRPr lang="de-DE" sz="2800" b="1" dirty="0">
+              <a:ea typeface="MS Mincho" panose="02020609040205080304" pitchFamily="49" charset="-128"/>
+              <a:cs typeface="Times New Roman" panose="02020603050405020304" pitchFamily="18" charset="0"/>
+            </a:endParaRPr>
+          </a:p>
+        </p:txBody>
+      </p:sp>
+    </p:spTree>
+    <p:extLst>
+      <p:ext uri="{BB962C8B-B14F-4D97-AF65-F5344CB8AC3E}">
+        <p14:creationId xmlns:p14="http://schemas.microsoft.com/office/powerpoint/2010/main" val="553160395"/>
+      </p:ext>
+    </p:extLst>
+  </p:cSld>
+  <p:clrMapOvr>
+    <a:masterClrMapping/>
+  </p:clrMapOvr>
+</p:sld>
+</file>
+
+<file path=ppt/slides/slide21.xml><?xml version="1.0" encoding="utf-8"?>
+<p:sld xmlns:a="http://schemas.openxmlformats.org/drawingml/2006/main" xmlns:r="http://schemas.openxmlformats.org/officeDocument/2006/relationships" xmlns:p="http://schemas.openxmlformats.org/presentationml/2006/main">
+  <p:cSld>
+    <p:spTree>
+      <p:nvGrpSpPr>
+        <p:cNvPr id="1" name=""/>
+        <p:cNvGrpSpPr/>
+        <p:nvPr/>
+      </p:nvGrpSpPr>
+      <p:grpSpPr>
+        <a:xfrm>
+          <a:off x="0" y="0"/>
+          <a:ext cx="0" cy="0"/>
+          <a:chOff x="0" y="0"/>
+          <a:chExt cx="0" cy="0"/>
+        </a:xfrm>
+      </p:grpSpPr>
+    </p:spTree>
+    <p:extLst>
+      <p:ext uri="{BB962C8B-B14F-4D97-AF65-F5344CB8AC3E}">
+        <p14:creationId xmlns:p14="http://schemas.microsoft.com/office/powerpoint/2010/main" val="3176741396"/>
+      </p:ext>
+    </p:extLst>
+  </p:cSld>
+  <p:clrMapOvr>
+    <a:masterClrMapping/>
+  </p:clrMapOvr>
+</p:sld>
+</file>
+
+<file path=ppt/slides/slide22.xml><?xml version="1.0" encoding="utf-8"?>
+<p:sld xmlns:a="http://schemas.openxmlformats.org/drawingml/2006/main" xmlns:r="http://schemas.openxmlformats.org/officeDocument/2006/relationships" xmlns:p="http://schemas.openxmlformats.org/presentationml/2006/main">
+  <p:cSld>
+    <p:spTree>
+      <p:nvGrpSpPr>
         <p:cNvPr id="1" name=""/>
         <p:cNvGrpSpPr/>
         <p:nvPr/>
@@ -9524,7 +10015,7 @@
           <a:p>
             <a:fld id="{001D04CD-A18E-4C48-A0D4-2F175BEDACF1}" type="slidenum">
               <a:rPr lang="de-DE" smtClean="0"/>
-              <a:t>20</a:t>
+              <a:t>22</a:t>
             </a:fld>
             <a:endParaRPr lang="de-DE"/>
           </a:p>

</xml_diff>